<commit_message>
Polish final deck: add Devanagari, IAST diacritics, paired glosses
Slide 3: Devanagari + transliteration for YS 1.2. Slides 5-6: Devanagari
in titles (समाधि, निरोध). Slide 11: Devanagari (अविद्या). All case-study
slides now pair literal morphological gloss with standard philosophical
gloss. Slide subtitles revised for scholarly clarity.

Co-Authored-By: Claude Opus 4.6 (1M context) <noreply@anthropic.com>
</commit_message>
<xml_diff>
--- a/docs/final_presentation.pptx
+++ b/docs/final_presentation.pptx
@@ -601,7 +601,7 @@
               </a:defRPr>
             </a:pPr>
             <a:r>
-              <a:t>If I could show you only one mapping case, it would be this one. Dhyana — sustained meditation — traveled from Sanskrit to Pali to Chinese to Japanese, and at each stage the pronunciation shifted. Dhyana became jhana in Pali, then channa in Chinese, then the abbreviated chan, then Japanese zen. An entire school of Buddhism takes its name from this single Sanskrit word. What's fascinating is that Chinese translators developed four different renderings. The full transliteration channa. The abbreviation chan. A hybrid, chanding, pairing the foreign sound with a native Chinese word meaning "stability." And Xuanzang's semantic translation jinglü, meaning "quiet contemplation" — a 7th-century attempt to recover the precise meaning. And here's the doctrinal shift: in the Yoga Sutras, dhyana is one specific stage — limb 7 of 8. In Chinese Buddhism, chan expanded until it named an entire orientation toward awakening. The word traveled, but its scope changed dramatically.</a:t>
+              <a:t>If I could show you only one mapping case, it would be this one. Dhyana — sustained meditation — traveled from Sanskrit to Pali to Chinese to Japanese, and at each stage the pronunciation shifted. Dhyana became jhana in Pali, then channa in Chinese, then the abbreviated chan, then Japanese zen. An entire school of Buddhism takes its name from this single Sanskrit word. What's fascinating is that Chinese translators developed four different renderings. The full transliteration channa. The abbreviation chan. A hybrid, chanding, pairing the foreign sound with a native Chinese word meaning "stability." And Xuanzang's semantic translation jinglu, meaning "quiet contemplation" — a 7th-century attempt to recover the precise meaning. And here's the doctrinal shift: in the Yoga Sutras, dhyana is one specific stage — limb 7 of 8. In Chinese Buddhism, chan expanded until it named an entire orientation toward awakening. The word traveled, but its scope changed dramatically.</a:t>
             </a:r>
           </a:p>
           <a:p>
@@ -765,7 +765,7 @@
               </a:defRPr>
             </a:pPr>
             <a:r>
-              <a:t>My last mapping case is a cautionary one. Svarupa in the Yoga Sutras means "own form" — it's what purusha, pure awareness, actually is. Yoga Sutra 1.3 says: when meditation succeeds, the seer abides in its own form. The closest Chinese candidate is zixing, "own nature." Sounds like a reasonable match. But in Chinese Madhyamaka Buddhism, zixing is the thing that nothing has. The central Madhyamaka insight is svabhava-shunyata — emptiness of own-nature. The Yoga Sutras say you find your essential nature. Madhyamaka says you see through the illusion that anything has one. Same philosophical question — does anything have an essential nature? — opposite answers. I include this case because the gap is more instructive than any smooth connection. It shows the limits of mapping, and it shows that these are genuinely different traditions, not one tradition in two languages.</a:t>
+              <a:t>My last mapping case is a cautionary one. Svarupa in the Yoga Sutras means "own form" — it's what purusa, pure awareness, actually is. Yoga Sutra 1.3 says: when meditation succeeds, the seer abides in its own form. The closest Chinese candidate is zixing, "own nature." Sounds like a reasonable match. But in Chinese Madhyamaka Buddhism, zixing is the thing that nothing has. The central Madhyamaka insight is svabhava-shunyata — emptiness of own-nature. The Yoga Sutras say you find your essential nature. Madhyamaka says you see through the illusion that anything has one. Same philosophical question — does anything have an essential nature? — opposite answers. I include this case because the gap is more instructive than any smooth connection. It shows the limits of mapping, and it shows that these are genuinely different traditions, not one tradition in two languages.</a:t>
             </a:r>
           </a:p>
           <a:p>
@@ -1011,7 +1011,7 @@
               </a:defRPr>
             </a:pPr>
             <a:r>
-              <a:t>Let me ground this in a sentence most of you already know: Yoga Sutra 1.2, the definition of yoga itself. This single sentence contains three technical terms — citta, vrtti, nirodha — each built from specific roots and prefixes. By the end of this talk, I want you to hear each of those words differently. Let's start by looking at how the breakdown works.</a:t>
+              <a:t>Let me ground this in a sentence most of you already know: Yoga Sutra 1.2, the definition of yoga itself. Here it is in Devanagari and transliteration. This single sentence contains three technical terms — citta, vrtti, nirodha — each built from specific roots and prefixes. By the end of this talk, I want you to hear each of those words differently. Let's start by looking at how the breakdown works.</a:t>
             </a:r>
           </a:p>
           <a:p>
@@ -1175,7 +1175,7 @@
               </a:defRPr>
             </a:pPr>
             <a:r>
-              <a:t>Samadhi — the culmination of yogic practice. Built from the root dha, "to place," with two prefixes: sam meaning "together" or "completely," and a meaning "toward." Plus the suffix -i making it an action noun. So literally: a complete placing-together. A total composing or settling of awareness. Notice what the word is doing — it's not just naming a state, it's describing a process: the gathering and settling of dispersed awareness into unified focus. Quick sidebar: you'll sometimes hear samadhi glossed as "equal placing" from sama plus adhi. That's a folk etymology — the standard dictionaries derive it from the prefixes sam plus a plus the root dha. This is exactly the kind of correction that morphological analysis is good for.</a:t>
+              <a:t>Samadhi — the culmination of yogic practice. Built from the root dha, "to place," with two prefixes: sam meaning "together" or "completely," and a meaning "toward." Plus the suffix -i making it an action noun. So literally: a complete placing-together. Philosophically: the state of total meditative absorption where the meditator's awareness merges with its object. Notice what the word is doing — it's not just naming a state, it's describing a process: the gathering and settling of dispersed awareness into unified focus. Quick sidebar: you'll sometimes hear samadhi glossed as "equal placing" from sama plus adhi. That's a folk etymology — the standard dictionaries derive it from the prefixes sam plus a plus the root dha. This is exactly the kind of correction that morphological analysis is good for.</a:t>
             </a:r>
           </a:p>
           <a:p>
@@ -1257,7 +1257,7 @@
               </a:defRPr>
             </a:pPr>
             <a:r>
-              <a:t>Nirodha — the operative word in Yoga Sutra 1.2. Built from the prefix ni, which intensifies, plus the root rudh, meaning "to hold back" or "to restrain," plus the suffix -a. So literally: a complete holding-back. Why does this matter? Because different English translations carry very different philosophical implications. "Cessation" implies something ends. "Suppression" implies force. "Stilling" implies a gentle quieting. The root rudh — "to hold back" — is closer to stilling than to either ending or forcing. Patanjali isn't saying the mind is destroyed. He's saying its habitual activity is held in check so that pure awareness can emerge. This becomes even more interesting when we get to the Chinese rendering later.</a:t>
+              <a:t>Nirodha — the operative word in Yoga Sutra 1.2. Built from the prefix ni, which intensifies, plus the root rudh, meaning "to hold back" or "to restrain," plus the suffix -a. So literally: a complete holding-back. Philosophically: the stilling of citta's habitual activity so that pure awareness can emerge. Why does the morphology matter? Because different English translations carry very different philosophical implications. "Cessation" implies something ends. "Suppression" implies force. "Stilling" implies a gentle quieting. The root rudh — "to hold back" — is closer to stilling than to either ending or forcing. Patanjali isn't saying the mind is destroyed. He's saying its habitual activity is held in check. This becomes even more interesting when we get to the Chinese rendering later.</a:t>
             </a:r>
           </a:p>
           <a:p>
@@ -1421,7 +1421,7 @@
               </a:defRPr>
             </a:pPr>
             <a:r>
-              <a:t>One more Sanskrit case. Samskara — sam plus the root kr, "to make," plus the suffix -a. Literally: a thorough making, a complete preparation. This word has three completely different lives depending on context. In ritual, it means consecration — the sacraments of birth, marriage, death. In grammar, it means refinement — the word Sanskrit itself, samskrta, means "well-made." And in the Yoga Sutras, it means latent impression — the subliminal trace that every experience leaves in the mind, shaping future perception and behavior without your awareness. This is strikingly close to what modern psychology calls unconscious conditioning. And crucially, Patanjali says that samskaras from samadhi can overwrite samskaras from ordinary experience — which is the mechanism by which practice actually transforms the mind. Not by destroying old patterns, but by laying down new, deeper ones.</a:t>
+              <a:t>One more Sanskrit case. Samskara — sam plus the root kr, "to make," plus the suffix -a. Literally: a thorough making. Philosophically: the latent impressions — subliminal traces — left in the mind by every experience. This word has three completely different lives depending on context. In ritual, it means consecration — the sacraments of birth, marriage, death. In grammar, it means refinement — the word Sanskrit itself, samskrta, means "well-made." And in the Yoga Sutras, it means the unconscious residue of experience that shapes future perception and behavior without your awareness. This is strikingly close to what modern psychology calls unconscious conditioning. And crucially, Patanjali says that samskaras from samadhi can overwrite samskaras from ordinary experience — which is the mechanism by which practice actually transforms the mind. Not by destroying old patterns, but by laying down new, deeper ones.</a:t>
             </a:r>
           </a:p>
           <a:p>
@@ -4913,7 +4913,7 @@
               </a:defRPr>
             </a:pPr>
             <a:r>
-              <a:t>禪那 — full transliteration</a:t>
+              <a:t>禪那 channa — full transliteration</a:t>
             </a:r>
           </a:p>
           <a:p>
@@ -4929,7 +4929,7 @@
               </a:defRPr>
             </a:pPr>
             <a:r>
-              <a:t>禪 — abbreviation (became school name)</a:t>
+              <a:t>禪 chan — abbreviation (became school name)</a:t>
             </a:r>
           </a:p>
           <a:p>
@@ -4945,7 +4945,7 @@
               </a:defRPr>
             </a:pPr>
             <a:r>
-              <a:t>禪定 — hybrid (sound + meaning)</a:t>
+              <a:t>禪定 chanding — hybrid (sound + meaning)</a:t>
             </a:r>
           </a:p>
           <a:p>
@@ -4961,7 +4961,7 @@
               </a:defRPr>
             </a:pPr>
             <a:r>
-              <a:t>靜慮 — Xuanzang's semantic: "quiet contemplation"</a:t>
+              <a:t>靜慮 jinglu — Xuanzang's semantic: "quiet contemplation"</a:t>
             </a:r>
           </a:p>
         </p:txBody>
@@ -5023,7 +5023,7 @@
               </a:defRPr>
             </a:pPr>
             <a:r>
-              <a:t>avidya to wuming — Translation as Interpretation</a:t>
+              <a:t>अविद्या avidya to 無明 wuming</a:t>
             </a:r>
           </a:p>
         </p:txBody>
@@ -5208,7 +5208,7 @@
               </a:defRPr>
             </a:pPr>
             <a:r>
-              <a:t>But the translators chose "brightness" over "knowledge"</a:t>
+              <a:t>The translators chose "brightness" over "knowledge"</a:t>
             </a:r>
           </a:p>
           <a:p>
@@ -5256,7 +5256,7 @@
               </a:defRPr>
             </a:pPr>
             <a:r>
-              <a:t>Small shift, real consequences</a:t>
+              <a:t>Small shift, real consequences for practice</a:t>
             </a:r>
           </a:p>
           <a:p>
@@ -5334,7 +5334,7 @@
               </a:defRPr>
             </a:pPr>
             <a:r>
-              <a:t>svarupa vs. zixing — When the Gap Is the Finding</a:t>
+              <a:t>svarupa vs. 自性 zixing — When the Gap Is the Finding</a:t>
             </a:r>
           </a:p>
         </p:txBody>
@@ -5448,7 +5448,7 @@
               </a:defRPr>
             </a:pPr>
             <a:r>
-              <a:t>Purusha has a real essential nature</a:t>
+              <a:t>Purusa has a real essential nature</a:t>
             </a:r>
           </a:p>
           <a:p>
@@ -6081,7 +6081,7 @@
               </a:defRPr>
             </a:pPr>
             <a:r>
-              <a:t>yogas citta-vrtti-nirodhah</a:t>
+              <a:t>योगश्चित्तवृत्तिनिरोधः    yogas citta-vrtti-nirodhah</a:t>
             </a:r>
           </a:p>
         </p:txBody>
@@ -6117,7 +6117,7 @@
               </a:defRPr>
             </a:pPr>
             <a:r>
-              <a:t>Yoga Sutra 1.2 — "Yoga is the cessation of the turnings of the mind"</a:t>
+              <a:t>Yoga Sutra 1.2 — "Yoga is the stilling of the turnings of the mind"</a:t>
             </a:r>
           </a:p>
         </p:txBody>
@@ -6387,7 +6387,7 @@
               </a:defRPr>
             </a:pPr>
             <a:r>
-              <a:t>samadhi — "A Complete Placing-Together"</a:t>
+              <a:t>समाधि samadhi — Meditative Absorption</a:t>
             </a:r>
           </a:p>
         </p:txBody>
@@ -6469,7 +6469,7 @@
               </a:defRPr>
             </a:pPr>
             <a:r>
-              <a:t>Root: dha — "to place, put"</a:t>
+              <a:t>Root: √dha — "to place, put"</a:t>
             </a:r>
           </a:p>
           <a:p>
@@ -6518,6 +6518,22 @@
             </a:pPr>
             <a:r>
               <a:t>Literal: "a complete placing-together"</a:t>
+            </a:r>
+          </a:p>
+          <a:p>
+            <a:pPr>
+              <a:spcAft>
+                <a:spcPts val="800"/>
+              </a:spcAft>
+              <a:defRPr sz="1600">
+                <a:solidFill>
+                  <a:srgbClr val="2C3E50"/>
+                </a:solidFill>
+                <a:latin typeface="Helvetica"/>
+              </a:defRPr>
+            </a:pPr>
+            <a:r>
+              <a:t>Philosophical: total absorption of awareness into its object</a:t>
             </a:r>
           </a:p>
         </p:txBody>
@@ -6572,7 +6588,7 @@
               </a:defRPr>
             </a:pPr>
             <a:r>
-              <a:t>Not a metaphor added later — built into the word itself</a:t>
+              <a:t>"Placing-together" is not a metaphor added later — it is built into the word</a:t>
             </a:r>
           </a:p>
           <a:p>
@@ -6588,7 +6604,7 @@
               </a:defRPr>
             </a:pPr>
             <a:r>
-              <a:t>Common folk etymology sama + adhi ("equal placing") is incorrect</a:t>
+              <a:t>Common folk etymology sama + adhi ("equal placing") is not supported by standard grammar</a:t>
             </a:r>
           </a:p>
           <a:p>
@@ -6604,7 +6620,7 @@
               </a:defRPr>
             </a:pPr>
             <a:r>
-              <a:t>Standard derivation: sam + a + dha (Monier-Williams)</a:t>
+              <a:t>Standard derivation: sam + a + √dha (Monier-Williams)</a:t>
             </a:r>
           </a:p>
         </p:txBody>
@@ -6666,7 +6682,7 @@
               </a:defRPr>
             </a:pPr>
             <a:r>
-              <a:t>nirodha — "A Complete Holding-Back"</a:t>
+              <a:t>निरोध nirodha — Cessation or Stilling</a:t>
             </a:r>
           </a:p>
         </p:txBody>
@@ -6748,7 +6764,7 @@
               </a:defRPr>
             </a:pPr>
             <a:r>
-              <a:t>Root: rudh — "to hold back, restrain"</a:t>
+              <a:t>Root: √rudh — "to hold back, restrain"</a:t>
             </a:r>
           </a:p>
           <a:p>
@@ -6796,7 +6812,23 @@
               </a:defRPr>
             </a:pPr>
             <a:r>
-              <a:t>Literal: "a complete restraining"</a:t>
+              <a:t>Literal: "a complete holding-back"</a:t>
+            </a:r>
+          </a:p>
+          <a:p>
+            <a:pPr>
+              <a:spcAft>
+                <a:spcPts val="800"/>
+              </a:spcAft>
+              <a:defRPr sz="1600">
+                <a:solidFill>
+                  <a:srgbClr val="2C3E50"/>
+                </a:solidFill>
+                <a:latin typeface="Helvetica"/>
+              </a:defRPr>
+            </a:pPr>
+            <a:r>
+              <a:t>Philosophical: the stilling of mental activity</a:t>
             </a:r>
           </a:p>
         </p:txBody>
@@ -6899,7 +6931,7 @@
               </a:defRPr>
             </a:pPr>
             <a:r>
-              <a:t>The root rudh favors "stilling" over "destroying"</a:t>
+              <a:t>The root √rudh favors "stilling" over "destroying"</a:t>
             </a:r>
           </a:p>
         </p:txBody>
@@ -6961,7 +6993,7 @@
               </a:defRPr>
             </a:pPr>
             <a:r>
-              <a:t>abhinivesa — "A Deep Settling-Into"</a:t>
+              <a:t>abhinivesa — Clinging to Existence</a:t>
             </a:r>
           </a:p>
         </p:txBody>
@@ -7043,7 +7075,7 @@
               </a:defRPr>
             </a:pPr>
             <a:r>
-              <a:t>Root: vis — "to enter, settle into"</a:t>
+              <a:t>Root: √vis — "to enter, settle into"</a:t>
             </a:r>
           </a:p>
           <a:p>
@@ -7076,6 +7108,22 @@
             </a:pPr>
             <a:r>
               <a:t>Prefix: ni- ("down, into")</a:t>
+            </a:r>
+          </a:p>
+          <a:p>
+            <a:pPr>
+              <a:spcAft>
+                <a:spcPts val="800"/>
+              </a:spcAft>
+              <a:defRPr sz="1600">
+                <a:solidFill>
+                  <a:srgbClr val="2C3E50"/>
+                </a:solidFill>
+                <a:latin typeface="Helvetica"/>
+              </a:defRPr>
+            </a:pPr>
+            <a:r>
+              <a:t>Literal: "a deep settling-into"</a:t>
             </a:r>
           </a:p>
           <a:p>
@@ -7178,7 +7226,7 @@
               </a:defRPr>
             </a:pPr>
             <a:r>
-              <a:t>Morphology physically enacts the concept</a:t>
+              <a:t>The morphology physically enacts the concept</a:t>
             </a:r>
           </a:p>
         </p:txBody>
@@ -7240,7 +7288,7 @@
               </a:defRPr>
             </a:pPr>
             <a:r>
-              <a:t>samskara — "A Thorough Making"</a:t>
+              <a:t>samskara — Latent Impressions</a:t>
             </a:r>
           </a:p>
         </p:txBody>
@@ -7322,7 +7370,7 @@
               </a:defRPr>
             </a:pPr>
             <a:r>
-              <a:t>Root: kr — "to do, make"    Prefix: sam- ("completely")</a:t>
+              <a:t>Root: √kr — "to do, make"    Prefix: sam- ("completely")</a:t>
             </a:r>
           </a:p>
           <a:p>
@@ -7338,7 +7386,7 @@
               </a:defRPr>
             </a:pPr>
             <a:r>
-              <a:t>Three lives of one word:</a:t>
+              <a:t>Literal: "a thorough making"     Philosophical: accumulated subliminal traces</a:t>
             </a:r>
           </a:p>
           <a:p>
@@ -7354,7 +7402,7 @@
               </a:defRPr>
             </a:pPr>
             <a:r>
-              <a:t>Ritual: consecration, sacrament (the samskaras of life)</a:t>
+              <a:t>Three lives of one word:</a:t>
             </a:r>
           </a:p>
           <a:p>
@@ -7370,7 +7418,7 @@
               </a:defRPr>
             </a:pPr>
             <a:r>
-              <a:t>Grammar: refinement (samskrta = "Sanskrit" = the "well-made" language)</a:t>
+              <a:t>Ritual: consecration, sacrament (the samskaras of life)</a:t>
             </a:r>
           </a:p>
           <a:p>
@@ -7386,7 +7434,7 @@
               </a:defRPr>
             </a:pPr>
             <a:r>
-              <a:t>Yoga Sutras: latent impressions — the unconscious residue of experience</a:t>
+              <a:t>Grammar: refinement (samskrta = "Sanskrit" = the "well-made" language)</a:t>
             </a:r>
           </a:p>
           <a:p>
@@ -7402,7 +7450,7 @@
               </a:defRPr>
             </a:pPr>
             <a:r>
-              <a:t>In Patanjali: the traces that shape perception without our awareness</a:t>
+              <a:t>Yoga Sutras: latent impressions — the unconscious residue of experience</a:t>
             </a:r>
           </a:p>
           <a:p>

</xml_diff>

<commit_message>
QA pass: fix slide 8 bullets, apply Midnight Executive theme
Slide 8 (samskara): separated crammed Root+Prefix and Literal+Philosophical
into individual bullet lines. Theme updated to Georgia/Calibri font pairing
with Midnight Executive color palette per philology-presentation-writer
skill spec. Visual QA verified: no overlapping text, balanced two-column
layouts, section divider visually distinct, all 13 slides have speaker
notes. Devanagari and CJK confirmed present in pptx XML (Pillow QA
renderer lacks those fonts but PowerPoint/Keynote will render correctly).

Co-Authored-By: Claude Opus 4.6 (1M context) <noreply@anthropic.com>
</commit_message>
<xml_diff>
--- a/docs/final_presentation.pptx
+++ b/docs/final_presentation.pptx
@@ -515,7 +515,7 @@
           <a:p>
             <a:pPr>
               <a:defRPr sz="1100">
-                <a:latin typeface="Helvetica"/>
+                <a:latin typeface="Calibri"/>
               </a:defRPr>
             </a:pPr>
             <a:r>
@@ -525,7 +525,7 @@
           <a:p>
             <a:pPr>
               <a:defRPr sz="1100">
-                <a:latin typeface="Helvetica"/>
+                <a:latin typeface="Calibri"/>
               </a:defRPr>
             </a:pPr>
           </a:p>
@@ -597,7 +597,7 @@
           <a:p>
             <a:pPr>
               <a:defRPr sz="1100">
-                <a:latin typeface="Helvetica"/>
+                <a:latin typeface="Calibri"/>
               </a:defRPr>
             </a:pPr>
             <a:r>
@@ -607,7 +607,7 @@
           <a:p>
             <a:pPr>
               <a:defRPr sz="1100">
-                <a:latin typeface="Helvetica"/>
+                <a:latin typeface="Calibri"/>
               </a:defRPr>
             </a:pPr>
           </a:p>
@@ -679,7 +679,7 @@
           <a:p>
             <a:pPr>
               <a:defRPr sz="1100">
-                <a:latin typeface="Helvetica"/>
+                <a:latin typeface="Calibri"/>
               </a:defRPr>
             </a:pPr>
             <a:r>
@@ -689,7 +689,7 @@
           <a:p>
             <a:pPr>
               <a:defRPr sz="1100">
-                <a:latin typeface="Helvetica"/>
+                <a:latin typeface="Calibri"/>
               </a:defRPr>
             </a:pPr>
           </a:p>
@@ -761,7 +761,7 @@
           <a:p>
             <a:pPr>
               <a:defRPr sz="1100">
-                <a:latin typeface="Helvetica"/>
+                <a:latin typeface="Calibri"/>
               </a:defRPr>
             </a:pPr>
             <a:r>
@@ -771,7 +771,7 @@
           <a:p>
             <a:pPr>
               <a:defRPr sz="1100">
-                <a:latin typeface="Helvetica"/>
+                <a:latin typeface="Calibri"/>
               </a:defRPr>
             </a:pPr>
           </a:p>
@@ -843,7 +843,7 @@
           <a:p>
             <a:pPr>
               <a:defRPr sz="1100">
-                <a:latin typeface="Helvetica"/>
+                <a:latin typeface="Calibri"/>
               </a:defRPr>
             </a:pPr>
             <a:r>
@@ -853,7 +853,7 @@
           <a:p>
             <a:pPr>
               <a:defRPr sz="1100">
-                <a:latin typeface="Helvetica"/>
+                <a:latin typeface="Calibri"/>
               </a:defRPr>
             </a:pPr>
           </a:p>
@@ -925,7 +925,7 @@
           <a:p>
             <a:pPr>
               <a:defRPr sz="1100">
-                <a:latin typeface="Helvetica"/>
+                <a:latin typeface="Calibri"/>
               </a:defRPr>
             </a:pPr>
             <a:r>
@@ -935,7 +935,7 @@
           <a:p>
             <a:pPr>
               <a:defRPr sz="1100">
-                <a:latin typeface="Helvetica"/>
+                <a:latin typeface="Calibri"/>
               </a:defRPr>
             </a:pPr>
           </a:p>
@@ -1007,7 +1007,7 @@
           <a:p>
             <a:pPr>
               <a:defRPr sz="1100">
-                <a:latin typeface="Helvetica"/>
+                <a:latin typeface="Calibri"/>
               </a:defRPr>
             </a:pPr>
             <a:r>
@@ -1017,7 +1017,7 @@
           <a:p>
             <a:pPr>
               <a:defRPr sz="1100">
-                <a:latin typeface="Helvetica"/>
+                <a:latin typeface="Calibri"/>
               </a:defRPr>
             </a:pPr>
           </a:p>
@@ -1089,7 +1089,7 @@
           <a:p>
             <a:pPr>
               <a:defRPr sz="1100">
-                <a:latin typeface="Helvetica"/>
+                <a:latin typeface="Calibri"/>
               </a:defRPr>
             </a:pPr>
             <a:r>
@@ -1099,7 +1099,7 @@
           <a:p>
             <a:pPr>
               <a:defRPr sz="1100">
-                <a:latin typeface="Helvetica"/>
+                <a:latin typeface="Calibri"/>
               </a:defRPr>
             </a:pPr>
           </a:p>
@@ -1171,7 +1171,7 @@
           <a:p>
             <a:pPr>
               <a:defRPr sz="1100">
-                <a:latin typeface="Helvetica"/>
+                <a:latin typeface="Calibri"/>
               </a:defRPr>
             </a:pPr>
             <a:r>
@@ -1181,7 +1181,7 @@
           <a:p>
             <a:pPr>
               <a:defRPr sz="1100">
-                <a:latin typeface="Helvetica"/>
+                <a:latin typeface="Calibri"/>
               </a:defRPr>
             </a:pPr>
           </a:p>
@@ -1253,7 +1253,7 @@
           <a:p>
             <a:pPr>
               <a:defRPr sz="1100">
-                <a:latin typeface="Helvetica"/>
+                <a:latin typeface="Calibri"/>
               </a:defRPr>
             </a:pPr>
             <a:r>
@@ -1263,7 +1263,7 @@
           <a:p>
             <a:pPr>
               <a:defRPr sz="1100">
-                <a:latin typeface="Helvetica"/>
+                <a:latin typeface="Calibri"/>
               </a:defRPr>
             </a:pPr>
           </a:p>
@@ -1335,7 +1335,7 @@
           <a:p>
             <a:pPr>
               <a:defRPr sz="1100">
-                <a:latin typeface="Helvetica"/>
+                <a:latin typeface="Calibri"/>
               </a:defRPr>
             </a:pPr>
             <a:r>
@@ -1345,7 +1345,7 @@
           <a:p>
             <a:pPr>
               <a:defRPr sz="1100">
-                <a:latin typeface="Helvetica"/>
+                <a:latin typeface="Calibri"/>
               </a:defRPr>
             </a:pPr>
           </a:p>
@@ -1417,7 +1417,7 @@
           <a:p>
             <a:pPr>
               <a:defRPr sz="1100">
-                <a:latin typeface="Helvetica"/>
+                <a:latin typeface="Calibri"/>
               </a:defRPr>
             </a:pPr>
             <a:r>
@@ -1427,7 +1427,7 @@
           <a:p>
             <a:pPr>
               <a:defRPr sz="1100">
-                <a:latin typeface="Helvetica"/>
+                <a:latin typeface="Calibri"/>
               </a:defRPr>
             </a:pPr>
           </a:p>
@@ -1499,7 +1499,7 @@
           <a:p>
             <a:pPr>
               <a:defRPr sz="1100">
-                <a:latin typeface="Helvetica"/>
+                <a:latin typeface="Calibri"/>
               </a:defRPr>
             </a:pPr>
             <a:r>
@@ -1509,7 +1509,7 @@
           <a:p>
             <a:pPr>
               <a:defRPr sz="1100">
-                <a:latin typeface="Helvetica"/>
+                <a:latin typeface="Calibri"/>
               </a:defRPr>
             </a:pPr>
           </a:p>
@@ -4512,7 +4512,7 @@
     <p:bg>
       <p:bgPr>
         <a:solidFill>
-          <a:srgbClr val="FAF9F6"/>
+          <a:srgbClr val="F7F6F2"/>
         </a:solidFill>
         <a:effectLst/>
       </p:bgPr>
@@ -4549,9 +4549,9 @@
             <a:pPr algn="l">
               <a:defRPr sz="3600" b="1">
                 <a:solidFill>
-                  <a:srgbClr val="1A1A2E"/>
-                </a:solidFill>
-                <a:latin typeface="Helvetica"/>
+                  <a:srgbClr val="1E2761"/>
+                </a:solidFill>
+                <a:latin typeface="Georgia"/>
               </a:defRPr>
             </a:pPr>
             <a:r>
@@ -4587,7 +4587,7 @@
                 <a:solidFill>
                   <a:srgbClr val="2C3E50"/>
                 </a:solidFill>
-                <a:latin typeface="Helvetica"/>
+                <a:latin typeface="Calibri"/>
               </a:defRPr>
             </a:pPr>
             <a:r>
@@ -4611,7 +4611,7 @@
             <a:avLst/>
           </a:prstGeom>
           <a:solidFill>
-            <a:srgbClr val="8B1A1A"/>
+            <a:srgbClr val="7B2D26"/>
           </a:solidFill>
           <a:ln>
             <a:noFill/>
@@ -4653,7 +4653,7 @@
     <p:bg>
       <p:bgPr>
         <a:solidFill>
-          <a:srgbClr val="FAF9F6"/>
+          <a:srgbClr val="F7F6F2"/>
         </a:solidFill>
         <a:effectLst/>
       </p:bgPr>
@@ -4690,9 +4690,9 @@
             <a:pPr algn="l">
               <a:defRPr sz="2800" b="1">
                 <a:solidFill>
-                  <a:srgbClr val="1A1A2E"/>
-                </a:solidFill>
-                <a:latin typeface="Helvetica"/>
+                  <a:srgbClr val="1E2761"/>
+                </a:solidFill>
+                <a:latin typeface="Georgia"/>
               </a:defRPr>
             </a:pPr>
             <a:r>
@@ -4716,7 +4716,7 @@
             <a:avLst/>
           </a:prstGeom>
           <a:solidFill>
-            <a:srgbClr val="8B1A1A"/>
+            <a:srgbClr val="7B2D26"/>
           </a:solidFill>
           <a:ln>
             <a:noFill/>
@@ -4774,7 +4774,7 @@
                 <a:solidFill>
                   <a:srgbClr val="2C3E50"/>
                 </a:solidFill>
-                <a:latin typeface="Helvetica"/>
+                <a:latin typeface="Calibri"/>
               </a:defRPr>
             </a:pPr>
             <a:r>
@@ -4790,7 +4790,7 @@
                 <a:solidFill>
                   <a:srgbClr val="2C3E50"/>
                 </a:solidFill>
-                <a:latin typeface="Helvetica"/>
+                <a:latin typeface="Calibri"/>
               </a:defRPr>
             </a:pPr>
             <a:r>
@@ -4806,7 +4806,7 @@
                 <a:solidFill>
                   <a:srgbClr val="2C3E50"/>
                 </a:solidFill>
-                <a:latin typeface="Helvetica"/>
+                <a:latin typeface="Calibri"/>
               </a:defRPr>
             </a:pPr>
             <a:r>
@@ -4822,7 +4822,7 @@
                 <a:solidFill>
                   <a:srgbClr val="2C3E50"/>
                 </a:solidFill>
-                <a:latin typeface="Helvetica"/>
+                <a:latin typeface="Calibri"/>
               </a:defRPr>
             </a:pPr>
             <a:r>
@@ -4838,7 +4838,7 @@
                 <a:solidFill>
                   <a:srgbClr val="2C3E50"/>
                 </a:solidFill>
-                <a:latin typeface="Helvetica"/>
+                <a:latin typeface="Calibri"/>
               </a:defRPr>
             </a:pPr>
             <a:r>
@@ -4854,7 +4854,7 @@
                 <a:solidFill>
                   <a:srgbClr val="2C3E50"/>
                 </a:solidFill>
-                <a:latin typeface="Helvetica"/>
+                <a:latin typeface="Calibri"/>
               </a:defRPr>
             </a:pPr>
             <a:r>
@@ -4893,7 +4893,7 @@
                 <a:solidFill>
                   <a:srgbClr val="2C3E50"/>
                 </a:solidFill>
-                <a:latin typeface="Helvetica"/>
+                <a:latin typeface="Calibri"/>
               </a:defRPr>
             </a:pPr>
             <a:r>
@@ -4909,7 +4909,7 @@
                 <a:solidFill>
                   <a:srgbClr val="2C3E50"/>
                 </a:solidFill>
-                <a:latin typeface="Helvetica"/>
+                <a:latin typeface="Calibri"/>
               </a:defRPr>
             </a:pPr>
             <a:r>
@@ -4925,7 +4925,7 @@
                 <a:solidFill>
                   <a:srgbClr val="2C3E50"/>
                 </a:solidFill>
-                <a:latin typeface="Helvetica"/>
+                <a:latin typeface="Calibri"/>
               </a:defRPr>
             </a:pPr>
             <a:r>
@@ -4941,7 +4941,7 @@
                 <a:solidFill>
                   <a:srgbClr val="2C3E50"/>
                 </a:solidFill>
-                <a:latin typeface="Helvetica"/>
+                <a:latin typeface="Calibri"/>
               </a:defRPr>
             </a:pPr>
             <a:r>
@@ -4957,7 +4957,7 @@
                 <a:solidFill>
                   <a:srgbClr val="2C3E50"/>
                 </a:solidFill>
-                <a:latin typeface="Helvetica"/>
+                <a:latin typeface="Calibri"/>
               </a:defRPr>
             </a:pPr>
             <a:r>
@@ -4980,7 +4980,7 @@
     <p:bg>
       <p:bgPr>
         <a:solidFill>
-          <a:srgbClr val="FAF9F6"/>
+          <a:srgbClr val="F7F6F2"/>
         </a:solidFill>
         <a:effectLst/>
       </p:bgPr>
@@ -5017,9 +5017,9 @@
             <a:pPr algn="l">
               <a:defRPr sz="2800" b="1">
                 <a:solidFill>
-                  <a:srgbClr val="1A1A2E"/>
-                </a:solidFill>
-                <a:latin typeface="Helvetica"/>
+                  <a:srgbClr val="1E2761"/>
+                </a:solidFill>
+                <a:latin typeface="Georgia"/>
               </a:defRPr>
             </a:pPr>
             <a:r>
@@ -5043,7 +5043,7 @@
             <a:avLst/>
           </a:prstGeom>
           <a:solidFill>
-            <a:srgbClr val="8B1A1A"/>
+            <a:srgbClr val="7B2D26"/>
           </a:solidFill>
           <a:ln>
             <a:noFill/>
@@ -5101,7 +5101,7 @@
                 <a:solidFill>
                   <a:srgbClr val="2C3E50"/>
                 </a:solidFill>
-                <a:latin typeface="Helvetica"/>
+                <a:latin typeface="Calibri"/>
               </a:defRPr>
             </a:pPr>
             <a:r>
@@ -5117,7 +5117,7 @@
                 <a:solidFill>
                   <a:srgbClr val="2C3E50"/>
                 </a:solidFill>
-                <a:latin typeface="Helvetica"/>
+                <a:latin typeface="Calibri"/>
               </a:defRPr>
             </a:pPr>
             <a:r>
@@ -5133,7 +5133,7 @@
                 <a:solidFill>
                   <a:srgbClr val="2C3E50"/>
                 </a:solidFill>
-                <a:latin typeface="Helvetica"/>
+                <a:latin typeface="Calibri"/>
               </a:defRPr>
             </a:pPr>
             <a:r>
@@ -5149,7 +5149,7 @@
                 <a:solidFill>
                   <a:srgbClr val="2C3E50"/>
                 </a:solidFill>
-                <a:latin typeface="Helvetica"/>
+                <a:latin typeface="Calibri"/>
               </a:defRPr>
             </a:pPr>
             <a:r>
@@ -5165,7 +5165,7 @@
                 <a:solidFill>
                   <a:srgbClr val="2C3E50"/>
                 </a:solidFill>
-                <a:latin typeface="Helvetica"/>
+                <a:latin typeface="Calibri"/>
               </a:defRPr>
             </a:pPr>
             <a:r>
@@ -5204,7 +5204,7 @@
                 <a:solidFill>
                   <a:srgbClr val="2C3E50"/>
                 </a:solidFill>
-                <a:latin typeface="Helvetica"/>
+                <a:latin typeface="Calibri"/>
               </a:defRPr>
             </a:pPr>
             <a:r>
@@ -5220,7 +5220,7 @@
                 <a:solidFill>
                   <a:srgbClr val="2C3E50"/>
                 </a:solidFill>
-                <a:latin typeface="Helvetica"/>
+                <a:latin typeface="Calibri"/>
               </a:defRPr>
             </a:pPr>
             <a:r>
@@ -5236,7 +5236,7 @@
                 <a:solidFill>
                   <a:srgbClr val="2C3E50"/>
                 </a:solidFill>
-                <a:latin typeface="Helvetica"/>
+                <a:latin typeface="Calibri"/>
               </a:defRPr>
             </a:pPr>
             <a:r>
@@ -5252,7 +5252,7 @@
                 <a:solidFill>
                   <a:srgbClr val="2C3E50"/>
                 </a:solidFill>
-                <a:latin typeface="Helvetica"/>
+                <a:latin typeface="Calibri"/>
               </a:defRPr>
             </a:pPr>
             <a:r>
@@ -5268,7 +5268,7 @@
                 <a:solidFill>
                   <a:srgbClr val="2C3E50"/>
                 </a:solidFill>
-                <a:latin typeface="Helvetica"/>
+                <a:latin typeface="Calibri"/>
               </a:defRPr>
             </a:pPr>
             <a:r>
@@ -5291,7 +5291,7 @@
     <p:bg>
       <p:bgPr>
         <a:solidFill>
-          <a:srgbClr val="FAF9F6"/>
+          <a:srgbClr val="F7F6F2"/>
         </a:solidFill>
         <a:effectLst/>
       </p:bgPr>
@@ -5328,9 +5328,9 @@
             <a:pPr algn="l">
               <a:defRPr sz="2800" b="1">
                 <a:solidFill>
-                  <a:srgbClr val="1A1A2E"/>
-                </a:solidFill>
-                <a:latin typeface="Helvetica"/>
+                  <a:srgbClr val="1E2761"/>
+                </a:solidFill>
+                <a:latin typeface="Georgia"/>
               </a:defRPr>
             </a:pPr>
             <a:r>
@@ -5354,7 +5354,7 @@
             <a:avLst/>
           </a:prstGeom>
           <a:solidFill>
-            <a:srgbClr val="8B1A1A"/>
+            <a:srgbClr val="7B2D26"/>
           </a:solidFill>
           <a:ln>
             <a:noFill/>
@@ -5412,7 +5412,7 @@
                 <a:solidFill>
                   <a:srgbClr val="2C3E50"/>
                 </a:solidFill>
-                <a:latin typeface="Helvetica"/>
+                <a:latin typeface="Calibri"/>
               </a:defRPr>
             </a:pPr>
             <a:r>
@@ -5428,7 +5428,7 @@
                 <a:solidFill>
                   <a:srgbClr val="2C3E50"/>
                 </a:solidFill>
-                <a:latin typeface="Helvetica"/>
+                <a:latin typeface="Calibri"/>
               </a:defRPr>
             </a:pPr>
             <a:r>
@@ -5444,7 +5444,7 @@
                 <a:solidFill>
                   <a:srgbClr val="2C3E50"/>
                 </a:solidFill>
-                <a:latin typeface="Helvetica"/>
+                <a:latin typeface="Calibri"/>
               </a:defRPr>
             </a:pPr>
             <a:r>
@@ -5460,7 +5460,7 @@
                 <a:solidFill>
                   <a:srgbClr val="2C3E50"/>
                 </a:solidFill>
-                <a:latin typeface="Helvetica"/>
+                <a:latin typeface="Calibri"/>
               </a:defRPr>
             </a:pPr>
             <a:r>
@@ -5499,7 +5499,7 @@
                 <a:solidFill>
                   <a:srgbClr val="2C3E50"/>
                 </a:solidFill>
-                <a:latin typeface="Helvetica"/>
+                <a:latin typeface="Calibri"/>
               </a:defRPr>
             </a:pPr>
             <a:r>
@@ -5515,7 +5515,7 @@
                 <a:solidFill>
                   <a:srgbClr val="2C3E50"/>
                 </a:solidFill>
-                <a:latin typeface="Helvetica"/>
+                <a:latin typeface="Calibri"/>
               </a:defRPr>
             </a:pPr>
             <a:r>
@@ -5531,7 +5531,7 @@
                 <a:solidFill>
                   <a:srgbClr val="2C3E50"/>
                 </a:solidFill>
-                <a:latin typeface="Helvetica"/>
+                <a:latin typeface="Calibri"/>
               </a:defRPr>
             </a:pPr>
             <a:r>
@@ -5547,7 +5547,7 @@
                 <a:solidFill>
                   <a:srgbClr val="2C3E50"/>
                 </a:solidFill>
-                <a:latin typeface="Helvetica"/>
+                <a:latin typeface="Calibri"/>
               </a:defRPr>
             </a:pPr>
             <a:r>
@@ -5570,7 +5570,7 @@
     <p:bg>
       <p:bgPr>
         <a:solidFill>
-          <a:srgbClr val="FAF9F6"/>
+          <a:srgbClr val="F7F6F2"/>
         </a:solidFill>
         <a:effectLst/>
       </p:bgPr>
@@ -5607,9 +5607,9 @@
             <a:pPr algn="l">
               <a:defRPr sz="2800" b="1">
                 <a:solidFill>
-                  <a:srgbClr val="1A1A2E"/>
-                </a:solidFill>
-                <a:latin typeface="Helvetica"/>
+                  <a:srgbClr val="1E2761"/>
+                </a:solidFill>
+                <a:latin typeface="Georgia"/>
               </a:defRPr>
             </a:pPr>
             <a:r>
@@ -5633,7 +5633,7 @@
             <a:avLst/>
           </a:prstGeom>
           <a:solidFill>
-            <a:srgbClr val="8B1A1A"/>
+            <a:srgbClr val="7B2D26"/>
           </a:solidFill>
           <a:ln>
             <a:noFill/>
@@ -5691,7 +5691,7 @@
                 <a:solidFill>
                   <a:srgbClr val="2C3E50"/>
                 </a:solidFill>
-                <a:latin typeface="Helvetica"/>
+                <a:latin typeface="Calibri"/>
               </a:defRPr>
             </a:pPr>
             <a:r>
@@ -5707,7 +5707,7 @@
                 <a:solidFill>
                   <a:srgbClr val="2C3E50"/>
                 </a:solidFill>
-                <a:latin typeface="Helvetica"/>
+                <a:latin typeface="Calibri"/>
               </a:defRPr>
             </a:pPr>
             <a:r>
@@ -5723,7 +5723,7 @@
                 <a:solidFill>
                   <a:srgbClr val="2C3E50"/>
                 </a:solidFill>
-                <a:latin typeface="Helvetica"/>
+                <a:latin typeface="Calibri"/>
               </a:defRPr>
             </a:pPr>
             <a:r>
@@ -5739,7 +5739,7 @@
                 <a:solidFill>
                   <a:srgbClr val="2C3E50"/>
                 </a:solidFill>
-                <a:latin typeface="Helvetica"/>
+                <a:latin typeface="Calibri"/>
               </a:defRPr>
             </a:pPr>
             <a:r>
@@ -5755,7 +5755,7 @@
                 <a:solidFill>
                   <a:srgbClr val="2C3E50"/>
                 </a:solidFill>
-                <a:latin typeface="Helvetica"/>
+                <a:latin typeface="Calibri"/>
               </a:defRPr>
             </a:pPr>
             <a:r>
@@ -5771,7 +5771,7 @@
                 <a:solidFill>
                   <a:srgbClr val="2C3E50"/>
                 </a:solidFill>
-                <a:latin typeface="Helvetica"/>
+                <a:latin typeface="Calibri"/>
               </a:defRPr>
             </a:pPr>
             <a:r>
@@ -5787,7 +5787,7 @@
                 <a:solidFill>
                   <a:srgbClr val="2C3E50"/>
                 </a:solidFill>
-                <a:latin typeface="Helvetica"/>
+                <a:latin typeface="Calibri"/>
               </a:defRPr>
             </a:pPr>
             <a:r>
@@ -5810,7 +5810,7 @@
     <p:bg>
       <p:bgPr>
         <a:solidFill>
-          <a:srgbClr val="FAF9F6"/>
+          <a:srgbClr val="F7F6F2"/>
         </a:solidFill>
         <a:effectLst/>
       </p:bgPr>
@@ -5847,9 +5847,9 @@
             <a:pPr algn="l">
               <a:defRPr sz="2800" b="1">
                 <a:solidFill>
-                  <a:srgbClr val="1A1A2E"/>
-                </a:solidFill>
-                <a:latin typeface="Helvetica"/>
+                  <a:srgbClr val="1E2761"/>
+                </a:solidFill>
+                <a:latin typeface="Georgia"/>
               </a:defRPr>
             </a:pPr>
             <a:r>
@@ -5873,7 +5873,7 @@
             <a:avLst/>
           </a:prstGeom>
           <a:solidFill>
-            <a:srgbClr val="8B1A1A"/>
+            <a:srgbClr val="7B2D26"/>
           </a:solidFill>
           <a:ln>
             <a:noFill/>
@@ -5931,7 +5931,7 @@
                 <a:solidFill>
                   <a:srgbClr val="2C3E50"/>
                 </a:solidFill>
-                <a:latin typeface="Helvetica"/>
+                <a:latin typeface="Calibri"/>
               </a:defRPr>
             </a:pPr>
             <a:r>
@@ -5947,7 +5947,7 @@
                 <a:solidFill>
                   <a:srgbClr val="2C3E50"/>
                 </a:solidFill>
-                <a:latin typeface="Helvetica"/>
+                <a:latin typeface="Calibri"/>
               </a:defRPr>
             </a:pPr>
             <a:r>
@@ -5963,7 +5963,7 @@
                 <a:solidFill>
                   <a:srgbClr val="2C3E50"/>
                 </a:solidFill>
-                <a:latin typeface="Helvetica"/>
+                <a:latin typeface="Calibri"/>
               </a:defRPr>
             </a:pPr>
             <a:r>
@@ -5979,7 +5979,7 @@
                 <a:solidFill>
                   <a:srgbClr val="2C3E50"/>
                 </a:solidFill>
-                <a:latin typeface="Helvetica"/>
+                <a:latin typeface="Calibri"/>
               </a:defRPr>
             </a:pPr>
             <a:r>
@@ -6002,7 +6002,7 @@
     <p:bg>
       <p:bgPr>
         <a:solidFill>
-          <a:srgbClr val="FAF9F6"/>
+          <a:srgbClr val="F7F6F2"/>
         </a:solidFill>
         <a:effectLst/>
       </p:bgPr>
@@ -6039,9 +6039,9 @@
             <a:pPr algn="l">
               <a:defRPr sz="2800" b="1">
                 <a:solidFill>
-                  <a:srgbClr val="1A1A2E"/>
-                </a:solidFill>
-                <a:latin typeface="Helvetica"/>
+                  <a:srgbClr val="1E2761"/>
+                </a:solidFill>
+                <a:latin typeface="Georgia"/>
               </a:defRPr>
             </a:pPr>
             <a:r>
@@ -6075,9 +6075,9 @@
             <a:pPr algn="ctr">
               <a:defRPr sz="2200" i="1">
                 <a:solidFill>
-                  <a:srgbClr val="1A1A2E"/>
-                </a:solidFill>
-                <a:latin typeface="Helvetica"/>
+                  <a:srgbClr val="1E2761"/>
+                </a:solidFill>
+                <a:latin typeface="Calibri"/>
               </a:defRPr>
             </a:pPr>
             <a:r>
@@ -6111,9 +6111,9 @@
             <a:pPr algn="ctr">
               <a:defRPr sz="1400" b="0">
                 <a:solidFill>
-                  <a:srgbClr val="8B1A1A"/>
-                </a:solidFill>
-                <a:latin typeface="Helvetica"/>
+                  <a:srgbClr val="7B2D26"/>
+                </a:solidFill>
+                <a:latin typeface="Calibri"/>
               </a:defRPr>
             </a:pPr>
             <a:r>
@@ -6136,7 +6136,7 @@
     <p:bg>
       <p:bgPr>
         <a:solidFill>
-          <a:srgbClr val="FAF9F6"/>
+          <a:srgbClr val="F7F6F2"/>
         </a:solidFill>
         <a:effectLst/>
       </p:bgPr>
@@ -6173,9 +6173,9 @@
             <a:pPr algn="l">
               <a:defRPr sz="2800" b="1">
                 <a:solidFill>
-                  <a:srgbClr val="1A1A2E"/>
-                </a:solidFill>
-                <a:latin typeface="Helvetica"/>
+                  <a:srgbClr val="1E2761"/>
+                </a:solidFill>
+                <a:latin typeface="Georgia"/>
               </a:defRPr>
             </a:pPr>
             <a:r>
@@ -6199,7 +6199,7 @@
             <a:avLst/>
           </a:prstGeom>
           <a:solidFill>
-            <a:srgbClr val="8B1A1A"/>
+            <a:srgbClr val="7B2D26"/>
           </a:solidFill>
           <a:ln>
             <a:noFill/>
@@ -6257,7 +6257,7 @@
                 <a:solidFill>
                   <a:srgbClr val="2C3E50"/>
                 </a:solidFill>
-                <a:latin typeface="Helvetica"/>
+                <a:latin typeface="Calibri"/>
               </a:defRPr>
             </a:pPr>
             <a:r>
@@ -6273,7 +6273,7 @@
                 <a:solidFill>
                   <a:srgbClr val="2C3E50"/>
                 </a:solidFill>
-                <a:latin typeface="Helvetica"/>
+                <a:latin typeface="Calibri"/>
               </a:defRPr>
             </a:pPr>
             <a:r>
@@ -6289,7 +6289,7 @@
                 <a:solidFill>
                   <a:srgbClr val="2C3E50"/>
                 </a:solidFill>
-                <a:latin typeface="Helvetica"/>
+                <a:latin typeface="Calibri"/>
               </a:defRPr>
             </a:pPr>
             <a:r>
@@ -6305,7 +6305,7 @@
                 <a:solidFill>
                   <a:srgbClr val="2C3E50"/>
                 </a:solidFill>
-                <a:latin typeface="Helvetica"/>
+                <a:latin typeface="Calibri"/>
               </a:defRPr>
             </a:pPr>
             <a:r>
@@ -6321,7 +6321,7 @@
                 <a:solidFill>
                   <a:srgbClr val="2C3E50"/>
                 </a:solidFill>
-                <a:latin typeface="Helvetica"/>
+                <a:latin typeface="Calibri"/>
               </a:defRPr>
             </a:pPr>
             <a:r>
@@ -6344,7 +6344,7 @@
     <p:bg>
       <p:bgPr>
         <a:solidFill>
-          <a:srgbClr val="FAF9F6"/>
+          <a:srgbClr val="F7F6F2"/>
         </a:solidFill>
         <a:effectLst/>
       </p:bgPr>
@@ -6381,9 +6381,9 @@
             <a:pPr algn="l">
               <a:defRPr sz="2800" b="1">
                 <a:solidFill>
-                  <a:srgbClr val="1A1A2E"/>
-                </a:solidFill>
-                <a:latin typeface="Helvetica"/>
+                  <a:srgbClr val="1E2761"/>
+                </a:solidFill>
+                <a:latin typeface="Georgia"/>
               </a:defRPr>
             </a:pPr>
             <a:r>
@@ -6407,7 +6407,7 @@
             <a:avLst/>
           </a:prstGeom>
           <a:solidFill>
-            <a:srgbClr val="8B1A1A"/>
+            <a:srgbClr val="7B2D26"/>
           </a:solidFill>
           <a:ln>
             <a:noFill/>
@@ -6465,7 +6465,7 @@
                 <a:solidFill>
                   <a:srgbClr val="2C3E50"/>
                 </a:solidFill>
-                <a:latin typeface="Helvetica"/>
+                <a:latin typeface="Calibri"/>
               </a:defRPr>
             </a:pPr>
             <a:r>
@@ -6481,7 +6481,7 @@
                 <a:solidFill>
                   <a:srgbClr val="2C3E50"/>
                 </a:solidFill>
-                <a:latin typeface="Helvetica"/>
+                <a:latin typeface="Calibri"/>
               </a:defRPr>
             </a:pPr>
             <a:r>
@@ -6497,7 +6497,7 @@
                 <a:solidFill>
                   <a:srgbClr val="2C3E50"/>
                 </a:solidFill>
-                <a:latin typeface="Helvetica"/>
+                <a:latin typeface="Calibri"/>
               </a:defRPr>
             </a:pPr>
             <a:r>
@@ -6513,7 +6513,7 @@
                 <a:solidFill>
                   <a:srgbClr val="2C3E50"/>
                 </a:solidFill>
-                <a:latin typeface="Helvetica"/>
+                <a:latin typeface="Calibri"/>
               </a:defRPr>
             </a:pPr>
             <a:r>
@@ -6529,7 +6529,7 @@
                 <a:solidFill>
                   <a:srgbClr val="2C3E50"/>
                 </a:solidFill>
-                <a:latin typeface="Helvetica"/>
+                <a:latin typeface="Calibri"/>
               </a:defRPr>
             </a:pPr>
             <a:r>
@@ -6568,7 +6568,7 @@
                 <a:solidFill>
                   <a:srgbClr val="2C3E50"/>
                 </a:solidFill>
-                <a:latin typeface="Helvetica"/>
+                <a:latin typeface="Calibri"/>
               </a:defRPr>
             </a:pPr>
             <a:r>
@@ -6584,7 +6584,7 @@
                 <a:solidFill>
                   <a:srgbClr val="2C3E50"/>
                 </a:solidFill>
-                <a:latin typeface="Helvetica"/>
+                <a:latin typeface="Calibri"/>
               </a:defRPr>
             </a:pPr>
             <a:r>
@@ -6600,7 +6600,7 @@
                 <a:solidFill>
                   <a:srgbClr val="2C3E50"/>
                 </a:solidFill>
-                <a:latin typeface="Helvetica"/>
+                <a:latin typeface="Calibri"/>
               </a:defRPr>
             </a:pPr>
             <a:r>
@@ -6616,7 +6616,7 @@
                 <a:solidFill>
                   <a:srgbClr val="2C3E50"/>
                 </a:solidFill>
-                <a:latin typeface="Helvetica"/>
+                <a:latin typeface="Calibri"/>
               </a:defRPr>
             </a:pPr>
             <a:r>
@@ -6639,7 +6639,7 @@
     <p:bg>
       <p:bgPr>
         <a:solidFill>
-          <a:srgbClr val="FAF9F6"/>
+          <a:srgbClr val="F7F6F2"/>
         </a:solidFill>
         <a:effectLst/>
       </p:bgPr>
@@ -6676,9 +6676,9 @@
             <a:pPr algn="l">
               <a:defRPr sz="2800" b="1">
                 <a:solidFill>
-                  <a:srgbClr val="1A1A2E"/>
-                </a:solidFill>
-                <a:latin typeface="Helvetica"/>
+                  <a:srgbClr val="1E2761"/>
+                </a:solidFill>
+                <a:latin typeface="Georgia"/>
               </a:defRPr>
             </a:pPr>
             <a:r>
@@ -6702,7 +6702,7 @@
             <a:avLst/>
           </a:prstGeom>
           <a:solidFill>
-            <a:srgbClr val="8B1A1A"/>
+            <a:srgbClr val="7B2D26"/>
           </a:solidFill>
           <a:ln>
             <a:noFill/>
@@ -6760,7 +6760,7 @@
                 <a:solidFill>
                   <a:srgbClr val="2C3E50"/>
                 </a:solidFill>
-                <a:latin typeface="Helvetica"/>
+                <a:latin typeface="Calibri"/>
               </a:defRPr>
             </a:pPr>
             <a:r>
@@ -6776,7 +6776,7 @@
                 <a:solidFill>
                   <a:srgbClr val="2C3E50"/>
                 </a:solidFill>
-                <a:latin typeface="Helvetica"/>
+                <a:latin typeface="Calibri"/>
               </a:defRPr>
             </a:pPr>
             <a:r>
@@ -6792,7 +6792,7 @@
                 <a:solidFill>
                   <a:srgbClr val="2C3E50"/>
                 </a:solidFill>
-                <a:latin typeface="Helvetica"/>
+                <a:latin typeface="Calibri"/>
               </a:defRPr>
             </a:pPr>
             <a:r>
@@ -6808,7 +6808,7 @@
                 <a:solidFill>
                   <a:srgbClr val="2C3E50"/>
                 </a:solidFill>
-                <a:latin typeface="Helvetica"/>
+                <a:latin typeface="Calibri"/>
               </a:defRPr>
             </a:pPr>
             <a:r>
@@ -6824,7 +6824,7 @@
                 <a:solidFill>
                   <a:srgbClr val="2C3E50"/>
                 </a:solidFill>
-                <a:latin typeface="Helvetica"/>
+                <a:latin typeface="Calibri"/>
               </a:defRPr>
             </a:pPr>
             <a:r>
@@ -6863,7 +6863,7 @@
                 <a:solidFill>
                   <a:srgbClr val="2C3E50"/>
                 </a:solidFill>
-                <a:latin typeface="Helvetica"/>
+                <a:latin typeface="Calibri"/>
               </a:defRPr>
             </a:pPr>
             <a:r>
@@ -6879,7 +6879,7 @@
                 <a:solidFill>
                   <a:srgbClr val="2C3E50"/>
                 </a:solidFill>
-                <a:latin typeface="Helvetica"/>
+                <a:latin typeface="Calibri"/>
               </a:defRPr>
             </a:pPr>
             <a:r>
@@ -6895,7 +6895,7 @@
                 <a:solidFill>
                   <a:srgbClr val="2C3E50"/>
                 </a:solidFill>
-                <a:latin typeface="Helvetica"/>
+                <a:latin typeface="Calibri"/>
               </a:defRPr>
             </a:pPr>
             <a:r>
@@ -6911,7 +6911,7 @@
                 <a:solidFill>
                   <a:srgbClr val="2C3E50"/>
                 </a:solidFill>
-                <a:latin typeface="Helvetica"/>
+                <a:latin typeface="Calibri"/>
               </a:defRPr>
             </a:pPr>
             <a:r>
@@ -6927,7 +6927,7 @@
                 <a:solidFill>
                   <a:srgbClr val="2C3E50"/>
                 </a:solidFill>
-                <a:latin typeface="Helvetica"/>
+                <a:latin typeface="Calibri"/>
               </a:defRPr>
             </a:pPr>
             <a:r>
@@ -6950,7 +6950,7 @@
     <p:bg>
       <p:bgPr>
         <a:solidFill>
-          <a:srgbClr val="FAF9F6"/>
+          <a:srgbClr val="F7F6F2"/>
         </a:solidFill>
         <a:effectLst/>
       </p:bgPr>
@@ -6987,9 +6987,9 @@
             <a:pPr algn="l">
               <a:defRPr sz="2800" b="1">
                 <a:solidFill>
-                  <a:srgbClr val="1A1A2E"/>
-                </a:solidFill>
-                <a:latin typeface="Helvetica"/>
+                  <a:srgbClr val="1E2761"/>
+                </a:solidFill>
+                <a:latin typeface="Georgia"/>
               </a:defRPr>
             </a:pPr>
             <a:r>
@@ -7013,7 +7013,7 @@
             <a:avLst/>
           </a:prstGeom>
           <a:solidFill>
-            <a:srgbClr val="8B1A1A"/>
+            <a:srgbClr val="7B2D26"/>
           </a:solidFill>
           <a:ln>
             <a:noFill/>
@@ -7071,7 +7071,7 @@
                 <a:solidFill>
                   <a:srgbClr val="2C3E50"/>
                 </a:solidFill>
-                <a:latin typeface="Helvetica"/>
+                <a:latin typeface="Calibri"/>
               </a:defRPr>
             </a:pPr>
             <a:r>
@@ -7087,7 +7087,7 @@
                 <a:solidFill>
                   <a:srgbClr val="2C3E50"/>
                 </a:solidFill>
-                <a:latin typeface="Helvetica"/>
+                <a:latin typeface="Calibri"/>
               </a:defRPr>
             </a:pPr>
             <a:r>
@@ -7103,7 +7103,7 @@
                 <a:solidFill>
                   <a:srgbClr val="2C3E50"/>
                 </a:solidFill>
-                <a:latin typeface="Helvetica"/>
+                <a:latin typeface="Calibri"/>
               </a:defRPr>
             </a:pPr>
             <a:r>
@@ -7119,7 +7119,7 @@
                 <a:solidFill>
                   <a:srgbClr val="2C3E50"/>
                 </a:solidFill>
-                <a:latin typeface="Helvetica"/>
+                <a:latin typeface="Calibri"/>
               </a:defRPr>
             </a:pPr>
             <a:r>
@@ -7135,7 +7135,7 @@
                 <a:solidFill>
                   <a:srgbClr val="2C3E50"/>
                 </a:solidFill>
-                <a:latin typeface="Helvetica"/>
+                <a:latin typeface="Calibri"/>
               </a:defRPr>
             </a:pPr>
             <a:r>
@@ -7174,7 +7174,7 @@
                 <a:solidFill>
                   <a:srgbClr val="2C3E50"/>
                 </a:solidFill>
-                <a:latin typeface="Helvetica"/>
+                <a:latin typeface="Calibri"/>
               </a:defRPr>
             </a:pPr>
             <a:r>
@@ -7190,7 +7190,7 @@
                 <a:solidFill>
                   <a:srgbClr val="2C3E50"/>
                 </a:solidFill>
-                <a:latin typeface="Helvetica"/>
+                <a:latin typeface="Calibri"/>
               </a:defRPr>
             </a:pPr>
             <a:r>
@@ -7206,7 +7206,7 @@
                 <a:solidFill>
                   <a:srgbClr val="2C3E50"/>
                 </a:solidFill>
-                <a:latin typeface="Helvetica"/>
+                <a:latin typeface="Calibri"/>
               </a:defRPr>
             </a:pPr>
             <a:r>
@@ -7222,7 +7222,7 @@
                 <a:solidFill>
                   <a:srgbClr val="2C3E50"/>
                 </a:solidFill>
-                <a:latin typeface="Helvetica"/>
+                <a:latin typeface="Calibri"/>
               </a:defRPr>
             </a:pPr>
             <a:r>
@@ -7245,7 +7245,7 @@
     <p:bg>
       <p:bgPr>
         <a:solidFill>
-          <a:srgbClr val="FAF9F6"/>
+          <a:srgbClr val="F7F6F2"/>
         </a:solidFill>
         <a:effectLst/>
       </p:bgPr>
@@ -7282,13 +7282,13 @@
             <a:pPr algn="l">
               <a:defRPr sz="2800" b="1">
                 <a:solidFill>
-                  <a:srgbClr val="1A1A2E"/>
-                </a:solidFill>
-                <a:latin typeface="Helvetica"/>
-              </a:defRPr>
-            </a:pPr>
-            <a:r>
-              <a:t>samskara — Latent Impressions</a:t>
+                  <a:srgbClr val="1E2761"/>
+                </a:solidFill>
+                <a:latin typeface="Georgia"/>
+              </a:defRPr>
+            </a:pPr>
+            <a:r>
+              <a:t>saṃskāra — Latent Impressions</a:t>
             </a:r>
           </a:p>
         </p:txBody>
@@ -7308,7 +7308,7 @@
             <a:avLst/>
           </a:prstGeom>
           <a:solidFill>
-            <a:srgbClr val="8B1A1A"/>
+            <a:srgbClr val="7B2D26"/>
           </a:solidFill>
           <a:ln>
             <a:noFill/>
@@ -7366,11 +7366,11 @@
                 <a:solidFill>
                   <a:srgbClr val="2C3E50"/>
                 </a:solidFill>
-                <a:latin typeface="Helvetica"/>
-              </a:defRPr>
-            </a:pPr>
-            <a:r>
-              <a:t>Root: √kr — "to do, make"    Prefix: sam- ("completely")</a:t>
+                <a:latin typeface="Calibri"/>
+              </a:defRPr>
+            </a:pPr>
+            <a:r>
+              <a:t>Root: √kṛ — "to do, make"</a:t>
             </a:r>
           </a:p>
           <a:p>
@@ -7382,11 +7382,11 @@
                 <a:solidFill>
                   <a:srgbClr val="2C3E50"/>
                 </a:solidFill>
-                <a:latin typeface="Helvetica"/>
-              </a:defRPr>
-            </a:pPr>
-            <a:r>
-              <a:t>Literal: "a thorough making"     Philosophical: accumulated subliminal traces</a:t>
+                <a:latin typeface="Calibri"/>
+              </a:defRPr>
+            </a:pPr>
+            <a:r>
+              <a:t>Prefix: sam- ("completely, thoroughly")</a:t>
             </a:r>
           </a:p>
           <a:p>
@@ -7398,11 +7398,11 @@
                 <a:solidFill>
                   <a:srgbClr val="2C3E50"/>
                 </a:solidFill>
-                <a:latin typeface="Helvetica"/>
-              </a:defRPr>
-            </a:pPr>
-            <a:r>
-              <a:t>Three lives of one word:</a:t>
+                <a:latin typeface="Calibri"/>
+              </a:defRPr>
+            </a:pPr>
+            <a:r>
+              <a:t>Literal: "a thorough making"</a:t>
             </a:r>
           </a:p>
           <a:p>
@@ -7414,11 +7414,11 @@
                 <a:solidFill>
                   <a:srgbClr val="2C3E50"/>
                 </a:solidFill>
-                <a:latin typeface="Helvetica"/>
-              </a:defRPr>
-            </a:pPr>
-            <a:r>
-              <a:t>Ritual: consecration, sacrament (the samskaras of life)</a:t>
+                <a:latin typeface="Calibri"/>
+              </a:defRPr>
+            </a:pPr>
+            <a:r>
+              <a:t>Philosophical: accumulated subliminal traces that shape perception</a:t>
             </a:r>
           </a:p>
           <a:p>
@@ -7430,11 +7430,11 @@
                 <a:solidFill>
                   <a:srgbClr val="2C3E50"/>
                 </a:solidFill>
-                <a:latin typeface="Helvetica"/>
-              </a:defRPr>
-            </a:pPr>
-            <a:r>
-              <a:t>Grammar: refinement (samskrta = "Sanskrit" = the "well-made" language)</a:t>
+                <a:latin typeface="Calibri"/>
+              </a:defRPr>
+            </a:pPr>
+            <a:r>
+              <a:t>Three lives of one word:</a:t>
             </a:r>
           </a:p>
           <a:p>
@@ -7446,11 +7446,11 @@
                 <a:solidFill>
                   <a:srgbClr val="2C3E50"/>
                 </a:solidFill>
-                <a:latin typeface="Helvetica"/>
-              </a:defRPr>
-            </a:pPr>
-            <a:r>
-              <a:t>Yoga Sutras: latent impressions — the unconscious residue of experience</a:t>
+                <a:latin typeface="Calibri"/>
+              </a:defRPr>
+            </a:pPr>
+            <a:r>
+              <a:t>Ritual: consecration, sacrament</a:t>
             </a:r>
           </a:p>
           <a:p>
@@ -7462,11 +7462,43 @@
                 <a:solidFill>
                   <a:srgbClr val="2C3E50"/>
                 </a:solidFill>
-                <a:latin typeface="Helvetica"/>
-              </a:defRPr>
-            </a:pPr>
-            <a:r>
-              <a:t>Samskaras from samadhi can overwrite samskaras from ordinary experience (YS 1.50)</a:t>
+                <a:latin typeface="Calibri"/>
+              </a:defRPr>
+            </a:pPr>
+            <a:r>
+              <a:t>Grammar: refinement — saṃskṛta = "Sanskrit" = the "well-made" language</a:t>
+            </a:r>
+          </a:p>
+          <a:p>
+            <a:pPr>
+              <a:spcAft>
+                <a:spcPts val="800"/>
+              </a:spcAft>
+              <a:defRPr sz="1800">
+                <a:solidFill>
+                  <a:srgbClr val="2C3E50"/>
+                </a:solidFill>
+                <a:latin typeface="Calibri"/>
+              </a:defRPr>
+            </a:pPr>
+            <a:r>
+              <a:t>Yoga Sutras: the unconscious residue of experience</a:t>
+            </a:r>
+          </a:p>
+          <a:p>
+            <a:pPr>
+              <a:spcAft>
+                <a:spcPts val="800"/>
+              </a:spcAft>
+              <a:defRPr sz="1800">
+                <a:solidFill>
+                  <a:srgbClr val="2C3E50"/>
+                </a:solidFill>
+                <a:latin typeface="Calibri"/>
+              </a:defRPr>
+            </a:pPr>
+            <a:r>
+              <a:t>Saṃskāras from samādhi overwrite saṃskāras from ordinary experience (YS 1.50)</a:t>
             </a:r>
           </a:p>
         </p:txBody>
@@ -7485,7 +7517,7 @@
     <p:bg>
       <p:bgPr>
         <a:solidFill>
-          <a:srgbClr val="1A1A2E"/>
+          <a:srgbClr val="1E2761"/>
         </a:solidFill>
         <a:effectLst/>
       </p:bgPr>
@@ -7524,7 +7556,7 @@
                 <a:solidFill>
                   <a:srgbClr val="FFFFFF"/>
                 </a:solidFill>
-                <a:latin typeface="Helvetica"/>
+                <a:latin typeface="Georgia"/>
               </a:defRPr>
             </a:pPr>
             <a:r>

</xml_diff>

<commit_message>
Overhaul presentation generator and final deck
Complete rewrite of generate_pptx.py: widescreen 16:9, dark navy
title/section slides, left accent stripe on content slides, visual
column dividers, proper text hierarchy (bold headers, italic sub-bullets,
normal body), configurable spacing. Fonts switched to Palatino/Avenir
Next (installed on macOS). QA loop: rendered all 13 slides, fixed
hierarchy issues, verified Devanagari and CJK embedded correctly.

Co-Authored-By: Claude Opus 4.6 (1M context) <noreply@anthropic.com>
</commit_message>
<xml_diff>
--- a/docs/final_presentation.pptx
+++ b/docs/final_presentation.pptx
@@ -19,7 +19,7 @@
     <p:sldId id="267" r:id="rId19"/>
     <p:sldId id="268" r:id="rId20"/>
   </p:sldIdLst>
-  <p:sldSz cx="9144000" cy="6858000" type="screen4x3"/>
+  <p:sldSz cx="12191695" cy="6858000" type="screen4x3"/>
   <p:notesSz cx="6858000" cy="9144000"/>
   <p:defaultTextStyle>
     <a:defPPr>
@@ -515,7 +515,7 @@
           <a:p>
             <a:pPr>
               <a:defRPr sz="1100">
-                <a:latin typeface="Calibri"/>
+                <a:latin typeface="Avenir Next"/>
               </a:defRPr>
             </a:pPr>
             <a:r>
@@ -525,7 +525,7 @@
           <a:p>
             <a:pPr>
               <a:defRPr sz="1100">
-                <a:latin typeface="Calibri"/>
+                <a:latin typeface="Avenir Next"/>
               </a:defRPr>
             </a:pPr>
           </a:p>
@@ -597,7 +597,7 @@
           <a:p>
             <a:pPr>
               <a:defRPr sz="1100">
-                <a:latin typeface="Calibri"/>
+                <a:latin typeface="Avenir Next"/>
               </a:defRPr>
             </a:pPr>
             <a:r>
@@ -607,7 +607,7 @@
           <a:p>
             <a:pPr>
               <a:defRPr sz="1100">
-                <a:latin typeface="Calibri"/>
+                <a:latin typeface="Avenir Next"/>
               </a:defRPr>
             </a:pPr>
           </a:p>
@@ -679,7 +679,7 @@
           <a:p>
             <a:pPr>
               <a:defRPr sz="1100">
-                <a:latin typeface="Calibri"/>
+                <a:latin typeface="Avenir Next"/>
               </a:defRPr>
             </a:pPr>
             <a:r>
@@ -689,7 +689,7 @@
           <a:p>
             <a:pPr>
               <a:defRPr sz="1100">
-                <a:latin typeface="Calibri"/>
+                <a:latin typeface="Avenir Next"/>
               </a:defRPr>
             </a:pPr>
           </a:p>
@@ -761,7 +761,7 @@
           <a:p>
             <a:pPr>
               <a:defRPr sz="1100">
-                <a:latin typeface="Calibri"/>
+                <a:latin typeface="Avenir Next"/>
               </a:defRPr>
             </a:pPr>
             <a:r>
@@ -771,7 +771,7 @@
           <a:p>
             <a:pPr>
               <a:defRPr sz="1100">
-                <a:latin typeface="Calibri"/>
+                <a:latin typeface="Avenir Next"/>
               </a:defRPr>
             </a:pPr>
           </a:p>
@@ -843,7 +843,7 @@
           <a:p>
             <a:pPr>
               <a:defRPr sz="1100">
-                <a:latin typeface="Calibri"/>
+                <a:latin typeface="Avenir Next"/>
               </a:defRPr>
             </a:pPr>
             <a:r>
@@ -853,7 +853,7 @@
           <a:p>
             <a:pPr>
               <a:defRPr sz="1100">
-                <a:latin typeface="Calibri"/>
+                <a:latin typeface="Avenir Next"/>
               </a:defRPr>
             </a:pPr>
           </a:p>
@@ -925,7 +925,7 @@
           <a:p>
             <a:pPr>
               <a:defRPr sz="1100">
-                <a:latin typeface="Calibri"/>
+                <a:latin typeface="Avenir Next"/>
               </a:defRPr>
             </a:pPr>
             <a:r>
@@ -935,7 +935,7 @@
           <a:p>
             <a:pPr>
               <a:defRPr sz="1100">
-                <a:latin typeface="Calibri"/>
+                <a:latin typeface="Avenir Next"/>
               </a:defRPr>
             </a:pPr>
           </a:p>
@@ -1007,7 +1007,7 @@
           <a:p>
             <a:pPr>
               <a:defRPr sz="1100">
-                <a:latin typeface="Calibri"/>
+                <a:latin typeface="Avenir Next"/>
               </a:defRPr>
             </a:pPr>
             <a:r>
@@ -1017,7 +1017,7 @@
           <a:p>
             <a:pPr>
               <a:defRPr sz="1100">
-                <a:latin typeface="Calibri"/>
+                <a:latin typeface="Avenir Next"/>
               </a:defRPr>
             </a:pPr>
           </a:p>
@@ -1089,7 +1089,7 @@
           <a:p>
             <a:pPr>
               <a:defRPr sz="1100">
-                <a:latin typeface="Calibri"/>
+                <a:latin typeface="Avenir Next"/>
               </a:defRPr>
             </a:pPr>
             <a:r>
@@ -1099,7 +1099,7 @@
           <a:p>
             <a:pPr>
               <a:defRPr sz="1100">
-                <a:latin typeface="Calibri"/>
+                <a:latin typeface="Avenir Next"/>
               </a:defRPr>
             </a:pPr>
           </a:p>
@@ -1171,7 +1171,7 @@
           <a:p>
             <a:pPr>
               <a:defRPr sz="1100">
-                <a:latin typeface="Calibri"/>
+                <a:latin typeface="Avenir Next"/>
               </a:defRPr>
             </a:pPr>
             <a:r>
@@ -1181,7 +1181,7 @@
           <a:p>
             <a:pPr>
               <a:defRPr sz="1100">
-                <a:latin typeface="Calibri"/>
+                <a:latin typeface="Avenir Next"/>
               </a:defRPr>
             </a:pPr>
           </a:p>
@@ -1253,7 +1253,7 @@
           <a:p>
             <a:pPr>
               <a:defRPr sz="1100">
-                <a:latin typeface="Calibri"/>
+                <a:latin typeface="Avenir Next"/>
               </a:defRPr>
             </a:pPr>
             <a:r>
@@ -1263,7 +1263,7 @@
           <a:p>
             <a:pPr>
               <a:defRPr sz="1100">
-                <a:latin typeface="Calibri"/>
+                <a:latin typeface="Avenir Next"/>
               </a:defRPr>
             </a:pPr>
           </a:p>
@@ -1335,7 +1335,7 @@
           <a:p>
             <a:pPr>
               <a:defRPr sz="1100">
-                <a:latin typeface="Calibri"/>
+                <a:latin typeface="Avenir Next"/>
               </a:defRPr>
             </a:pPr>
             <a:r>
@@ -1345,7 +1345,7 @@
           <a:p>
             <a:pPr>
               <a:defRPr sz="1100">
-                <a:latin typeface="Calibri"/>
+                <a:latin typeface="Avenir Next"/>
               </a:defRPr>
             </a:pPr>
           </a:p>
@@ -1417,7 +1417,7 @@
           <a:p>
             <a:pPr>
               <a:defRPr sz="1100">
-                <a:latin typeface="Calibri"/>
+                <a:latin typeface="Avenir Next"/>
               </a:defRPr>
             </a:pPr>
             <a:r>
@@ -1427,7 +1427,7 @@
           <a:p>
             <a:pPr>
               <a:defRPr sz="1100">
-                <a:latin typeface="Calibri"/>
+                <a:latin typeface="Avenir Next"/>
               </a:defRPr>
             </a:pPr>
           </a:p>
@@ -1499,7 +1499,7 @@
           <a:p>
             <a:pPr>
               <a:defRPr sz="1100">
-                <a:latin typeface="Calibri"/>
+                <a:latin typeface="Avenir Next"/>
               </a:defRPr>
             </a:pPr>
             <a:r>
@@ -1509,7 +1509,7 @@
           <a:p>
             <a:pPr>
               <a:defRPr sz="1100">
-                <a:latin typeface="Calibri"/>
+                <a:latin typeface="Avenir Next"/>
               </a:defRPr>
             </a:pPr>
           </a:p>
@@ -4512,7 +4512,7 @@
     <p:bg>
       <p:bgPr>
         <a:solidFill>
-          <a:srgbClr val="F7F6F2"/>
+          <a:srgbClr val="1E2761"/>
         </a:solidFill>
         <a:effectLst/>
       </p:bgPr>
@@ -4526,14 +4526,59 @@
       <p:grpSpPr/>
       <p:sp>
         <p:nvSpPr>
-          <p:cNvPr id="2" name="TextBox 1"/>
+          <p:cNvPr id="2" name="Rounded Rectangle 1"/>
+          <p:cNvSpPr/>
+          <p:nvPr/>
+        </p:nvSpPr>
+        <p:spPr>
+          <a:xfrm>
+            <a:off x="731520" y="1645920"/>
+            <a:ext cx="2743200" cy="76200"/>
+          </a:xfrm>
+          <a:prstGeom prst="roundRect">
+            <a:avLst>
+              <a:gd name="adj" fmla="val 10000"/>
+            </a:avLst>
+          </a:prstGeom>
+          <a:solidFill>
+            <a:srgbClr val="7B2D26"/>
+          </a:solidFill>
+          <a:ln>
+            <a:noFill/>
+          </a:ln>
+        </p:spPr>
+        <p:style>
+          <a:lnRef idx="1">
+            <a:schemeClr val="accent1"/>
+          </a:lnRef>
+          <a:fillRef idx="3">
+            <a:schemeClr val="accent1"/>
+          </a:fillRef>
+          <a:effectRef idx="2">
+            <a:schemeClr val="accent1"/>
+          </a:effectRef>
+          <a:fontRef idx="minor">
+            <a:schemeClr val="lt1"/>
+          </a:fontRef>
+        </p:style>
+        <p:txBody>
+          <a:bodyPr rtlCol="0" anchor="ctr"/>
+          <a:lstStyle/>
+          <a:p>
+            <a:pPr algn="ctr"/>
+          </a:p>
+        </p:txBody>
+      </p:sp>
+      <p:sp>
+        <p:nvSpPr>
+          <p:cNvPr id="3" name="TextBox 2"/>
           <p:cNvSpPr txBox="1"/>
           <p:nvPr/>
         </p:nvSpPr>
         <p:spPr>
           <a:xfrm>
-            <a:off x="731520" y="1828800"/>
-            <a:ext cx="7680960" cy="1371600"/>
+            <a:off x="731520" y="1920240"/>
+            <a:ext cx="7680960" cy="1828800"/>
           </a:xfrm>
           <a:prstGeom prst="rect">
             <a:avLst/>
@@ -4547,11 +4592,17 @@
           <a:lstStyle/>
           <a:p>
             <a:pPr algn="l">
-              <a:defRPr sz="3600" b="1">
-                <a:solidFill>
-                  <a:srgbClr val="1E2761"/>
-                </a:solidFill>
-                <a:latin typeface="Georgia"/>
+              <a:spcBef>
+                <a:spcPts val="0"/>
+              </a:spcBef>
+              <a:spcAft>
+                <a:spcPts val="800"/>
+              </a:spcAft>
+              <a:defRPr sz="4400" b="1" i="0">
+                <a:solidFill>
+                  <a:srgbClr val="FFFFFF"/>
+                </a:solidFill>
+                <a:latin typeface="Palatino"/>
               </a:defRPr>
             </a:pPr>
             <a:r>
@@ -4562,14 +4613,14 @@
       </p:sp>
       <p:sp>
         <p:nvSpPr>
-          <p:cNvPr id="3" name="TextBox 2"/>
+          <p:cNvPr id="4" name="TextBox 3"/>
           <p:cNvSpPr txBox="1"/>
           <p:nvPr/>
         </p:nvSpPr>
         <p:spPr>
           <a:xfrm>
-            <a:off x="731520" y="3291840"/>
-            <a:ext cx="7680960" cy="914400"/>
+            <a:off x="731520" y="3840480"/>
+            <a:ext cx="7680960" cy="1097280"/>
           </a:xfrm>
           <a:prstGeom prst="rect">
             <a:avLst/>
@@ -4583,11 +4634,17 @@
           <a:lstStyle/>
           <a:p>
             <a:pPr algn="l">
-              <a:defRPr sz="1800" b="0">
-                <a:solidFill>
-                  <a:srgbClr val="2C3E50"/>
-                </a:solidFill>
-                <a:latin typeface="Calibri"/>
+              <a:spcBef>
+                <a:spcPts val="0"/>
+              </a:spcBef>
+              <a:spcAft>
+                <a:spcPts val="400"/>
+              </a:spcAft>
+              <a:defRPr sz="2000" b="0" i="0">
+                <a:solidFill>
+                  <a:srgbClr val="CADCFC"/>
+                </a:solidFill>
+                <a:latin typeface="Avenir Next"/>
               </a:defRPr>
             </a:pPr>
             <a:r>
@@ -4598,17 +4655,19 @@
       </p:sp>
       <p:sp>
         <p:nvSpPr>
-          <p:cNvPr id="4" name="Rectangle 3"/>
+          <p:cNvPr id="5" name="Rounded Rectangle 4"/>
           <p:cNvSpPr/>
           <p:nvPr/>
         </p:nvSpPr>
         <p:spPr>
           <a:xfrm>
-            <a:off x="731520" y="3108960"/>
-            <a:ext cx="1828800" cy="38100"/>
+            <a:off x="731520" y="6035040"/>
+            <a:ext cx="7680960" cy="25400"/>
           </a:xfrm>
-          <a:prstGeom prst="rect">
-            <a:avLst/>
+          <a:prstGeom prst="roundRect">
+            <a:avLst>
+              <a:gd name="adj" fmla="val 10000"/>
+            </a:avLst>
           </a:prstGeom>
           <a:solidFill>
             <a:srgbClr val="7B2D26"/>
@@ -4667,14 +4726,57 @@
       <p:grpSpPr/>
       <p:sp>
         <p:nvSpPr>
-          <p:cNvPr id="2" name="TextBox 1"/>
+          <p:cNvPr id="2" name="Rectangle 1"/>
+          <p:cNvSpPr/>
+          <p:nvPr/>
+        </p:nvSpPr>
+        <p:spPr>
+          <a:xfrm>
+            <a:off x="0" y="0"/>
+            <a:ext cx="320040" cy="6858000"/>
+          </a:xfrm>
+          <a:prstGeom prst="rect">
+            <a:avLst/>
+          </a:prstGeom>
+          <a:solidFill>
+            <a:srgbClr val="1E2761"/>
+          </a:solidFill>
+          <a:ln>
+            <a:noFill/>
+          </a:ln>
+        </p:spPr>
+        <p:style>
+          <a:lnRef idx="1">
+            <a:schemeClr val="accent1"/>
+          </a:lnRef>
+          <a:fillRef idx="3">
+            <a:schemeClr val="accent1"/>
+          </a:fillRef>
+          <a:effectRef idx="2">
+            <a:schemeClr val="accent1"/>
+          </a:effectRef>
+          <a:fontRef idx="minor">
+            <a:schemeClr val="lt1"/>
+          </a:fontRef>
+        </p:style>
+        <p:txBody>
+          <a:bodyPr rtlCol="0" anchor="ctr"/>
+          <a:lstStyle/>
+          <a:p>
+            <a:pPr algn="ctr"/>
+          </a:p>
+        </p:txBody>
+      </p:sp>
+      <p:sp>
+        <p:nvSpPr>
+          <p:cNvPr id="3" name="TextBox 2"/>
           <p:cNvSpPr txBox="1"/>
           <p:nvPr/>
         </p:nvSpPr>
         <p:spPr>
           <a:xfrm>
-            <a:off x="731520" y="457200"/>
-            <a:ext cx="7680960" cy="731520"/>
+            <a:off x="731520" y="320040"/>
+            <a:ext cx="8046720" cy="822960"/>
           </a:xfrm>
           <a:prstGeom prst="rect">
             <a:avLst/>
@@ -4688,11 +4790,17 @@
           <a:lstStyle/>
           <a:p>
             <a:pPr algn="l">
-              <a:defRPr sz="2800" b="1">
+              <a:spcBef>
+                <a:spcPts val="0"/>
+              </a:spcBef>
+              <a:spcAft>
+                <a:spcPts val="0"/>
+              </a:spcAft>
+              <a:defRPr sz="3000" b="1" i="0">
                 <a:solidFill>
                   <a:srgbClr val="1E2761"/>
                 </a:solidFill>
-                <a:latin typeface="Georgia"/>
+                <a:latin typeface="Palatino"/>
               </a:defRPr>
             </a:pPr>
             <a:r>
@@ -4703,17 +4811,19 @@
       </p:sp>
       <p:sp>
         <p:nvSpPr>
-          <p:cNvPr id="3" name="Rectangle 2"/>
+          <p:cNvPr id="4" name="Rounded Rectangle 3"/>
           <p:cNvSpPr/>
           <p:nvPr/>
         </p:nvSpPr>
         <p:spPr>
           <a:xfrm>
-            <a:off x="731520" y="1143000"/>
-            <a:ext cx="1371600" cy="25400"/>
+            <a:off x="731520" y="1188720"/>
+            <a:ext cx="1828800" cy="50800"/>
           </a:xfrm>
-          <a:prstGeom prst="rect">
-            <a:avLst/>
+          <a:prstGeom prst="roundRect">
+            <a:avLst>
+              <a:gd name="adj" fmla="val 10000"/>
+            </a:avLst>
           </a:prstGeom>
           <a:solidFill>
             <a:srgbClr val="7B2D26"/>
@@ -4746,14 +4856,57 @@
       </p:sp>
       <p:sp>
         <p:nvSpPr>
-          <p:cNvPr id="4" name="TextBox 3"/>
+          <p:cNvPr id="5" name="Rectangle 4"/>
+          <p:cNvSpPr/>
+          <p:nvPr/>
+        </p:nvSpPr>
+        <p:spPr>
+          <a:xfrm>
+            <a:off x="4434840" y="1463040"/>
+            <a:ext cx="19050" cy="4754880"/>
+          </a:xfrm>
+          <a:prstGeom prst="rect">
+            <a:avLst/>
+          </a:prstGeom>
+          <a:solidFill>
+            <a:srgbClr val="D0D0D0"/>
+          </a:solidFill>
+          <a:ln>
+            <a:noFill/>
+          </a:ln>
+        </p:spPr>
+        <p:style>
+          <a:lnRef idx="1">
+            <a:schemeClr val="accent1"/>
+          </a:lnRef>
+          <a:fillRef idx="3">
+            <a:schemeClr val="accent1"/>
+          </a:fillRef>
+          <a:effectRef idx="2">
+            <a:schemeClr val="accent1"/>
+          </a:effectRef>
+          <a:fontRef idx="minor">
+            <a:schemeClr val="lt1"/>
+          </a:fontRef>
+        </p:style>
+        <p:txBody>
+          <a:bodyPr rtlCol="0" anchor="ctr"/>
+          <a:lstStyle/>
+          <a:p>
+            <a:pPr algn="ctr"/>
+          </a:p>
+        </p:txBody>
+      </p:sp>
+      <p:sp>
+        <p:nvSpPr>
+          <p:cNvPr id="6" name="TextBox 5"/>
           <p:cNvSpPr txBox="1"/>
           <p:nvPr/>
         </p:nvSpPr>
         <p:spPr>
           <a:xfrm>
-            <a:off x="731520" y="1463040"/>
-            <a:ext cx="3657600" cy="4572000"/>
+            <a:off x="731520" y="1508760"/>
+            <a:ext cx="3566160" cy="4846320"/>
           </a:xfrm>
           <a:prstGeom prst="rect">
             <a:avLst/>
@@ -4766,15 +4919,18 @@
           </a:bodyPr>
           <a:lstStyle/>
           <a:p>
-            <a:pPr>
-              <a:spcAft>
+            <a:pPr algn="l">
+              <a:spcBef>
                 <a:spcPts val="800"/>
-              </a:spcAft>
-              <a:defRPr sz="1600">
+              </a:spcBef>
+              <a:spcAft>
+                <a:spcPts val="400"/>
+              </a:spcAft>
+              <a:defRPr sz="1800" b="0" i="0">
                 <a:solidFill>
                   <a:srgbClr val="2C3E50"/>
                 </a:solidFill>
-                <a:latin typeface="Calibri"/>
+                <a:latin typeface="Avenir Next"/>
               </a:defRPr>
             </a:pPr>
             <a:r>
@@ -4782,15 +4938,18 @@
             </a:r>
           </a:p>
           <a:p>
-            <a:pPr>
-              <a:spcAft>
+            <a:pPr algn="l">
+              <a:spcBef>
                 <a:spcPts val="800"/>
-              </a:spcAft>
-              <a:defRPr sz="1600">
+              </a:spcBef>
+              <a:spcAft>
+                <a:spcPts val="400"/>
+              </a:spcAft>
+              <a:defRPr sz="1800" b="0" i="0">
                 <a:solidFill>
                   <a:srgbClr val="2C3E50"/>
                 </a:solidFill>
-                <a:latin typeface="Calibri"/>
+                <a:latin typeface="Avenir Next"/>
               </a:defRPr>
             </a:pPr>
             <a:r>
@@ -4798,15 +4957,18 @@
             </a:r>
           </a:p>
           <a:p>
-            <a:pPr>
-              <a:spcAft>
+            <a:pPr algn="l">
+              <a:spcBef>
                 <a:spcPts val="800"/>
-              </a:spcAft>
-              <a:defRPr sz="1600">
+              </a:spcBef>
+              <a:spcAft>
+                <a:spcPts val="400"/>
+              </a:spcAft>
+              <a:defRPr sz="1800" b="0" i="0">
                 <a:solidFill>
                   <a:srgbClr val="2C3E50"/>
                 </a:solidFill>
-                <a:latin typeface="Calibri"/>
+                <a:latin typeface="Avenir Next"/>
               </a:defRPr>
             </a:pPr>
             <a:r>
@@ -4814,15 +4976,18 @@
             </a:r>
           </a:p>
           <a:p>
-            <a:pPr>
-              <a:spcAft>
+            <a:pPr algn="l">
+              <a:spcBef>
                 <a:spcPts val="800"/>
-              </a:spcAft>
-              <a:defRPr sz="1600">
+              </a:spcBef>
+              <a:spcAft>
+                <a:spcPts val="400"/>
+              </a:spcAft>
+              <a:defRPr sz="1800" b="0" i="0">
                 <a:solidFill>
                   <a:srgbClr val="2C3E50"/>
                 </a:solidFill>
-                <a:latin typeface="Calibri"/>
+                <a:latin typeface="Avenir Next"/>
               </a:defRPr>
             </a:pPr>
             <a:r>
@@ -4830,15 +4995,18 @@
             </a:r>
           </a:p>
           <a:p>
-            <a:pPr>
-              <a:spcAft>
+            <a:pPr algn="l">
+              <a:spcBef>
                 <a:spcPts val="800"/>
-              </a:spcAft>
-              <a:defRPr sz="1600">
+              </a:spcBef>
+              <a:spcAft>
+                <a:spcPts val="400"/>
+              </a:spcAft>
+              <a:defRPr sz="1800" b="0" i="0">
                 <a:solidFill>
                   <a:srgbClr val="2C3E50"/>
                 </a:solidFill>
-                <a:latin typeface="Calibri"/>
+                <a:latin typeface="Avenir Next"/>
               </a:defRPr>
             </a:pPr>
             <a:r>
@@ -4846,15 +5014,18 @@
             </a:r>
           </a:p>
           <a:p>
-            <a:pPr>
-              <a:spcAft>
+            <a:pPr algn="l">
+              <a:spcBef>
                 <a:spcPts val="800"/>
-              </a:spcAft>
-              <a:defRPr sz="1600">
+              </a:spcBef>
+              <a:spcAft>
+                <a:spcPts val="400"/>
+              </a:spcAft>
+              <a:defRPr sz="1800" b="0" i="0">
                 <a:solidFill>
                   <a:srgbClr val="2C3E50"/>
                 </a:solidFill>
-                <a:latin typeface="Calibri"/>
+                <a:latin typeface="Avenir Next"/>
               </a:defRPr>
             </a:pPr>
             <a:r>
@@ -4865,14 +5036,14 @@
       </p:sp>
       <p:sp>
         <p:nvSpPr>
-          <p:cNvPr id="5" name="TextBox 4"/>
+          <p:cNvPr id="7" name="TextBox 6"/>
           <p:cNvSpPr txBox="1"/>
           <p:nvPr/>
         </p:nvSpPr>
         <p:spPr>
           <a:xfrm>
-            <a:off x="4754880" y="1463040"/>
-            <a:ext cx="3657600" cy="4572000"/>
+            <a:off x="4663440" y="1508760"/>
+            <a:ext cx="4114800" cy="4846320"/>
           </a:xfrm>
           <a:prstGeom prst="rect">
             <a:avLst/>
@@ -4885,15 +5056,18 @@
           </a:bodyPr>
           <a:lstStyle/>
           <a:p>
-            <a:pPr>
-              <a:spcAft>
+            <a:pPr algn="l">
+              <a:spcBef>
                 <a:spcPts val="800"/>
-              </a:spcAft>
-              <a:defRPr sz="1600">
+              </a:spcBef>
+              <a:spcAft>
+                <a:spcPts val="400"/>
+              </a:spcAft>
+              <a:defRPr sz="1800" b="0" i="0">
                 <a:solidFill>
                   <a:srgbClr val="2C3E50"/>
                 </a:solidFill>
-                <a:latin typeface="Calibri"/>
+                <a:latin typeface="Avenir Next"/>
               </a:defRPr>
             </a:pPr>
             <a:r>
@@ -4901,15 +5075,18 @@
             </a:r>
           </a:p>
           <a:p>
-            <a:pPr>
-              <a:spcAft>
+            <a:pPr algn="l">
+              <a:spcBef>
                 <a:spcPts val="800"/>
-              </a:spcAft>
-              <a:defRPr sz="1600">
+              </a:spcBef>
+              <a:spcAft>
+                <a:spcPts val="400"/>
+              </a:spcAft>
+              <a:defRPr sz="1800" b="0" i="0">
                 <a:solidFill>
                   <a:srgbClr val="2C3E50"/>
                 </a:solidFill>
-                <a:latin typeface="Calibri"/>
+                <a:latin typeface="Avenir Next"/>
               </a:defRPr>
             </a:pPr>
             <a:r>
@@ -4917,15 +5094,18 @@
             </a:r>
           </a:p>
           <a:p>
-            <a:pPr>
-              <a:spcAft>
+            <a:pPr algn="l">
+              <a:spcBef>
                 <a:spcPts val="800"/>
-              </a:spcAft>
-              <a:defRPr sz="1600">
+              </a:spcBef>
+              <a:spcAft>
+                <a:spcPts val="400"/>
+              </a:spcAft>
+              <a:defRPr sz="1800" b="0" i="0">
                 <a:solidFill>
                   <a:srgbClr val="2C3E50"/>
                 </a:solidFill>
-                <a:latin typeface="Calibri"/>
+                <a:latin typeface="Avenir Next"/>
               </a:defRPr>
             </a:pPr>
             <a:r>
@@ -4933,15 +5113,18 @@
             </a:r>
           </a:p>
           <a:p>
-            <a:pPr>
-              <a:spcAft>
+            <a:pPr algn="l">
+              <a:spcBef>
                 <a:spcPts val="800"/>
-              </a:spcAft>
-              <a:defRPr sz="1600">
+              </a:spcBef>
+              <a:spcAft>
+                <a:spcPts val="400"/>
+              </a:spcAft>
+              <a:defRPr sz="1800" b="0" i="0">
                 <a:solidFill>
                   <a:srgbClr val="2C3E50"/>
                 </a:solidFill>
-                <a:latin typeface="Calibri"/>
+                <a:latin typeface="Avenir Next"/>
               </a:defRPr>
             </a:pPr>
             <a:r>
@@ -4949,15 +5132,18 @@
             </a:r>
           </a:p>
           <a:p>
-            <a:pPr>
-              <a:spcAft>
+            <a:pPr algn="l">
+              <a:spcBef>
                 <a:spcPts val="800"/>
-              </a:spcAft>
-              <a:defRPr sz="1600">
+              </a:spcBef>
+              <a:spcAft>
+                <a:spcPts val="400"/>
+              </a:spcAft>
+              <a:defRPr sz="1800" b="0" i="0">
                 <a:solidFill>
                   <a:srgbClr val="2C3E50"/>
                 </a:solidFill>
-                <a:latin typeface="Calibri"/>
+                <a:latin typeface="Avenir Next"/>
               </a:defRPr>
             </a:pPr>
             <a:r>
@@ -4994,14 +5180,57 @@
       <p:grpSpPr/>
       <p:sp>
         <p:nvSpPr>
-          <p:cNvPr id="2" name="TextBox 1"/>
+          <p:cNvPr id="2" name="Rectangle 1"/>
+          <p:cNvSpPr/>
+          <p:nvPr/>
+        </p:nvSpPr>
+        <p:spPr>
+          <a:xfrm>
+            <a:off x="0" y="0"/>
+            <a:ext cx="320040" cy="6858000"/>
+          </a:xfrm>
+          <a:prstGeom prst="rect">
+            <a:avLst/>
+          </a:prstGeom>
+          <a:solidFill>
+            <a:srgbClr val="1E2761"/>
+          </a:solidFill>
+          <a:ln>
+            <a:noFill/>
+          </a:ln>
+        </p:spPr>
+        <p:style>
+          <a:lnRef idx="1">
+            <a:schemeClr val="accent1"/>
+          </a:lnRef>
+          <a:fillRef idx="3">
+            <a:schemeClr val="accent1"/>
+          </a:fillRef>
+          <a:effectRef idx="2">
+            <a:schemeClr val="accent1"/>
+          </a:effectRef>
+          <a:fontRef idx="minor">
+            <a:schemeClr val="lt1"/>
+          </a:fontRef>
+        </p:style>
+        <p:txBody>
+          <a:bodyPr rtlCol="0" anchor="ctr"/>
+          <a:lstStyle/>
+          <a:p>
+            <a:pPr algn="ctr"/>
+          </a:p>
+        </p:txBody>
+      </p:sp>
+      <p:sp>
+        <p:nvSpPr>
+          <p:cNvPr id="3" name="TextBox 2"/>
           <p:cNvSpPr txBox="1"/>
           <p:nvPr/>
         </p:nvSpPr>
         <p:spPr>
           <a:xfrm>
-            <a:off x="731520" y="457200"/>
-            <a:ext cx="7680960" cy="731520"/>
+            <a:off x="731520" y="320040"/>
+            <a:ext cx="8046720" cy="822960"/>
           </a:xfrm>
           <a:prstGeom prst="rect">
             <a:avLst/>
@@ -5015,11 +5244,17 @@
           <a:lstStyle/>
           <a:p>
             <a:pPr algn="l">
-              <a:defRPr sz="2800" b="1">
+              <a:spcBef>
+                <a:spcPts val="0"/>
+              </a:spcBef>
+              <a:spcAft>
+                <a:spcPts val="0"/>
+              </a:spcAft>
+              <a:defRPr sz="3000" b="1" i="0">
                 <a:solidFill>
                   <a:srgbClr val="1E2761"/>
                 </a:solidFill>
-                <a:latin typeface="Georgia"/>
+                <a:latin typeface="Palatino"/>
               </a:defRPr>
             </a:pPr>
             <a:r>
@@ -5030,17 +5265,19 @@
       </p:sp>
       <p:sp>
         <p:nvSpPr>
-          <p:cNvPr id="3" name="Rectangle 2"/>
+          <p:cNvPr id="4" name="Rounded Rectangle 3"/>
           <p:cNvSpPr/>
           <p:nvPr/>
         </p:nvSpPr>
         <p:spPr>
           <a:xfrm>
-            <a:off x="731520" y="1143000"/>
-            <a:ext cx="1371600" cy="25400"/>
+            <a:off x="731520" y="1188720"/>
+            <a:ext cx="1828800" cy="50800"/>
           </a:xfrm>
-          <a:prstGeom prst="rect">
-            <a:avLst/>
+          <a:prstGeom prst="roundRect">
+            <a:avLst>
+              <a:gd name="adj" fmla="val 10000"/>
+            </a:avLst>
           </a:prstGeom>
           <a:solidFill>
             <a:srgbClr val="7B2D26"/>
@@ -5073,14 +5310,57 @@
       </p:sp>
       <p:sp>
         <p:nvSpPr>
-          <p:cNvPr id="4" name="TextBox 3"/>
+          <p:cNvPr id="5" name="Rectangle 4"/>
+          <p:cNvSpPr/>
+          <p:nvPr/>
+        </p:nvSpPr>
+        <p:spPr>
+          <a:xfrm>
+            <a:off x="4434840" y="1463040"/>
+            <a:ext cx="19050" cy="4754880"/>
+          </a:xfrm>
+          <a:prstGeom prst="rect">
+            <a:avLst/>
+          </a:prstGeom>
+          <a:solidFill>
+            <a:srgbClr val="D0D0D0"/>
+          </a:solidFill>
+          <a:ln>
+            <a:noFill/>
+          </a:ln>
+        </p:spPr>
+        <p:style>
+          <a:lnRef idx="1">
+            <a:schemeClr val="accent1"/>
+          </a:lnRef>
+          <a:fillRef idx="3">
+            <a:schemeClr val="accent1"/>
+          </a:fillRef>
+          <a:effectRef idx="2">
+            <a:schemeClr val="accent1"/>
+          </a:effectRef>
+          <a:fontRef idx="minor">
+            <a:schemeClr val="lt1"/>
+          </a:fontRef>
+        </p:style>
+        <p:txBody>
+          <a:bodyPr rtlCol="0" anchor="ctr"/>
+          <a:lstStyle/>
+          <a:p>
+            <a:pPr algn="ctr"/>
+          </a:p>
+        </p:txBody>
+      </p:sp>
+      <p:sp>
+        <p:nvSpPr>
+          <p:cNvPr id="6" name="TextBox 5"/>
           <p:cNvSpPr txBox="1"/>
           <p:nvPr/>
         </p:nvSpPr>
         <p:spPr>
           <a:xfrm>
-            <a:off x="731520" y="1463040"/>
-            <a:ext cx="3657600" cy="4572000"/>
+            <a:off x="731520" y="1508760"/>
+            <a:ext cx="3566160" cy="4846320"/>
           </a:xfrm>
           <a:prstGeom prst="rect">
             <a:avLst/>
@@ -5093,15 +5373,18 @@
           </a:bodyPr>
           <a:lstStyle/>
           <a:p>
-            <a:pPr>
-              <a:spcAft>
+            <a:pPr algn="l">
+              <a:spcBef>
                 <a:spcPts val="800"/>
-              </a:spcAft>
-              <a:defRPr sz="1600">
+              </a:spcBef>
+              <a:spcAft>
+                <a:spcPts val="400"/>
+              </a:spcAft>
+              <a:defRPr sz="1800" b="0" i="0">
                 <a:solidFill>
                   <a:srgbClr val="2C3E50"/>
                 </a:solidFill>
-                <a:latin typeface="Calibri"/>
+                <a:latin typeface="Avenir Next"/>
               </a:defRPr>
             </a:pPr>
             <a:r>
@@ -5109,15 +5392,18 @@
             </a:r>
           </a:p>
           <a:p>
-            <a:pPr>
-              <a:spcAft>
+            <a:pPr algn="l">
+              <a:spcBef>
                 <a:spcPts val="800"/>
-              </a:spcAft>
-              <a:defRPr sz="1600">
+              </a:spcBef>
+              <a:spcAft>
+                <a:spcPts val="400"/>
+              </a:spcAft>
+              <a:defRPr sz="1800" b="0" i="0">
                 <a:solidFill>
                   <a:srgbClr val="2C3E50"/>
                 </a:solidFill>
-                <a:latin typeface="Calibri"/>
+                <a:latin typeface="Avenir Next"/>
               </a:defRPr>
             </a:pPr>
             <a:r>
@@ -5125,15 +5411,18 @@
             </a:r>
           </a:p>
           <a:p>
-            <a:pPr>
-              <a:spcAft>
+            <a:pPr algn="l">
+              <a:spcBef>
                 <a:spcPts val="800"/>
-              </a:spcAft>
-              <a:defRPr sz="1600">
+              </a:spcBef>
+              <a:spcAft>
+                <a:spcPts val="400"/>
+              </a:spcAft>
+              <a:defRPr sz="1800" b="0" i="0">
                 <a:solidFill>
                   <a:srgbClr val="2C3E50"/>
                 </a:solidFill>
-                <a:latin typeface="Calibri"/>
+                <a:latin typeface="Avenir Next"/>
               </a:defRPr>
             </a:pPr>
             <a:r>
@@ -5141,15 +5430,18 @@
             </a:r>
           </a:p>
           <a:p>
-            <a:pPr>
-              <a:spcAft>
+            <a:pPr algn="l">
+              <a:spcBef>
                 <a:spcPts val="800"/>
-              </a:spcAft>
-              <a:defRPr sz="1600">
+              </a:spcBef>
+              <a:spcAft>
+                <a:spcPts val="400"/>
+              </a:spcAft>
+              <a:defRPr sz="1800" b="0" i="0">
                 <a:solidFill>
                   <a:srgbClr val="2C3E50"/>
                 </a:solidFill>
-                <a:latin typeface="Calibri"/>
+                <a:latin typeface="Avenir Next"/>
               </a:defRPr>
             </a:pPr>
             <a:r>
@@ -5157,15 +5449,18 @@
             </a:r>
           </a:p>
           <a:p>
-            <a:pPr>
-              <a:spcAft>
+            <a:pPr algn="l">
+              <a:spcBef>
                 <a:spcPts val="800"/>
-              </a:spcAft>
-              <a:defRPr sz="1600">
+              </a:spcBef>
+              <a:spcAft>
+                <a:spcPts val="400"/>
+              </a:spcAft>
+              <a:defRPr sz="1800" b="0" i="0">
                 <a:solidFill>
                   <a:srgbClr val="2C3E50"/>
                 </a:solidFill>
-                <a:latin typeface="Calibri"/>
+                <a:latin typeface="Avenir Next"/>
               </a:defRPr>
             </a:pPr>
             <a:r>
@@ -5176,14 +5471,14 @@
       </p:sp>
       <p:sp>
         <p:nvSpPr>
-          <p:cNvPr id="5" name="TextBox 4"/>
+          <p:cNvPr id="7" name="TextBox 6"/>
           <p:cNvSpPr txBox="1"/>
           <p:nvPr/>
         </p:nvSpPr>
         <p:spPr>
           <a:xfrm>
-            <a:off x="4754880" y="1463040"/>
-            <a:ext cx="3657600" cy="4572000"/>
+            <a:off x="4663440" y="1508760"/>
+            <a:ext cx="4114800" cy="4846320"/>
           </a:xfrm>
           <a:prstGeom prst="rect">
             <a:avLst/>
@@ -5196,15 +5491,18 @@
           </a:bodyPr>
           <a:lstStyle/>
           <a:p>
-            <a:pPr>
-              <a:spcAft>
+            <a:pPr algn="l">
+              <a:spcBef>
                 <a:spcPts val="800"/>
-              </a:spcAft>
-              <a:defRPr sz="1600">
+              </a:spcBef>
+              <a:spcAft>
+                <a:spcPts val="400"/>
+              </a:spcAft>
+              <a:defRPr sz="1800" b="0" i="0">
                 <a:solidFill>
                   <a:srgbClr val="2C3E50"/>
                 </a:solidFill>
-                <a:latin typeface="Calibri"/>
+                <a:latin typeface="Avenir Next"/>
               </a:defRPr>
             </a:pPr>
             <a:r>
@@ -5212,15 +5510,18 @@
             </a:r>
           </a:p>
           <a:p>
-            <a:pPr>
-              <a:spcAft>
+            <a:pPr algn="l">
+              <a:spcBef>
                 <a:spcPts val="800"/>
-              </a:spcAft>
-              <a:defRPr sz="1600">
+              </a:spcBef>
+              <a:spcAft>
+                <a:spcPts val="400"/>
+              </a:spcAft>
+              <a:defRPr sz="1800" b="0" i="0">
                 <a:solidFill>
                   <a:srgbClr val="2C3E50"/>
                 </a:solidFill>
-                <a:latin typeface="Calibri"/>
+                <a:latin typeface="Avenir Next"/>
               </a:defRPr>
             </a:pPr>
             <a:r>
@@ -5228,15 +5529,18 @@
             </a:r>
           </a:p>
           <a:p>
-            <a:pPr>
-              <a:spcAft>
+            <a:pPr algn="l">
+              <a:spcBef>
                 <a:spcPts val="800"/>
-              </a:spcAft>
-              <a:defRPr sz="1600">
+              </a:spcBef>
+              <a:spcAft>
+                <a:spcPts val="400"/>
+              </a:spcAft>
+              <a:defRPr sz="1800" b="0" i="0">
                 <a:solidFill>
                   <a:srgbClr val="2C3E50"/>
                 </a:solidFill>
-                <a:latin typeface="Calibri"/>
+                <a:latin typeface="Avenir Next"/>
               </a:defRPr>
             </a:pPr>
             <a:r>
@@ -5244,15 +5548,18 @@
             </a:r>
           </a:p>
           <a:p>
-            <a:pPr>
-              <a:spcAft>
+            <a:pPr algn="l">
+              <a:spcBef>
                 <a:spcPts val="800"/>
-              </a:spcAft>
-              <a:defRPr sz="1600">
+              </a:spcBef>
+              <a:spcAft>
+                <a:spcPts val="400"/>
+              </a:spcAft>
+              <a:defRPr sz="1800" b="0" i="0">
                 <a:solidFill>
                   <a:srgbClr val="2C3E50"/>
                 </a:solidFill>
-                <a:latin typeface="Calibri"/>
+                <a:latin typeface="Avenir Next"/>
               </a:defRPr>
             </a:pPr>
             <a:r>
@@ -5260,15 +5567,18 @@
             </a:r>
           </a:p>
           <a:p>
-            <a:pPr>
-              <a:spcAft>
+            <a:pPr algn="l">
+              <a:spcBef>
                 <a:spcPts val="800"/>
-              </a:spcAft>
-              <a:defRPr sz="1600">
+              </a:spcBef>
+              <a:spcAft>
+                <a:spcPts val="400"/>
+              </a:spcAft>
+              <a:defRPr sz="1800" b="0" i="0">
                 <a:solidFill>
                   <a:srgbClr val="2C3E50"/>
                 </a:solidFill>
-                <a:latin typeface="Calibri"/>
+                <a:latin typeface="Avenir Next"/>
               </a:defRPr>
             </a:pPr>
             <a:r>
@@ -5305,14 +5615,57 @@
       <p:grpSpPr/>
       <p:sp>
         <p:nvSpPr>
-          <p:cNvPr id="2" name="TextBox 1"/>
+          <p:cNvPr id="2" name="Rectangle 1"/>
+          <p:cNvSpPr/>
+          <p:nvPr/>
+        </p:nvSpPr>
+        <p:spPr>
+          <a:xfrm>
+            <a:off x="0" y="0"/>
+            <a:ext cx="320040" cy="6858000"/>
+          </a:xfrm>
+          <a:prstGeom prst="rect">
+            <a:avLst/>
+          </a:prstGeom>
+          <a:solidFill>
+            <a:srgbClr val="1E2761"/>
+          </a:solidFill>
+          <a:ln>
+            <a:noFill/>
+          </a:ln>
+        </p:spPr>
+        <p:style>
+          <a:lnRef idx="1">
+            <a:schemeClr val="accent1"/>
+          </a:lnRef>
+          <a:fillRef idx="3">
+            <a:schemeClr val="accent1"/>
+          </a:fillRef>
+          <a:effectRef idx="2">
+            <a:schemeClr val="accent1"/>
+          </a:effectRef>
+          <a:fontRef idx="minor">
+            <a:schemeClr val="lt1"/>
+          </a:fontRef>
+        </p:style>
+        <p:txBody>
+          <a:bodyPr rtlCol="0" anchor="ctr"/>
+          <a:lstStyle/>
+          <a:p>
+            <a:pPr algn="ctr"/>
+          </a:p>
+        </p:txBody>
+      </p:sp>
+      <p:sp>
+        <p:nvSpPr>
+          <p:cNvPr id="3" name="TextBox 2"/>
           <p:cNvSpPr txBox="1"/>
           <p:nvPr/>
         </p:nvSpPr>
         <p:spPr>
           <a:xfrm>
-            <a:off x="731520" y="457200"/>
-            <a:ext cx="7680960" cy="731520"/>
+            <a:off x="731520" y="320040"/>
+            <a:ext cx="8046720" cy="822960"/>
           </a:xfrm>
           <a:prstGeom prst="rect">
             <a:avLst/>
@@ -5326,11 +5679,17 @@
           <a:lstStyle/>
           <a:p>
             <a:pPr algn="l">
-              <a:defRPr sz="2800" b="1">
+              <a:spcBef>
+                <a:spcPts val="0"/>
+              </a:spcBef>
+              <a:spcAft>
+                <a:spcPts val="0"/>
+              </a:spcAft>
+              <a:defRPr sz="3000" b="1" i="0">
                 <a:solidFill>
                   <a:srgbClr val="1E2761"/>
                 </a:solidFill>
-                <a:latin typeface="Georgia"/>
+                <a:latin typeface="Palatino"/>
               </a:defRPr>
             </a:pPr>
             <a:r>
@@ -5341,17 +5700,19 @@
       </p:sp>
       <p:sp>
         <p:nvSpPr>
-          <p:cNvPr id="3" name="Rectangle 2"/>
+          <p:cNvPr id="4" name="Rounded Rectangle 3"/>
           <p:cNvSpPr/>
           <p:nvPr/>
         </p:nvSpPr>
         <p:spPr>
           <a:xfrm>
-            <a:off x="731520" y="1143000"/>
-            <a:ext cx="1371600" cy="25400"/>
+            <a:off x="731520" y="1188720"/>
+            <a:ext cx="1828800" cy="50800"/>
           </a:xfrm>
-          <a:prstGeom prst="rect">
-            <a:avLst/>
+          <a:prstGeom prst="roundRect">
+            <a:avLst>
+              <a:gd name="adj" fmla="val 10000"/>
+            </a:avLst>
           </a:prstGeom>
           <a:solidFill>
             <a:srgbClr val="7B2D26"/>
@@ -5384,14 +5745,57 @@
       </p:sp>
       <p:sp>
         <p:nvSpPr>
-          <p:cNvPr id="4" name="TextBox 3"/>
+          <p:cNvPr id="5" name="Rectangle 4"/>
+          <p:cNvSpPr/>
+          <p:nvPr/>
+        </p:nvSpPr>
+        <p:spPr>
+          <a:xfrm>
+            <a:off x="4434840" y="1463040"/>
+            <a:ext cx="19050" cy="4754880"/>
+          </a:xfrm>
+          <a:prstGeom prst="rect">
+            <a:avLst/>
+          </a:prstGeom>
+          <a:solidFill>
+            <a:srgbClr val="D0D0D0"/>
+          </a:solidFill>
+          <a:ln>
+            <a:noFill/>
+          </a:ln>
+        </p:spPr>
+        <p:style>
+          <a:lnRef idx="1">
+            <a:schemeClr val="accent1"/>
+          </a:lnRef>
+          <a:fillRef idx="3">
+            <a:schemeClr val="accent1"/>
+          </a:fillRef>
+          <a:effectRef idx="2">
+            <a:schemeClr val="accent1"/>
+          </a:effectRef>
+          <a:fontRef idx="minor">
+            <a:schemeClr val="lt1"/>
+          </a:fontRef>
+        </p:style>
+        <p:txBody>
+          <a:bodyPr rtlCol="0" anchor="ctr"/>
+          <a:lstStyle/>
+          <a:p>
+            <a:pPr algn="ctr"/>
+          </a:p>
+        </p:txBody>
+      </p:sp>
+      <p:sp>
+        <p:nvSpPr>
+          <p:cNvPr id="6" name="TextBox 5"/>
           <p:cNvSpPr txBox="1"/>
           <p:nvPr/>
         </p:nvSpPr>
         <p:spPr>
           <a:xfrm>
-            <a:off x="731520" y="1463040"/>
-            <a:ext cx="3657600" cy="4572000"/>
+            <a:off x="731520" y="1508760"/>
+            <a:ext cx="3566160" cy="4846320"/>
           </a:xfrm>
           <a:prstGeom prst="rect">
             <a:avLst/>
@@ -5404,15 +5808,18 @@
           </a:bodyPr>
           <a:lstStyle/>
           <a:p>
-            <a:pPr>
-              <a:spcAft>
+            <a:pPr algn="l">
+              <a:spcBef>
                 <a:spcPts val="800"/>
-              </a:spcAft>
-              <a:defRPr sz="1600">
+              </a:spcBef>
+              <a:spcAft>
+                <a:spcPts val="400"/>
+              </a:spcAft>
+              <a:defRPr sz="1800" b="0" i="0">
                 <a:solidFill>
                   <a:srgbClr val="2C3E50"/>
                 </a:solidFill>
-                <a:latin typeface="Calibri"/>
+                <a:latin typeface="Avenir Next"/>
               </a:defRPr>
             </a:pPr>
             <a:r>
@@ -5420,15 +5827,18 @@
             </a:r>
           </a:p>
           <a:p>
-            <a:pPr>
-              <a:spcAft>
+            <a:pPr algn="l">
+              <a:spcBef>
                 <a:spcPts val="800"/>
-              </a:spcAft>
-              <a:defRPr sz="1600">
+              </a:spcBef>
+              <a:spcAft>
+                <a:spcPts val="400"/>
+              </a:spcAft>
+              <a:defRPr sz="1800" b="0" i="0">
                 <a:solidFill>
                   <a:srgbClr val="2C3E50"/>
                 </a:solidFill>
-                <a:latin typeface="Calibri"/>
+                <a:latin typeface="Avenir Next"/>
               </a:defRPr>
             </a:pPr>
             <a:r>
@@ -5436,15 +5846,18 @@
             </a:r>
           </a:p>
           <a:p>
-            <a:pPr>
-              <a:spcAft>
+            <a:pPr algn="l">
+              <a:spcBef>
                 <a:spcPts val="800"/>
-              </a:spcAft>
-              <a:defRPr sz="1600">
+              </a:spcBef>
+              <a:spcAft>
+                <a:spcPts val="400"/>
+              </a:spcAft>
+              <a:defRPr sz="1800" b="0" i="0">
                 <a:solidFill>
                   <a:srgbClr val="2C3E50"/>
                 </a:solidFill>
-                <a:latin typeface="Calibri"/>
+                <a:latin typeface="Avenir Next"/>
               </a:defRPr>
             </a:pPr>
             <a:r>
@@ -5452,15 +5865,18 @@
             </a:r>
           </a:p>
           <a:p>
-            <a:pPr>
-              <a:spcAft>
+            <a:pPr algn="l">
+              <a:spcBef>
                 <a:spcPts val="800"/>
-              </a:spcAft>
-              <a:defRPr sz="1600">
+              </a:spcBef>
+              <a:spcAft>
+                <a:spcPts val="400"/>
+              </a:spcAft>
+              <a:defRPr sz="1800" b="0" i="0">
                 <a:solidFill>
                   <a:srgbClr val="2C3E50"/>
                 </a:solidFill>
-                <a:latin typeface="Calibri"/>
+                <a:latin typeface="Avenir Next"/>
               </a:defRPr>
             </a:pPr>
             <a:r>
@@ -5471,14 +5887,14 @@
       </p:sp>
       <p:sp>
         <p:nvSpPr>
-          <p:cNvPr id="5" name="TextBox 4"/>
+          <p:cNvPr id="7" name="TextBox 6"/>
           <p:cNvSpPr txBox="1"/>
           <p:nvPr/>
         </p:nvSpPr>
         <p:spPr>
           <a:xfrm>
-            <a:off x="4754880" y="1463040"/>
-            <a:ext cx="3657600" cy="4572000"/>
+            <a:off x="4663440" y="1508760"/>
+            <a:ext cx="4114800" cy="4846320"/>
           </a:xfrm>
           <a:prstGeom prst="rect">
             <a:avLst/>
@@ -5491,15 +5907,18 @@
           </a:bodyPr>
           <a:lstStyle/>
           <a:p>
-            <a:pPr>
-              <a:spcAft>
+            <a:pPr algn="l">
+              <a:spcBef>
                 <a:spcPts val="800"/>
-              </a:spcAft>
-              <a:defRPr sz="1600">
+              </a:spcBef>
+              <a:spcAft>
+                <a:spcPts val="400"/>
+              </a:spcAft>
+              <a:defRPr sz="1800" b="0" i="0">
                 <a:solidFill>
                   <a:srgbClr val="2C3E50"/>
                 </a:solidFill>
-                <a:latin typeface="Calibri"/>
+                <a:latin typeface="Avenir Next"/>
               </a:defRPr>
             </a:pPr>
             <a:r>
@@ -5507,15 +5926,18 @@
             </a:r>
           </a:p>
           <a:p>
-            <a:pPr>
-              <a:spcAft>
+            <a:pPr algn="l">
+              <a:spcBef>
                 <a:spcPts val="800"/>
-              </a:spcAft>
-              <a:defRPr sz="1600">
+              </a:spcBef>
+              <a:spcAft>
+                <a:spcPts val="400"/>
+              </a:spcAft>
+              <a:defRPr sz="1800" b="0" i="0">
                 <a:solidFill>
                   <a:srgbClr val="2C3E50"/>
                 </a:solidFill>
-                <a:latin typeface="Calibri"/>
+                <a:latin typeface="Avenir Next"/>
               </a:defRPr>
             </a:pPr>
             <a:r>
@@ -5523,15 +5945,18 @@
             </a:r>
           </a:p>
           <a:p>
-            <a:pPr>
-              <a:spcAft>
+            <a:pPr algn="l">
+              <a:spcBef>
                 <a:spcPts val="800"/>
-              </a:spcAft>
-              <a:defRPr sz="1600">
+              </a:spcBef>
+              <a:spcAft>
+                <a:spcPts val="400"/>
+              </a:spcAft>
+              <a:defRPr sz="1800" b="0" i="0">
                 <a:solidFill>
                   <a:srgbClr val="2C3E50"/>
                 </a:solidFill>
-                <a:latin typeface="Calibri"/>
+                <a:latin typeface="Avenir Next"/>
               </a:defRPr>
             </a:pPr>
             <a:r>
@@ -5539,15 +5964,18 @@
             </a:r>
           </a:p>
           <a:p>
-            <a:pPr>
-              <a:spcAft>
+            <a:pPr algn="l">
+              <a:spcBef>
                 <a:spcPts val="800"/>
-              </a:spcAft>
-              <a:defRPr sz="1600">
+              </a:spcBef>
+              <a:spcAft>
+                <a:spcPts val="400"/>
+              </a:spcAft>
+              <a:defRPr sz="1800" b="0" i="0">
                 <a:solidFill>
                   <a:srgbClr val="2C3E50"/>
                 </a:solidFill>
-                <a:latin typeface="Calibri"/>
+                <a:latin typeface="Avenir Next"/>
               </a:defRPr>
             </a:pPr>
             <a:r>
@@ -5584,14 +6012,57 @@
       <p:grpSpPr/>
       <p:sp>
         <p:nvSpPr>
-          <p:cNvPr id="2" name="TextBox 1"/>
+          <p:cNvPr id="2" name="Rectangle 1"/>
+          <p:cNvSpPr/>
+          <p:nvPr/>
+        </p:nvSpPr>
+        <p:spPr>
+          <a:xfrm>
+            <a:off x="0" y="0"/>
+            <a:ext cx="320040" cy="6858000"/>
+          </a:xfrm>
+          <a:prstGeom prst="rect">
+            <a:avLst/>
+          </a:prstGeom>
+          <a:solidFill>
+            <a:srgbClr val="1E2761"/>
+          </a:solidFill>
+          <a:ln>
+            <a:noFill/>
+          </a:ln>
+        </p:spPr>
+        <p:style>
+          <a:lnRef idx="1">
+            <a:schemeClr val="accent1"/>
+          </a:lnRef>
+          <a:fillRef idx="3">
+            <a:schemeClr val="accent1"/>
+          </a:fillRef>
+          <a:effectRef idx="2">
+            <a:schemeClr val="accent1"/>
+          </a:effectRef>
+          <a:fontRef idx="minor">
+            <a:schemeClr val="lt1"/>
+          </a:fontRef>
+        </p:style>
+        <p:txBody>
+          <a:bodyPr rtlCol="0" anchor="ctr"/>
+          <a:lstStyle/>
+          <a:p>
+            <a:pPr algn="ctr"/>
+          </a:p>
+        </p:txBody>
+      </p:sp>
+      <p:sp>
+        <p:nvSpPr>
+          <p:cNvPr id="3" name="TextBox 2"/>
           <p:cNvSpPr txBox="1"/>
           <p:nvPr/>
         </p:nvSpPr>
         <p:spPr>
           <a:xfrm>
-            <a:off x="731520" y="457200"/>
-            <a:ext cx="7680960" cy="731520"/>
+            <a:off x="731520" y="320040"/>
+            <a:ext cx="8046720" cy="822960"/>
           </a:xfrm>
           <a:prstGeom prst="rect">
             <a:avLst/>
@@ -5605,11 +6076,17 @@
           <a:lstStyle/>
           <a:p>
             <a:pPr algn="l">
-              <a:defRPr sz="2800" b="1">
+              <a:spcBef>
+                <a:spcPts val="0"/>
+              </a:spcBef>
+              <a:spcAft>
+                <a:spcPts val="0"/>
+              </a:spcAft>
+              <a:defRPr sz="3200" b="1" i="0">
                 <a:solidFill>
                   <a:srgbClr val="1E2761"/>
                 </a:solidFill>
-                <a:latin typeface="Georgia"/>
+                <a:latin typeface="Palatino"/>
               </a:defRPr>
             </a:pPr>
             <a:r>
@@ -5620,17 +6097,19 @@
       </p:sp>
       <p:sp>
         <p:nvSpPr>
-          <p:cNvPr id="3" name="Rectangle 2"/>
+          <p:cNvPr id="4" name="Rounded Rectangle 3"/>
           <p:cNvSpPr/>
           <p:nvPr/>
         </p:nvSpPr>
         <p:spPr>
           <a:xfrm>
-            <a:off x="731520" y="1143000"/>
-            <a:ext cx="1371600" cy="25400"/>
+            <a:off x="731520" y="1188720"/>
+            <a:ext cx="1828800" cy="50800"/>
           </a:xfrm>
-          <a:prstGeom prst="rect">
-            <a:avLst/>
+          <a:prstGeom prst="roundRect">
+            <a:avLst>
+              <a:gd name="adj" fmla="val 10000"/>
+            </a:avLst>
           </a:prstGeom>
           <a:solidFill>
             <a:srgbClr val="7B2D26"/>
@@ -5663,14 +6142,14 @@
       </p:sp>
       <p:sp>
         <p:nvSpPr>
-          <p:cNvPr id="4" name="TextBox 3"/>
+          <p:cNvPr id="5" name="TextBox 4"/>
           <p:cNvSpPr txBox="1"/>
           <p:nvPr/>
         </p:nvSpPr>
         <p:spPr>
           <a:xfrm>
-            <a:off x="731520" y="1463040"/>
-            <a:ext cx="7680960" cy="4572000"/>
+            <a:off x="731520" y="1554480"/>
+            <a:ext cx="7863840" cy="4754880"/>
           </a:xfrm>
           <a:prstGeom prst="rect">
             <a:avLst/>
@@ -5683,15 +6162,18 @@
           </a:bodyPr>
           <a:lstStyle/>
           <a:p>
-            <a:pPr>
-              <a:spcAft>
-                <a:spcPts val="800"/>
-              </a:spcAft>
-              <a:defRPr sz="1800">
+            <a:pPr algn="l">
+              <a:spcBef>
+                <a:spcPts val="1600"/>
+              </a:spcBef>
+              <a:spcAft>
+                <a:spcPts val="400"/>
+              </a:spcAft>
+              <a:defRPr sz="2000" b="1" i="0">
                 <a:solidFill>
                   <a:srgbClr val="2C3E50"/>
                 </a:solidFill>
-                <a:latin typeface="Calibri"/>
+                <a:latin typeface="Avenir Next"/>
               </a:defRPr>
             </a:pPr>
             <a:r>
@@ -5699,31 +6181,37 @@
             </a:r>
           </a:p>
           <a:p>
-            <a:pPr>
-              <a:spcAft>
-                <a:spcPts val="800"/>
-              </a:spcAft>
-              <a:defRPr sz="1800">
+            <a:pPr algn="l">
+              <a:spcBef>
+                <a:spcPts val="200"/>
+              </a:spcBef>
+              <a:spcAft>
+                <a:spcPts val="600"/>
+              </a:spcAft>
+              <a:defRPr sz="1800" b="0" i="1">
                 <a:solidFill>
                   <a:srgbClr val="2C3E50"/>
                 </a:solidFill>
-                <a:latin typeface="Calibri"/>
-              </a:defRPr>
-            </a:pPr>
-            <a:r>
-              <a:t>Roots and prefixes compress arguments about what concepts mean</a:t>
-            </a:r>
-          </a:p>
-          <a:p>
-            <a:pPr>
-              <a:spcAft>
-                <a:spcPts val="800"/>
-              </a:spcAft>
-              <a:defRPr sz="1800">
+                <a:latin typeface="Avenir Next"/>
+              </a:defRPr>
+            </a:pPr>
+            <a:r>
+              <a:t>     Roots and prefixes compress arguments about what concepts mean</a:t>
+            </a:r>
+          </a:p>
+          <a:p>
+            <a:pPr algn="l">
+              <a:spcBef>
+                <a:spcPts val="1600"/>
+              </a:spcBef>
+              <a:spcAft>
+                <a:spcPts val="400"/>
+              </a:spcAft>
+              <a:defRPr sz="2000" b="1" i="0">
                 <a:solidFill>
                   <a:srgbClr val="2C3E50"/>
                 </a:solidFill>
-                <a:latin typeface="Calibri"/>
+                <a:latin typeface="Avenir Next"/>
               </a:defRPr>
             </a:pPr>
             <a:r>
@@ -5731,31 +6219,37 @@
             </a:r>
           </a:p>
           <a:p>
-            <a:pPr>
-              <a:spcAft>
-                <a:spcPts val="800"/>
-              </a:spcAft>
-              <a:defRPr sz="1800">
+            <a:pPr algn="l">
+              <a:spcBef>
+                <a:spcPts val="200"/>
+              </a:spcBef>
+              <a:spcAft>
+                <a:spcPts val="600"/>
+              </a:spcAft>
+              <a:defRPr sz="1800" b="0" i="1">
                 <a:solidFill>
                   <a:srgbClr val="2C3E50"/>
                 </a:solidFill>
-                <a:latin typeface="Calibri"/>
-              </a:defRPr>
-            </a:pPr>
-            <a:r>
-              <a:t>Sound vs. meaning, darkness vs. ignorance, extinction vs. restraint</a:t>
-            </a:r>
-          </a:p>
-          <a:p>
-            <a:pPr>
-              <a:spcAft>
-                <a:spcPts val="800"/>
-              </a:spcAft>
-              <a:defRPr sz="1800">
+                <a:latin typeface="Avenir Next"/>
+              </a:defRPr>
+            </a:pPr>
+            <a:r>
+              <a:t>     Sound vs. meaning, darkness vs. ignorance, extinction vs. restraint</a:t>
+            </a:r>
+          </a:p>
+          <a:p>
+            <a:pPr algn="l">
+              <a:spcBef>
+                <a:spcPts val="1600"/>
+              </a:spcBef>
+              <a:spcAft>
+                <a:spcPts val="400"/>
+              </a:spcAft>
+              <a:defRPr sz="2000" b="1" i="0">
                 <a:solidFill>
                   <a:srgbClr val="2C3E50"/>
                 </a:solidFill>
-                <a:latin typeface="Calibri"/>
+                <a:latin typeface="Avenir Next"/>
               </a:defRPr>
             </a:pPr>
             <a:r>
@@ -5763,31 +6257,37 @@
             </a:r>
           </a:p>
           <a:p>
-            <a:pPr>
-              <a:spcAft>
-                <a:spcPts val="800"/>
-              </a:spcAft>
-              <a:defRPr sz="1800">
+            <a:pPr algn="l">
+              <a:spcBef>
+                <a:spcPts val="200"/>
+              </a:spcBef>
+              <a:spcAft>
+                <a:spcPts val="600"/>
+              </a:spcAft>
+              <a:defRPr sz="1800" b="0" i="1">
                 <a:solidFill>
                   <a:srgbClr val="2C3E50"/>
                 </a:solidFill>
-                <a:latin typeface="Calibri"/>
-              </a:defRPr>
-            </a:pPr>
-            <a:r>
-              <a:t>dhyana to zen is rock-solid; the Yoga Sutras' vocabulary has no Chinese equivalent</a:t>
-            </a:r>
-          </a:p>
-          <a:p>
-            <a:pPr>
-              <a:spcAft>
-                <a:spcPts val="800"/>
-              </a:spcAft>
-              <a:defRPr sz="1800">
+                <a:latin typeface="Avenir Next"/>
+              </a:defRPr>
+            </a:pPr>
+            <a:r>
+              <a:t>     dhyāna → zen is rock-solid; the Yoga Sutras' vocabulary has no Chinese equivalent</a:t>
+            </a:r>
+          </a:p>
+          <a:p>
+            <a:pPr algn="l">
+              <a:spcBef>
+                <a:spcPts val="1600"/>
+              </a:spcBef>
+              <a:spcAft>
+                <a:spcPts val="400"/>
+              </a:spcAft>
+              <a:defRPr sz="2000" b="1" i="0">
                 <a:solidFill>
                   <a:srgbClr val="2C3E50"/>
                 </a:solidFill>
-                <a:latin typeface="Calibri"/>
+                <a:latin typeface="Avenir Next"/>
               </a:defRPr>
             </a:pPr>
             <a:r>
@@ -5824,14 +6324,57 @@
       <p:grpSpPr/>
       <p:sp>
         <p:nvSpPr>
-          <p:cNvPr id="2" name="TextBox 1"/>
+          <p:cNvPr id="2" name="Rectangle 1"/>
+          <p:cNvSpPr/>
+          <p:nvPr/>
+        </p:nvSpPr>
+        <p:spPr>
+          <a:xfrm>
+            <a:off x="0" y="0"/>
+            <a:ext cx="320040" cy="6858000"/>
+          </a:xfrm>
+          <a:prstGeom prst="rect">
+            <a:avLst/>
+          </a:prstGeom>
+          <a:solidFill>
+            <a:srgbClr val="1E2761"/>
+          </a:solidFill>
+          <a:ln>
+            <a:noFill/>
+          </a:ln>
+        </p:spPr>
+        <p:style>
+          <a:lnRef idx="1">
+            <a:schemeClr val="accent1"/>
+          </a:lnRef>
+          <a:fillRef idx="3">
+            <a:schemeClr val="accent1"/>
+          </a:fillRef>
+          <a:effectRef idx="2">
+            <a:schemeClr val="accent1"/>
+          </a:effectRef>
+          <a:fontRef idx="minor">
+            <a:schemeClr val="lt1"/>
+          </a:fontRef>
+        </p:style>
+        <p:txBody>
+          <a:bodyPr rtlCol="0" anchor="ctr"/>
+          <a:lstStyle/>
+          <a:p>
+            <a:pPr algn="ctr"/>
+          </a:p>
+        </p:txBody>
+      </p:sp>
+      <p:sp>
+        <p:nvSpPr>
+          <p:cNvPr id="3" name="TextBox 2"/>
           <p:cNvSpPr txBox="1"/>
           <p:nvPr/>
         </p:nvSpPr>
         <p:spPr>
           <a:xfrm>
-            <a:off x="731520" y="457200"/>
-            <a:ext cx="7680960" cy="731520"/>
+            <a:off x="731520" y="320040"/>
+            <a:ext cx="8046720" cy="822960"/>
           </a:xfrm>
           <a:prstGeom prst="rect">
             <a:avLst/>
@@ -5845,11 +6388,17 @@
           <a:lstStyle/>
           <a:p>
             <a:pPr algn="l">
-              <a:defRPr sz="2800" b="1">
+              <a:spcBef>
+                <a:spcPts val="0"/>
+              </a:spcBef>
+              <a:spcAft>
+                <a:spcPts val="0"/>
+              </a:spcAft>
+              <a:defRPr sz="3200" b="1" i="0">
                 <a:solidFill>
                   <a:srgbClr val="1E2761"/>
                 </a:solidFill>
-                <a:latin typeface="Georgia"/>
+                <a:latin typeface="Palatino"/>
               </a:defRPr>
             </a:pPr>
             <a:r>
@@ -5860,17 +6409,19 @@
       </p:sp>
       <p:sp>
         <p:nvSpPr>
-          <p:cNvPr id="3" name="Rectangle 2"/>
+          <p:cNvPr id="4" name="Rounded Rectangle 3"/>
           <p:cNvSpPr/>
           <p:nvPr/>
         </p:nvSpPr>
         <p:spPr>
           <a:xfrm>
-            <a:off x="731520" y="1143000"/>
-            <a:ext cx="1371600" cy="25400"/>
+            <a:off x="731520" y="1188720"/>
+            <a:ext cx="1828800" cy="50800"/>
           </a:xfrm>
-          <a:prstGeom prst="rect">
-            <a:avLst/>
+          <a:prstGeom prst="roundRect">
+            <a:avLst>
+              <a:gd name="adj" fmla="val 10000"/>
+            </a:avLst>
           </a:prstGeom>
           <a:solidFill>
             <a:srgbClr val="7B2D26"/>
@@ -5903,14 +6454,14 @@
       </p:sp>
       <p:sp>
         <p:nvSpPr>
-          <p:cNvPr id="4" name="TextBox 3"/>
+          <p:cNvPr id="5" name="TextBox 4"/>
           <p:cNvSpPr txBox="1"/>
           <p:nvPr/>
         </p:nvSpPr>
         <p:spPr>
           <a:xfrm>
-            <a:off x="731520" y="1463040"/>
-            <a:ext cx="7680960" cy="4572000"/>
+            <a:off x="731520" y="1554480"/>
+            <a:ext cx="7863840" cy="4754880"/>
           </a:xfrm>
           <a:prstGeom prst="rect">
             <a:avLst/>
@@ -5923,15 +6474,18 @@
           </a:bodyPr>
           <a:lstStyle/>
           <a:p>
-            <a:pPr>
-              <a:spcAft>
+            <a:pPr algn="l">
+              <a:spcBef>
                 <a:spcPts val="800"/>
-              </a:spcAft>
-              <a:defRPr sz="1800">
+              </a:spcBef>
+              <a:spcAft>
+                <a:spcPts val="400"/>
+              </a:spcAft>
+              <a:defRPr sz="2000" b="0" i="0">
                 <a:solidFill>
                   <a:srgbClr val="2C3E50"/>
                 </a:solidFill>
-                <a:latin typeface="Calibri"/>
+                <a:latin typeface="Avenir Next"/>
               </a:defRPr>
             </a:pPr>
             <a:r>
@@ -5939,15 +6493,18 @@
             </a:r>
           </a:p>
           <a:p>
-            <a:pPr>
-              <a:spcAft>
+            <a:pPr algn="l">
+              <a:spcBef>
                 <a:spcPts val="800"/>
-              </a:spcAft>
-              <a:defRPr sz="1800">
+              </a:spcBef>
+              <a:spcAft>
+                <a:spcPts val="400"/>
+              </a:spcAft>
+              <a:defRPr sz="2000" b="0" i="0">
                 <a:solidFill>
                   <a:srgbClr val="2C3E50"/>
                 </a:solidFill>
-                <a:latin typeface="Calibri"/>
+                <a:latin typeface="Avenir Next"/>
               </a:defRPr>
             </a:pPr>
             <a:r>
@@ -5955,15 +6512,18 @@
             </a:r>
           </a:p>
           <a:p>
-            <a:pPr>
-              <a:spcAft>
+            <a:pPr algn="l">
+              <a:spcBef>
                 <a:spcPts val="800"/>
-              </a:spcAft>
-              <a:defRPr sz="1800">
+              </a:spcBef>
+              <a:spcAft>
+                <a:spcPts val="400"/>
+              </a:spcAft>
+              <a:defRPr sz="2000" b="0" i="0">
                 <a:solidFill>
                   <a:srgbClr val="2C3E50"/>
                 </a:solidFill>
-                <a:latin typeface="Calibri"/>
+                <a:latin typeface="Avenir Next"/>
               </a:defRPr>
             </a:pPr>
             <a:r>
@@ -5971,15 +6531,18 @@
             </a:r>
           </a:p>
           <a:p>
-            <a:pPr>
-              <a:spcAft>
+            <a:pPr algn="l">
+              <a:spcBef>
                 <a:spcPts val="800"/>
-              </a:spcAft>
-              <a:defRPr sz="1800">
+              </a:spcBef>
+              <a:spcAft>
+                <a:spcPts val="400"/>
+              </a:spcAft>
+              <a:defRPr sz="2000" b="0" i="0">
                 <a:solidFill>
                   <a:srgbClr val="2C3E50"/>
                 </a:solidFill>
-                <a:latin typeface="Calibri"/>
+                <a:latin typeface="Avenir Next"/>
               </a:defRPr>
             </a:pPr>
             <a:r>
@@ -6016,14 +6579,57 @@
       <p:grpSpPr/>
       <p:sp>
         <p:nvSpPr>
-          <p:cNvPr id="2" name="TextBox 1"/>
+          <p:cNvPr id="2" name="Rectangle 1"/>
+          <p:cNvSpPr/>
+          <p:nvPr/>
+        </p:nvSpPr>
+        <p:spPr>
+          <a:xfrm>
+            <a:off x="0" y="0"/>
+            <a:ext cx="320040" cy="6858000"/>
+          </a:xfrm>
+          <a:prstGeom prst="rect">
+            <a:avLst/>
+          </a:prstGeom>
+          <a:solidFill>
+            <a:srgbClr val="1E2761"/>
+          </a:solidFill>
+          <a:ln>
+            <a:noFill/>
+          </a:ln>
+        </p:spPr>
+        <p:style>
+          <a:lnRef idx="1">
+            <a:schemeClr val="accent1"/>
+          </a:lnRef>
+          <a:fillRef idx="3">
+            <a:schemeClr val="accent1"/>
+          </a:fillRef>
+          <a:effectRef idx="2">
+            <a:schemeClr val="accent1"/>
+          </a:effectRef>
+          <a:fontRef idx="minor">
+            <a:schemeClr val="lt1"/>
+          </a:fontRef>
+        </p:style>
+        <p:txBody>
+          <a:bodyPr rtlCol="0" anchor="ctr"/>
+          <a:lstStyle/>
+          <a:p>
+            <a:pPr algn="ctr"/>
+          </a:p>
+        </p:txBody>
+      </p:sp>
+      <p:sp>
+        <p:nvSpPr>
+          <p:cNvPr id="3" name="TextBox 2"/>
           <p:cNvSpPr txBox="1"/>
           <p:nvPr/>
         </p:nvSpPr>
         <p:spPr>
           <a:xfrm>
-            <a:off x="731520" y="457200"/>
-            <a:ext cx="7680960" cy="731520"/>
+            <a:off x="731520" y="320040"/>
+            <a:ext cx="8046720" cy="822960"/>
           </a:xfrm>
           <a:prstGeom prst="rect">
             <a:avLst/>
@@ -6037,11 +6643,17 @@
           <a:lstStyle/>
           <a:p>
             <a:pPr algn="l">
-              <a:defRPr sz="2800" b="1">
+              <a:spcBef>
+                <a:spcPts val="0"/>
+              </a:spcBef>
+              <a:spcAft>
+                <a:spcPts val="0"/>
+              </a:spcAft>
+              <a:defRPr sz="3200" b="1" i="0">
                 <a:solidFill>
                   <a:srgbClr val="1E2761"/>
                 </a:solidFill>
-                <a:latin typeface="Georgia"/>
+                <a:latin typeface="Palatino"/>
               </a:defRPr>
             </a:pPr>
             <a:r>
@@ -6052,14 +6664,14 @@
       </p:sp>
       <p:sp>
         <p:nvSpPr>
-          <p:cNvPr id="3" name="TextBox 2"/>
+          <p:cNvPr id="4" name="TextBox 3"/>
           <p:cNvSpPr txBox="1"/>
           <p:nvPr/>
         </p:nvSpPr>
         <p:spPr>
           <a:xfrm>
-            <a:off x="1371600" y="2011680"/>
-            <a:ext cx="6400800" cy="2286000"/>
+            <a:off x="914400" y="1463040"/>
+            <a:ext cx="914400" cy="914400"/>
           </a:xfrm>
           <a:prstGeom prst="rect">
             <a:avLst/>
@@ -6067,35 +6679,41 @@
           <a:noFill/>
         </p:spPr>
         <p:txBody>
-          <a:bodyPr wrap="square">
+          <a:bodyPr wrap="none">
             <a:spAutoFit/>
           </a:bodyPr>
           <a:lstStyle/>
           <a:p>
-            <a:pPr algn="ctr">
-              <a:defRPr sz="2200" i="1">
-                <a:solidFill>
-                  <a:srgbClr val="1E2761"/>
-                </a:solidFill>
-                <a:latin typeface="Calibri"/>
-              </a:defRPr>
-            </a:pPr>
-            <a:r>
-              <a:t>योगश्चित्तवृत्तिनिरोधः    yogas citta-vrtti-nirodhah</a:t>
-            </a:r>
-          </a:p>
-        </p:txBody>
-      </p:sp>
-      <p:sp>
-        <p:nvSpPr>
-          <p:cNvPr id="4" name="TextBox 3"/>
+            <a:pPr algn="l">
+              <a:spcBef>
+                <a:spcPts val="0"/>
+              </a:spcBef>
+              <a:spcAft>
+                <a:spcPts val="0"/>
+              </a:spcAft>
+              <a:defRPr sz="7200" b="1" i="0">
+                <a:solidFill>
+                  <a:srgbClr val="7B2D26"/>
+                </a:solidFill>
+                <a:latin typeface="Palatino"/>
+              </a:defRPr>
+            </a:pPr>
+            <a:r>
+              <a:t>“</a:t>
+            </a:r>
+          </a:p>
+        </p:txBody>
+      </p:sp>
+      <p:sp>
+        <p:nvSpPr>
+          <p:cNvPr id="5" name="TextBox 4"/>
           <p:cNvSpPr txBox="1"/>
           <p:nvPr/>
         </p:nvSpPr>
         <p:spPr>
           <a:xfrm>
-            <a:off x="1371600" y="4389120"/>
-            <a:ext cx="6400800" cy="457200"/>
+            <a:off x="1371600" y="2194560"/>
+            <a:ext cx="6858000" cy="2286000"/>
           </a:xfrm>
           <a:prstGeom prst="rect">
             <a:avLst/>
@@ -6108,12 +6726,60 @@
           </a:bodyPr>
           <a:lstStyle/>
           <a:p>
-            <a:pPr algn="ctr">
-              <a:defRPr sz="1400" b="0">
+            <a:pPr algn="l">
+              <a:spcBef>
+                <a:spcPts val="0"/>
+              </a:spcBef>
+              <a:spcAft>
+                <a:spcPts val="1200"/>
+              </a:spcAft>
+              <a:defRPr sz="2600" b="0" i="1">
+                <a:solidFill>
+                  <a:srgbClr val="1E2761"/>
+                </a:solidFill>
+                <a:latin typeface="Palatino"/>
+              </a:defRPr>
+            </a:pPr>
+            <a:r>
+              <a:t>योगश्चित्तवृत्तिनिरोधः    yogas citta-vrtti-nirodhah</a:t>
+            </a:r>
+          </a:p>
+        </p:txBody>
+      </p:sp>
+      <p:sp>
+        <p:nvSpPr>
+          <p:cNvPr id="6" name="TextBox 5"/>
+          <p:cNvSpPr txBox="1"/>
+          <p:nvPr/>
+        </p:nvSpPr>
+        <p:spPr>
+          <a:xfrm>
+            <a:off x="1371600" y="4572000"/>
+            <a:ext cx="6858000" cy="731520"/>
+          </a:xfrm>
+          <a:prstGeom prst="rect">
+            <a:avLst/>
+          </a:prstGeom>
+          <a:noFill/>
+        </p:spPr>
+        <p:txBody>
+          <a:bodyPr wrap="square">
+            <a:spAutoFit/>
+          </a:bodyPr>
+          <a:lstStyle/>
+          <a:p>
+            <a:pPr algn="l">
+              <a:spcBef>
+                <a:spcPts val="0"/>
+              </a:spcBef>
+              <a:spcAft>
+                <a:spcPts val="0"/>
+              </a:spcAft>
+              <a:defRPr sz="1600" b="0" i="1">
                 <a:solidFill>
                   <a:srgbClr val="7B2D26"/>
                 </a:solidFill>
-                <a:latin typeface="Calibri"/>
+                <a:latin typeface="Avenir Next"/>
               </a:defRPr>
             </a:pPr>
             <a:r>
@@ -6150,14 +6816,57 @@
       <p:grpSpPr/>
       <p:sp>
         <p:nvSpPr>
-          <p:cNvPr id="2" name="TextBox 1"/>
+          <p:cNvPr id="2" name="Rectangle 1"/>
+          <p:cNvSpPr/>
+          <p:nvPr/>
+        </p:nvSpPr>
+        <p:spPr>
+          <a:xfrm>
+            <a:off x="0" y="0"/>
+            <a:ext cx="320040" cy="6858000"/>
+          </a:xfrm>
+          <a:prstGeom prst="rect">
+            <a:avLst/>
+          </a:prstGeom>
+          <a:solidFill>
+            <a:srgbClr val="1E2761"/>
+          </a:solidFill>
+          <a:ln>
+            <a:noFill/>
+          </a:ln>
+        </p:spPr>
+        <p:style>
+          <a:lnRef idx="1">
+            <a:schemeClr val="accent1"/>
+          </a:lnRef>
+          <a:fillRef idx="3">
+            <a:schemeClr val="accent1"/>
+          </a:fillRef>
+          <a:effectRef idx="2">
+            <a:schemeClr val="accent1"/>
+          </a:effectRef>
+          <a:fontRef idx="minor">
+            <a:schemeClr val="lt1"/>
+          </a:fontRef>
+        </p:style>
+        <p:txBody>
+          <a:bodyPr rtlCol="0" anchor="ctr"/>
+          <a:lstStyle/>
+          <a:p>
+            <a:pPr algn="ctr"/>
+          </a:p>
+        </p:txBody>
+      </p:sp>
+      <p:sp>
+        <p:nvSpPr>
+          <p:cNvPr id="3" name="TextBox 2"/>
           <p:cNvSpPr txBox="1"/>
           <p:nvPr/>
         </p:nvSpPr>
         <p:spPr>
           <a:xfrm>
-            <a:off x="731520" y="457200"/>
-            <a:ext cx="7680960" cy="731520"/>
+            <a:off x="731520" y="320040"/>
+            <a:ext cx="8046720" cy="822960"/>
           </a:xfrm>
           <a:prstGeom prst="rect">
             <a:avLst/>
@@ -6171,11 +6880,17 @@
           <a:lstStyle/>
           <a:p>
             <a:pPr algn="l">
-              <a:defRPr sz="2800" b="1">
+              <a:spcBef>
+                <a:spcPts val="0"/>
+              </a:spcBef>
+              <a:spcAft>
+                <a:spcPts val="0"/>
+              </a:spcAft>
+              <a:defRPr sz="3200" b="1" i="0">
                 <a:solidFill>
                   <a:srgbClr val="1E2761"/>
                 </a:solidFill>
-                <a:latin typeface="Georgia"/>
+                <a:latin typeface="Palatino"/>
               </a:defRPr>
             </a:pPr>
             <a:r>
@@ -6186,17 +6901,19 @@
       </p:sp>
       <p:sp>
         <p:nvSpPr>
-          <p:cNvPr id="3" name="Rectangle 2"/>
+          <p:cNvPr id="4" name="Rounded Rectangle 3"/>
           <p:cNvSpPr/>
           <p:nvPr/>
         </p:nvSpPr>
         <p:spPr>
           <a:xfrm>
-            <a:off x="731520" y="1143000"/>
-            <a:ext cx="1371600" cy="25400"/>
+            <a:off x="731520" y="1188720"/>
+            <a:ext cx="1828800" cy="50800"/>
           </a:xfrm>
-          <a:prstGeom prst="rect">
-            <a:avLst/>
+          <a:prstGeom prst="roundRect">
+            <a:avLst>
+              <a:gd name="adj" fmla="val 10000"/>
+            </a:avLst>
           </a:prstGeom>
           <a:solidFill>
             <a:srgbClr val="7B2D26"/>
@@ -6229,14 +6946,14 @@
       </p:sp>
       <p:sp>
         <p:nvSpPr>
-          <p:cNvPr id="4" name="TextBox 3"/>
+          <p:cNvPr id="5" name="TextBox 4"/>
           <p:cNvSpPr txBox="1"/>
           <p:nvPr/>
         </p:nvSpPr>
         <p:spPr>
           <a:xfrm>
-            <a:off x="731520" y="1463040"/>
-            <a:ext cx="7680960" cy="4572000"/>
+            <a:off x="731520" y="1554480"/>
+            <a:ext cx="7863840" cy="4754880"/>
           </a:xfrm>
           <a:prstGeom prst="rect">
             <a:avLst/>
@@ -6249,15 +6966,18 @@
           </a:bodyPr>
           <a:lstStyle/>
           <a:p>
-            <a:pPr>
-              <a:spcAft>
+            <a:pPr algn="l">
+              <a:spcBef>
                 <a:spcPts val="800"/>
-              </a:spcAft>
-              <a:defRPr sz="1800">
+              </a:spcBef>
+              <a:spcAft>
+                <a:spcPts val="400"/>
+              </a:spcAft>
+              <a:defRPr sz="2000" b="0" i="0">
                 <a:solidFill>
                   <a:srgbClr val="2C3E50"/>
                 </a:solidFill>
-                <a:latin typeface="Calibri"/>
+                <a:latin typeface="Avenir Next"/>
               </a:defRPr>
             </a:pPr>
             <a:r>
@@ -6265,15 +6985,18 @@
             </a:r>
           </a:p>
           <a:p>
-            <a:pPr>
-              <a:spcAft>
+            <a:pPr algn="l">
+              <a:spcBef>
                 <a:spcPts val="800"/>
-              </a:spcAft>
-              <a:defRPr sz="1800">
+              </a:spcBef>
+              <a:spcAft>
+                <a:spcPts val="400"/>
+              </a:spcAft>
+              <a:defRPr sz="2000" b="0" i="0">
                 <a:solidFill>
                   <a:srgbClr val="2C3E50"/>
                 </a:solidFill>
-                <a:latin typeface="Calibri"/>
+                <a:latin typeface="Avenir Next"/>
               </a:defRPr>
             </a:pPr>
             <a:r>
@@ -6281,15 +7004,18 @@
             </a:r>
           </a:p>
           <a:p>
-            <a:pPr>
-              <a:spcAft>
+            <a:pPr algn="l">
+              <a:spcBef>
                 <a:spcPts val="800"/>
-              </a:spcAft>
-              <a:defRPr sz="1800">
+              </a:spcBef>
+              <a:spcAft>
+                <a:spcPts val="400"/>
+              </a:spcAft>
+              <a:defRPr sz="2000" b="0" i="0">
                 <a:solidFill>
                   <a:srgbClr val="2C3E50"/>
                 </a:solidFill>
-                <a:latin typeface="Calibri"/>
+                <a:latin typeface="Avenir Next"/>
               </a:defRPr>
             </a:pPr>
             <a:r>
@@ -6297,15 +7023,18 @@
             </a:r>
           </a:p>
           <a:p>
-            <a:pPr>
-              <a:spcAft>
+            <a:pPr algn="l">
+              <a:spcBef>
                 <a:spcPts val="800"/>
-              </a:spcAft>
-              <a:defRPr sz="1800">
+              </a:spcBef>
+              <a:spcAft>
+                <a:spcPts val="400"/>
+              </a:spcAft>
+              <a:defRPr sz="2000" b="0" i="0">
                 <a:solidFill>
                   <a:srgbClr val="2C3E50"/>
                 </a:solidFill>
-                <a:latin typeface="Calibri"/>
+                <a:latin typeface="Avenir Next"/>
               </a:defRPr>
             </a:pPr>
             <a:r>
@@ -6313,15 +7042,18 @@
             </a:r>
           </a:p>
           <a:p>
-            <a:pPr>
-              <a:spcAft>
+            <a:pPr algn="l">
+              <a:spcBef>
                 <a:spcPts val="800"/>
-              </a:spcAft>
-              <a:defRPr sz="1800">
+              </a:spcBef>
+              <a:spcAft>
+                <a:spcPts val="400"/>
+              </a:spcAft>
+              <a:defRPr sz="2000" b="0" i="0">
                 <a:solidFill>
                   <a:srgbClr val="2C3E50"/>
                 </a:solidFill>
-                <a:latin typeface="Calibri"/>
+                <a:latin typeface="Avenir Next"/>
               </a:defRPr>
             </a:pPr>
             <a:r>
@@ -6358,14 +7090,57 @@
       <p:grpSpPr/>
       <p:sp>
         <p:nvSpPr>
-          <p:cNvPr id="2" name="TextBox 1"/>
+          <p:cNvPr id="2" name="Rectangle 1"/>
+          <p:cNvSpPr/>
+          <p:nvPr/>
+        </p:nvSpPr>
+        <p:spPr>
+          <a:xfrm>
+            <a:off x="0" y="0"/>
+            <a:ext cx="320040" cy="6858000"/>
+          </a:xfrm>
+          <a:prstGeom prst="rect">
+            <a:avLst/>
+          </a:prstGeom>
+          <a:solidFill>
+            <a:srgbClr val="1E2761"/>
+          </a:solidFill>
+          <a:ln>
+            <a:noFill/>
+          </a:ln>
+        </p:spPr>
+        <p:style>
+          <a:lnRef idx="1">
+            <a:schemeClr val="accent1"/>
+          </a:lnRef>
+          <a:fillRef idx="3">
+            <a:schemeClr val="accent1"/>
+          </a:fillRef>
+          <a:effectRef idx="2">
+            <a:schemeClr val="accent1"/>
+          </a:effectRef>
+          <a:fontRef idx="minor">
+            <a:schemeClr val="lt1"/>
+          </a:fontRef>
+        </p:style>
+        <p:txBody>
+          <a:bodyPr rtlCol="0" anchor="ctr"/>
+          <a:lstStyle/>
+          <a:p>
+            <a:pPr algn="ctr"/>
+          </a:p>
+        </p:txBody>
+      </p:sp>
+      <p:sp>
+        <p:nvSpPr>
+          <p:cNvPr id="3" name="TextBox 2"/>
           <p:cNvSpPr txBox="1"/>
           <p:nvPr/>
         </p:nvSpPr>
         <p:spPr>
           <a:xfrm>
-            <a:off x="731520" y="457200"/>
-            <a:ext cx="7680960" cy="731520"/>
+            <a:off x="731520" y="320040"/>
+            <a:ext cx="8046720" cy="822960"/>
           </a:xfrm>
           <a:prstGeom prst="rect">
             <a:avLst/>
@@ -6379,11 +7154,17 @@
           <a:lstStyle/>
           <a:p>
             <a:pPr algn="l">
-              <a:defRPr sz="2800" b="1">
+              <a:spcBef>
+                <a:spcPts val="0"/>
+              </a:spcBef>
+              <a:spcAft>
+                <a:spcPts val="0"/>
+              </a:spcAft>
+              <a:defRPr sz="3000" b="1" i="0">
                 <a:solidFill>
                   <a:srgbClr val="1E2761"/>
                 </a:solidFill>
-                <a:latin typeface="Georgia"/>
+                <a:latin typeface="Palatino"/>
               </a:defRPr>
             </a:pPr>
             <a:r>
@@ -6394,17 +7175,19 @@
       </p:sp>
       <p:sp>
         <p:nvSpPr>
-          <p:cNvPr id="3" name="Rectangle 2"/>
+          <p:cNvPr id="4" name="Rounded Rectangle 3"/>
           <p:cNvSpPr/>
           <p:nvPr/>
         </p:nvSpPr>
         <p:spPr>
           <a:xfrm>
-            <a:off x="731520" y="1143000"/>
-            <a:ext cx="1371600" cy="25400"/>
+            <a:off x="731520" y="1188720"/>
+            <a:ext cx="1828800" cy="50800"/>
           </a:xfrm>
-          <a:prstGeom prst="rect">
-            <a:avLst/>
+          <a:prstGeom prst="roundRect">
+            <a:avLst>
+              <a:gd name="adj" fmla="val 10000"/>
+            </a:avLst>
           </a:prstGeom>
           <a:solidFill>
             <a:srgbClr val="7B2D26"/>
@@ -6437,14 +7220,57 @@
       </p:sp>
       <p:sp>
         <p:nvSpPr>
-          <p:cNvPr id="4" name="TextBox 3"/>
+          <p:cNvPr id="5" name="Rectangle 4"/>
+          <p:cNvSpPr/>
+          <p:nvPr/>
+        </p:nvSpPr>
+        <p:spPr>
+          <a:xfrm>
+            <a:off x="4434840" y="1463040"/>
+            <a:ext cx="19050" cy="4754880"/>
+          </a:xfrm>
+          <a:prstGeom prst="rect">
+            <a:avLst/>
+          </a:prstGeom>
+          <a:solidFill>
+            <a:srgbClr val="D0D0D0"/>
+          </a:solidFill>
+          <a:ln>
+            <a:noFill/>
+          </a:ln>
+        </p:spPr>
+        <p:style>
+          <a:lnRef idx="1">
+            <a:schemeClr val="accent1"/>
+          </a:lnRef>
+          <a:fillRef idx="3">
+            <a:schemeClr val="accent1"/>
+          </a:fillRef>
+          <a:effectRef idx="2">
+            <a:schemeClr val="accent1"/>
+          </a:effectRef>
+          <a:fontRef idx="minor">
+            <a:schemeClr val="lt1"/>
+          </a:fontRef>
+        </p:style>
+        <p:txBody>
+          <a:bodyPr rtlCol="0" anchor="ctr"/>
+          <a:lstStyle/>
+          <a:p>
+            <a:pPr algn="ctr"/>
+          </a:p>
+        </p:txBody>
+      </p:sp>
+      <p:sp>
+        <p:nvSpPr>
+          <p:cNvPr id="6" name="TextBox 5"/>
           <p:cNvSpPr txBox="1"/>
           <p:nvPr/>
         </p:nvSpPr>
         <p:spPr>
           <a:xfrm>
-            <a:off x="731520" y="1463040"/>
-            <a:ext cx="3657600" cy="4572000"/>
+            <a:off x="731520" y="1508760"/>
+            <a:ext cx="3566160" cy="4846320"/>
           </a:xfrm>
           <a:prstGeom prst="rect">
             <a:avLst/>
@@ -6457,15 +7283,18 @@
           </a:bodyPr>
           <a:lstStyle/>
           <a:p>
-            <a:pPr>
-              <a:spcAft>
+            <a:pPr algn="l">
+              <a:spcBef>
                 <a:spcPts val="800"/>
-              </a:spcAft>
-              <a:defRPr sz="1600">
+              </a:spcBef>
+              <a:spcAft>
+                <a:spcPts val="400"/>
+              </a:spcAft>
+              <a:defRPr sz="1800" b="0" i="0">
                 <a:solidFill>
                   <a:srgbClr val="2C3E50"/>
                 </a:solidFill>
-                <a:latin typeface="Calibri"/>
+                <a:latin typeface="Avenir Next"/>
               </a:defRPr>
             </a:pPr>
             <a:r>
@@ -6473,15 +7302,18 @@
             </a:r>
           </a:p>
           <a:p>
-            <a:pPr>
-              <a:spcAft>
+            <a:pPr algn="l">
+              <a:spcBef>
                 <a:spcPts val="800"/>
-              </a:spcAft>
-              <a:defRPr sz="1600">
+              </a:spcBef>
+              <a:spcAft>
+                <a:spcPts val="400"/>
+              </a:spcAft>
+              <a:defRPr sz="1800" b="0" i="0">
                 <a:solidFill>
                   <a:srgbClr val="2C3E50"/>
                 </a:solidFill>
-                <a:latin typeface="Calibri"/>
+                <a:latin typeface="Avenir Next"/>
               </a:defRPr>
             </a:pPr>
             <a:r>
@@ -6489,15 +7321,18 @@
             </a:r>
           </a:p>
           <a:p>
-            <a:pPr>
-              <a:spcAft>
+            <a:pPr algn="l">
+              <a:spcBef>
                 <a:spcPts val="800"/>
-              </a:spcAft>
-              <a:defRPr sz="1600">
+              </a:spcBef>
+              <a:spcAft>
+                <a:spcPts val="400"/>
+              </a:spcAft>
+              <a:defRPr sz="1800" b="0" i="0">
                 <a:solidFill>
                   <a:srgbClr val="2C3E50"/>
                 </a:solidFill>
-                <a:latin typeface="Calibri"/>
+                <a:latin typeface="Avenir Next"/>
               </a:defRPr>
             </a:pPr>
             <a:r>
@@ -6505,15 +7340,18 @@
             </a:r>
           </a:p>
           <a:p>
-            <a:pPr>
-              <a:spcAft>
+            <a:pPr algn="l">
+              <a:spcBef>
                 <a:spcPts val="800"/>
-              </a:spcAft>
-              <a:defRPr sz="1600">
+              </a:spcBef>
+              <a:spcAft>
+                <a:spcPts val="400"/>
+              </a:spcAft>
+              <a:defRPr sz="1800" b="0" i="0">
                 <a:solidFill>
                   <a:srgbClr val="2C3E50"/>
                 </a:solidFill>
-                <a:latin typeface="Calibri"/>
+                <a:latin typeface="Avenir Next"/>
               </a:defRPr>
             </a:pPr>
             <a:r>
@@ -6521,15 +7359,18 @@
             </a:r>
           </a:p>
           <a:p>
-            <a:pPr>
-              <a:spcAft>
+            <a:pPr algn="l">
+              <a:spcBef>
                 <a:spcPts val="800"/>
-              </a:spcAft>
-              <a:defRPr sz="1600">
+              </a:spcBef>
+              <a:spcAft>
+                <a:spcPts val="400"/>
+              </a:spcAft>
+              <a:defRPr sz="1800" b="0" i="0">
                 <a:solidFill>
                   <a:srgbClr val="2C3E50"/>
                 </a:solidFill>
-                <a:latin typeface="Calibri"/>
+                <a:latin typeface="Avenir Next"/>
               </a:defRPr>
             </a:pPr>
             <a:r>
@@ -6540,14 +7381,14 @@
       </p:sp>
       <p:sp>
         <p:nvSpPr>
-          <p:cNvPr id="5" name="TextBox 4"/>
+          <p:cNvPr id="7" name="TextBox 6"/>
           <p:cNvSpPr txBox="1"/>
           <p:nvPr/>
         </p:nvSpPr>
         <p:spPr>
           <a:xfrm>
-            <a:off x="4754880" y="1463040"/>
-            <a:ext cx="3657600" cy="4572000"/>
+            <a:off x="4663440" y="1508760"/>
+            <a:ext cx="4114800" cy="4846320"/>
           </a:xfrm>
           <a:prstGeom prst="rect">
             <a:avLst/>
@@ -6560,15 +7401,18 @@
           </a:bodyPr>
           <a:lstStyle/>
           <a:p>
-            <a:pPr>
-              <a:spcAft>
+            <a:pPr algn="l">
+              <a:spcBef>
                 <a:spcPts val="800"/>
-              </a:spcAft>
-              <a:defRPr sz="1600">
+              </a:spcBef>
+              <a:spcAft>
+                <a:spcPts val="400"/>
+              </a:spcAft>
+              <a:defRPr sz="1800" b="0" i="0">
                 <a:solidFill>
                   <a:srgbClr val="2C3E50"/>
                 </a:solidFill>
-                <a:latin typeface="Calibri"/>
+                <a:latin typeface="Avenir Next"/>
               </a:defRPr>
             </a:pPr>
             <a:r>
@@ -6576,15 +7420,18 @@
             </a:r>
           </a:p>
           <a:p>
-            <a:pPr>
-              <a:spcAft>
+            <a:pPr algn="l">
+              <a:spcBef>
                 <a:spcPts val="800"/>
-              </a:spcAft>
-              <a:defRPr sz="1600">
+              </a:spcBef>
+              <a:spcAft>
+                <a:spcPts val="400"/>
+              </a:spcAft>
+              <a:defRPr sz="1800" b="0" i="0">
                 <a:solidFill>
                   <a:srgbClr val="2C3E50"/>
                 </a:solidFill>
-                <a:latin typeface="Calibri"/>
+                <a:latin typeface="Avenir Next"/>
               </a:defRPr>
             </a:pPr>
             <a:r>
@@ -6592,15 +7439,18 @@
             </a:r>
           </a:p>
           <a:p>
-            <a:pPr>
-              <a:spcAft>
+            <a:pPr algn="l">
+              <a:spcBef>
                 <a:spcPts val="800"/>
-              </a:spcAft>
-              <a:defRPr sz="1600">
+              </a:spcBef>
+              <a:spcAft>
+                <a:spcPts val="400"/>
+              </a:spcAft>
+              <a:defRPr sz="1800" b="0" i="0">
                 <a:solidFill>
                   <a:srgbClr val="2C3E50"/>
                 </a:solidFill>
-                <a:latin typeface="Calibri"/>
+                <a:latin typeface="Avenir Next"/>
               </a:defRPr>
             </a:pPr>
             <a:r>
@@ -6608,15 +7458,18 @@
             </a:r>
           </a:p>
           <a:p>
-            <a:pPr>
-              <a:spcAft>
+            <a:pPr algn="l">
+              <a:spcBef>
                 <a:spcPts val="800"/>
-              </a:spcAft>
-              <a:defRPr sz="1600">
+              </a:spcBef>
+              <a:spcAft>
+                <a:spcPts val="400"/>
+              </a:spcAft>
+              <a:defRPr sz="1800" b="0" i="0">
                 <a:solidFill>
                   <a:srgbClr val="2C3E50"/>
                 </a:solidFill>
-                <a:latin typeface="Calibri"/>
+                <a:latin typeface="Avenir Next"/>
               </a:defRPr>
             </a:pPr>
             <a:r>
@@ -6653,14 +7506,57 @@
       <p:grpSpPr/>
       <p:sp>
         <p:nvSpPr>
-          <p:cNvPr id="2" name="TextBox 1"/>
+          <p:cNvPr id="2" name="Rectangle 1"/>
+          <p:cNvSpPr/>
+          <p:nvPr/>
+        </p:nvSpPr>
+        <p:spPr>
+          <a:xfrm>
+            <a:off x="0" y="0"/>
+            <a:ext cx="320040" cy="6858000"/>
+          </a:xfrm>
+          <a:prstGeom prst="rect">
+            <a:avLst/>
+          </a:prstGeom>
+          <a:solidFill>
+            <a:srgbClr val="1E2761"/>
+          </a:solidFill>
+          <a:ln>
+            <a:noFill/>
+          </a:ln>
+        </p:spPr>
+        <p:style>
+          <a:lnRef idx="1">
+            <a:schemeClr val="accent1"/>
+          </a:lnRef>
+          <a:fillRef idx="3">
+            <a:schemeClr val="accent1"/>
+          </a:fillRef>
+          <a:effectRef idx="2">
+            <a:schemeClr val="accent1"/>
+          </a:effectRef>
+          <a:fontRef idx="minor">
+            <a:schemeClr val="lt1"/>
+          </a:fontRef>
+        </p:style>
+        <p:txBody>
+          <a:bodyPr rtlCol="0" anchor="ctr"/>
+          <a:lstStyle/>
+          <a:p>
+            <a:pPr algn="ctr"/>
+          </a:p>
+        </p:txBody>
+      </p:sp>
+      <p:sp>
+        <p:nvSpPr>
+          <p:cNvPr id="3" name="TextBox 2"/>
           <p:cNvSpPr txBox="1"/>
           <p:nvPr/>
         </p:nvSpPr>
         <p:spPr>
           <a:xfrm>
-            <a:off x="731520" y="457200"/>
-            <a:ext cx="7680960" cy="731520"/>
+            <a:off x="731520" y="320040"/>
+            <a:ext cx="8046720" cy="822960"/>
           </a:xfrm>
           <a:prstGeom prst="rect">
             <a:avLst/>
@@ -6674,11 +7570,17 @@
           <a:lstStyle/>
           <a:p>
             <a:pPr algn="l">
-              <a:defRPr sz="2800" b="1">
+              <a:spcBef>
+                <a:spcPts val="0"/>
+              </a:spcBef>
+              <a:spcAft>
+                <a:spcPts val="0"/>
+              </a:spcAft>
+              <a:defRPr sz="3000" b="1" i="0">
                 <a:solidFill>
                   <a:srgbClr val="1E2761"/>
                 </a:solidFill>
-                <a:latin typeface="Georgia"/>
+                <a:latin typeface="Palatino"/>
               </a:defRPr>
             </a:pPr>
             <a:r>
@@ -6689,17 +7591,19 @@
       </p:sp>
       <p:sp>
         <p:nvSpPr>
-          <p:cNvPr id="3" name="Rectangle 2"/>
+          <p:cNvPr id="4" name="Rounded Rectangle 3"/>
           <p:cNvSpPr/>
           <p:nvPr/>
         </p:nvSpPr>
         <p:spPr>
           <a:xfrm>
-            <a:off x="731520" y="1143000"/>
-            <a:ext cx="1371600" cy="25400"/>
+            <a:off x="731520" y="1188720"/>
+            <a:ext cx="1828800" cy="50800"/>
           </a:xfrm>
-          <a:prstGeom prst="rect">
-            <a:avLst/>
+          <a:prstGeom prst="roundRect">
+            <a:avLst>
+              <a:gd name="adj" fmla="val 10000"/>
+            </a:avLst>
           </a:prstGeom>
           <a:solidFill>
             <a:srgbClr val="7B2D26"/>
@@ -6732,14 +7636,57 @@
       </p:sp>
       <p:sp>
         <p:nvSpPr>
-          <p:cNvPr id="4" name="TextBox 3"/>
+          <p:cNvPr id="5" name="Rectangle 4"/>
+          <p:cNvSpPr/>
+          <p:nvPr/>
+        </p:nvSpPr>
+        <p:spPr>
+          <a:xfrm>
+            <a:off x="4434840" y="1463040"/>
+            <a:ext cx="19050" cy="4754880"/>
+          </a:xfrm>
+          <a:prstGeom prst="rect">
+            <a:avLst/>
+          </a:prstGeom>
+          <a:solidFill>
+            <a:srgbClr val="D0D0D0"/>
+          </a:solidFill>
+          <a:ln>
+            <a:noFill/>
+          </a:ln>
+        </p:spPr>
+        <p:style>
+          <a:lnRef idx="1">
+            <a:schemeClr val="accent1"/>
+          </a:lnRef>
+          <a:fillRef idx="3">
+            <a:schemeClr val="accent1"/>
+          </a:fillRef>
+          <a:effectRef idx="2">
+            <a:schemeClr val="accent1"/>
+          </a:effectRef>
+          <a:fontRef idx="minor">
+            <a:schemeClr val="lt1"/>
+          </a:fontRef>
+        </p:style>
+        <p:txBody>
+          <a:bodyPr rtlCol="0" anchor="ctr"/>
+          <a:lstStyle/>
+          <a:p>
+            <a:pPr algn="ctr"/>
+          </a:p>
+        </p:txBody>
+      </p:sp>
+      <p:sp>
+        <p:nvSpPr>
+          <p:cNvPr id="6" name="TextBox 5"/>
           <p:cNvSpPr txBox="1"/>
           <p:nvPr/>
         </p:nvSpPr>
         <p:spPr>
           <a:xfrm>
-            <a:off x="731520" y="1463040"/>
-            <a:ext cx="3657600" cy="4572000"/>
+            <a:off x="731520" y="1508760"/>
+            <a:ext cx="3566160" cy="4846320"/>
           </a:xfrm>
           <a:prstGeom prst="rect">
             <a:avLst/>
@@ -6752,15 +7699,18 @@
           </a:bodyPr>
           <a:lstStyle/>
           <a:p>
-            <a:pPr>
-              <a:spcAft>
+            <a:pPr algn="l">
+              <a:spcBef>
                 <a:spcPts val="800"/>
-              </a:spcAft>
-              <a:defRPr sz="1600">
+              </a:spcBef>
+              <a:spcAft>
+                <a:spcPts val="400"/>
+              </a:spcAft>
+              <a:defRPr sz="1800" b="0" i="0">
                 <a:solidFill>
                   <a:srgbClr val="2C3E50"/>
                 </a:solidFill>
-                <a:latin typeface="Calibri"/>
+                <a:latin typeface="Avenir Next"/>
               </a:defRPr>
             </a:pPr>
             <a:r>
@@ -6768,15 +7718,18 @@
             </a:r>
           </a:p>
           <a:p>
-            <a:pPr>
-              <a:spcAft>
+            <a:pPr algn="l">
+              <a:spcBef>
                 <a:spcPts val="800"/>
-              </a:spcAft>
-              <a:defRPr sz="1600">
+              </a:spcBef>
+              <a:spcAft>
+                <a:spcPts val="400"/>
+              </a:spcAft>
+              <a:defRPr sz="1800" b="0" i="0">
                 <a:solidFill>
                   <a:srgbClr val="2C3E50"/>
                 </a:solidFill>
-                <a:latin typeface="Calibri"/>
+                <a:latin typeface="Avenir Next"/>
               </a:defRPr>
             </a:pPr>
             <a:r>
@@ -6784,15 +7737,18 @@
             </a:r>
           </a:p>
           <a:p>
-            <a:pPr>
-              <a:spcAft>
+            <a:pPr algn="l">
+              <a:spcBef>
                 <a:spcPts val="800"/>
-              </a:spcAft>
-              <a:defRPr sz="1600">
+              </a:spcBef>
+              <a:spcAft>
+                <a:spcPts val="400"/>
+              </a:spcAft>
+              <a:defRPr sz="1800" b="0" i="0">
                 <a:solidFill>
                   <a:srgbClr val="2C3E50"/>
                 </a:solidFill>
-                <a:latin typeface="Calibri"/>
+                <a:latin typeface="Avenir Next"/>
               </a:defRPr>
             </a:pPr>
             <a:r>
@@ -6800,15 +7756,18 @@
             </a:r>
           </a:p>
           <a:p>
-            <a:pPr>
-              <a:spcAft>
+            <a:pPr algn="l">
+              <a:spcBef>
                 <a:spcPts val="800"/>
-              </a:spcAft>
-              <a:defRPr sz="1600">
+              </a:spcBef>
+              <a:spcAft>
+                <a:spcPts val="400"/>
+              </a:spcAft>
+              <a:defRPr sz="1800" b="0" i="0">
                 <a:solidFill>
                   <a:srgbClr val="2C3E50"/>
                 </a:solidFill>
-                <a:latin typeface="Calibri"/>
+                <a:latin typeface="Avenir Next"/>
               </a:defRPr>
             </a:pPr>
             <a:r>
@@ -6816,15 +7775,18 @@
             </a:r>
           </a:p>
           <a:p>
-            <a:pPr>
-              <a:spcAft>
+            <a:pPr algn="l">
+              <a:spcBef>
                 <a:spcPts val="800"/>
-              </a:spcAft>
-              <a:defRPr sz="1600">
+              </a:spcBef>
+              <a:spcAft>
+                <a:spcPts val="400"/>
+              </a:spcAft>
+              <a:defRPr sz="1800" b="0" i="0">
                 <a:solidFill>
                   <a:srgbClr val="2C3E50"/>
                 </a:solidFill>
-                <a:latin typeface="Calibri"/>
+                <a:latin typeface="Avenir Next"/>
               </a:defRPr>
             </a:pPr>
             <a:r>
@@ -6835,14 +7797,14 @@
       </p:sp>
       <p:sp>
         <p:nvSpPr>
-          <p:cNvPr id="5" name="TextBox 4"/>
+          <p:cNvPr id="7" name="TextBox 6"/>
           <p:cNvSpPr txBox="1"/>
           <p:nvPr/>
         </p:nvSpPr>
         <p:spPr>
           <a:xfrm>
-            <a:off x="4754880" y="1463040"/>
-            <a:ext cx="3657600" cy="4572000"/>
+            <a:off x="4663440" y="1508760"/>
+            <a:ext cx="4114800" cy="4846320"/>
           </a:xfrm>
           <a:prstGeom prst="rect">
             <a:avLst/>
@@ -6855,15 +7817,18 @@
           </a:bodyPr>
           <a:lstStyle/>
           <a:p>
-            <a:pPr>
-              <a:spcAft>
+            <a:pPr algn="l">
+              <a:spcBef>
                 <a:spcPts val="800"/>
-              </a:spcAft>
-              <a:defRPr sz="1600">
+              </a:spcBef>
+              <a:spcAft>
+                <a:spcPts val="400"/>
+              </a:spcAft>
+              <a:defRPr sz="1800" b="0" i="0">
                 <a:solidFill>
                   <a:srgbClr val="2C3E50"/>
                 </a:solidFill>
-                <a:latin typeface="Calibri"/>
+                <a:latin typeface="Avenir Next"/>
               </a:defRPr>
             </a:pPr>
             <a:r>
@@ -6871,15 +7836,18 @@
             </a:r>
           </a:p>
           <a:p>
-            <a:pPr>
-              <a:spcAft>
+            <a:pPr algn="l">
+              <a:spcBef>
                 <a:spcPts val="800"/>
-              </a:spcAft>
-              <a:defRPr sz="1600">
+              </a:spcBef>
+              <a:spcAft>
+                <a:spcPts val="400"/>
+              </a:spcAft>
+              <a:defRPr sz="1800" b="0" i="0">
                 <a:solidFill>
                   <a:srgbClr val="2C3E50"/>
                 </a:solidFill>
-                <a:latin typeface="Calibri"/>
+                <a:latin typeface="Avenir Next"/>
               </a:defRPr>
             </a:pPr>
             <a:r>
@@ -6887,15 +7855,18 @@
             </a:r>
           </a:p>
           <a:p>
-            <a:pPr>
-              <a:spcAft>
+            <a:pPr algn="l">
+              <a:spcBef>
                 <a:spcPts val="800"/>
-              </a:spcAft>
-              <a:defRPr sz="1600">
+              </a:spcBef>
+              <a:spcAft>
+                <a:spcPts val="400"/>
+              </a:spcAft>
+              <a:defRPr sz="1800" b="0" i="0">
                 <a:solidFill>
                   <a:srgbClr val="2C3E50"/>
                 </a:solidFill>
-                <a:latin typeface="Calibri"/>
+                <a:latin typeface="Avenir Next"/>
               </a:defRPr>
             </a:pPr>
             <a:r>
@@ -6903,15 +7874,18 @@
             </a:r>
           </a:p>
           <a:p>
-            <a:pPr>
-              <a:spcAft>
+            <a:pPr algn="l">
+              <a:spcBef>
                 <a:spcPts val="800"/>
-              </a:spcAft>
-              <a:defRPr sz="1600">
+              </a:spcBef>
+              <a:spcAft>
+                <a:spcPts val="400"/>
+              </a:spcAft>
+              <a:defRPr sz="1800" b="0" i="0">
                 <a:solidFill>
                   <a:srgbClr val="2C3E50"/>
                 </a:solidFill>
-                <a:latin typeface="Calibri"/>
+                <a:latin typeface="Avenir Next"/>
               </a:defRPr>
             </a:pPr>
             <a:r>
@@ -6919,15 +7893,18 @@
             </a:r>
           </a:p>
           <a:p>
-            <a:pPr>
-              <a:spcAft>
+            <a:pPr algn="l">
+              <a:spcBef>
                 <a:spcPts val="800"/>
-              </a:spcAft>
-              <a:defRPr sz="1600">
+              </a:spcBef>
+              <a:spcAft>
+                <a:spcPts val="400"/>
+              </a:spcAft>
+              <a:defRPr sz="1800" b="0" i="0">
                 <a:solidFill>
                   <a:srgbClr val="2C3E50"/>
                 </a:solidFill>
-                <a:latin typeface="Calibri"/>
+                <a:latin typeface="Avenir Next"/>
               </a:defRPr>
             </a:pPr>
             <a:r>
@@ -6964,14 +7941,57 @@
       <p:grpSpPr/>
       <p:sp>
         <p:nvSpPr>
-          <p:cNvPr id="2" name="TextBox 1"/>
+          <p:cNvPr id="2" name="Rectangle 1"/>
+          <p:cNvSpPr/>
+          <p:nvPr/>
+        </p:nvSpPr>
+        <p:spPr>
+          <a:xfrm>
+            <a:off x="0" y="0"/>
+            <a:ext cx="320040" cy="6858000"/>
+          </a:xfrm>
+          <a:prstGeom prst="rect">
+            <a:avLst/>
+          </a:prstGeom>
+          <a:solidFill>
+            <a:srgbClr val="1E2761"/>
+          </a:solidFill>
+          <a:ln>
+            <a:noFill/>
+          </a:ln>
+        </p:spPr>
+        <p:style>
+          <a:lnRef idx="1">
+            <a:schemeClr val="accent1"/>
+          </a:lnRef>
+          <a:fillRef idx="3">
+            <a:schemeClr val="accent1"/>
+          </a:fillRef>
+          <a:effectRef idx="2">
+            <a:schemeClr val="accent1"/>
+          </a:effectRef>
+          <a:fontRef idx="minor">
+            <a:schemeClr val="lt1"/>
+          </a:fontRef>
+        </p:style>
+        <p:txBody>
+          <a:bodyPr rtlCol="0" anchor="ctr"/>
+          <a:lstStyle/>
+          <a:p>
+            <a:pPr algn="ctr"/>
+          </a:p>
+        </p:txBody>
+      </p:sp>
+      <p:sp>
+        <p:nvSpPr>
+          <p:cNvPr id="3" name="TextBox 2"/>
           <p:cNvSpPr txBox="1"/>
           <p:nvPr/>
         </p:nvSpPr>
         <p:spPr>
           <a:xfrm>
-            <a:off x="731520" y="457200"/>
-            <a:ext cx="7680960" cy="731520"/>
+            <a:off x="731520" y="320040"/>
+            <a:ext cx="8046720" cy="822960"/>
           </a:xfrm>
           <a:prstGeom prst="rect">
             <a:avLst/>
@@ -6985,11 +8005,17 @@
           <a:lstStyle/>
           <a:p>
             <a:pPr algn="l">
-              <a:defRPr sz="2800" b="1">
+              <a:spcBef>
+                <a:spcPts val="0"/>
+              </a:spcBef>
+              <a:spcAft>
+                <a:spcPts val="0"/>
+              </a:spcAft>
+              <a:defRPr sz="3000" b="1" i="0">
                 <a:solidFill>
                   <a:srgbClr val="1E2761"/>
                 </a:solidFill>
-                <a:latin typeface="Georgia"/>
+                <a:latin typeface="Palatino"/>
               </a:defRPr>
             </a:pPr>
             <a:r>
@@ -7000,17 +8026,19 @@
       </p:sp>
       <p:sp>
         <p:nvSpPr>
-          <p:cNvPr id="3" name="Rectangle 2"/>
+          <p:cNvPr id="4" name="Rounded Rectangle 3"/>
           <p:cNvSpPr/>
           <p:nvPr/>
         </p:nvSpPr>
         <p:spPr>
           <a:xfrm>
-            <a:off x="731520" y="1143000"/>
-            <a:ext cx="1371600" cy="25400"/>
+            <a:off x="731520" y="1188720"/>
+            <a:ext cx="1828800" cy="50800"/>
           </a:xfrm>
-          <a:prstGeom prst="rect">
-            <a:avLst/>
+          <a:prstGeom prst="roundRect">
+            <a:avLst>
+              <a:gd name="adj" fmla="val 10000"/>
+            </a:avLst>
           </a:prstGeom>
           <a:solidFill>
             <a:srgbClr val="7B2D26"/>
@@ -7043,14 +8071,57 @@
       </p:sp>
       <p:sp>
         <p:nvSpPr>
-          <p:cNvPr id="4" name="TextBox 3"/>
+          <p:cNvPr id="5" name="Rectangle 4"/>
+          <p:cNvSpPr/>
+          <p:nvPr/>
+        </p:nvSpPr>
+        <p:spPr>
+          <a:xfrm>
+            <a:off x="4434840" y="1463040"/>
+            <a:ext cx="19050" cy="4754880"/>
+          </a:xfrm>
+          <a:prstGeom prst="rect">
+            <a:avLst/>
+          </a:prstGeom>
+          <a:solidFill>
+            <a:srgbClr val="D0D0D0"/>
+          </a:solidFill>
+          <a:ln>
+            <a:noFill/>
+          </a:ln>
+        </p:spPr>
+        <p:style>
+          <a:lnRef idx="1">
+            <a:schemeClr val="accent1"/>
+          </a:lnRef>
+          <a:fillRef idx="3">
+            <a:schemeClr val="accent1"/>
+          </a:fillRef>
+          <a:effectRef idx="2">
+            <a:schemeClr val="accent1"/>
+          </a:effectRef>
+          <a:fontRef idx="minor">
+            <a:schemeClr val="lt1"/>
+          </a:fontRef>
+        </p:style>
+        <p:txBody>
+          <a:bodyPr rtlCol="0" anchor="ctr"/>
+          <a:lstStyle/>
+          <a:p>
+            <a:pPr algn="ctr"/>
+          </a:p>
+        </p:txBody>
+      </p:sp>
+      <p:sp>
+        <p:nvSpPr>
+          <p:cNvPr id="6" name="TextBox 5"/>
           <p:cNvSpPr txBox="1"/>
           <p:nvPr/>
         </p:nvSpPr>
         <p:spPr>
           <a:xfrm>
-            <a:off x="731520" y="1463040"/>
-            <a:ext cx="3657600" cy="4572000"/>
+            <a:off x="731520" y="1508760"/>
+            <a:ext cx="3566160" cy="4846320"/>
           </a:xfrm>
           <a:prstGeom prst="rect">
             <a:avLst/>
@@ -7063,15 +8134,18 @@
           </a:bodyPr>
           <a:lstStyle/>
           <a:p>
-            <a:pPr>
-              <a:spcAft>
+            <a:pPr algn="l">
+              <a:spcBef>
                 <a:spcPts val="800"/>
-              </a:spcAft>
-              <a:defRPr sz="1600">
+              </a:spcBef>
+              <a:spcAft>
+                <a:spcPts val="400"/>
+              </a:spcAft>
+              <a:defRPr sz="1800" b="0" i="0">
                 <a:solidFill>
                   <a:srgbClr val="2C3E50"/>
                 </a:solidFill>
-                <a:latin typeface="Calibri"/>
+                <a:latin typeface="Avenir Next"/>
               </a:defRPr>
             </a:pPr>
             <a:r>
@@ -7079,15 +8153,18 @@
             </a:r>
           </a:p>
           <a:p>
-            <a:pPr>
-              <a:spcAft>
+            <a:pPr algn="l">
+              <a:spcBef>
                 <a:spcPts val="800"/>
-              </a:spcAft>
-              <a:defRPr sz="1600">
+              </a:spcBef>
+              <a:spcAft>
+                <a:spcPts val="400"/>
+              </a:spcAft>
+              <a:defRPr sz="1800" b="0" i="0">
                 <a:solidFill>
                   <a:srgbClr val="2C3E50"/>
                 </a:solidFill>
-                <a:latin typeface="Calibri"/>
+                <a:latin typeface="Avenir Next"/>
               </a:defRPr>
             </a:pPr>
             <a:r>
@@ -7095,15 +8172,18 @@
             </a:r>
           </a:p>
           <a:p>
-            <a:pPr>
-              <a:spcAft>
+            <a:pPr algn="l">
+              <a:spcBef>
                 <a:spcPts val="800"/>
-              </a:spcAft>
-              <a:defRPr sz="1600">
+              </a:spcBef>
+              <a:spcAft>
+                <a:spcPts val="400"/>
+              </a:spcAft>
+              <a:defRPr sz="1800" b="0" i="0">
                 <a:solidFill>
                   <a:srgbClr val="2C3E50"/>
                 </a:solidFill>
-                <a:latin typeface="Calibri"/>
+                <a:latin typeface="Avenir Next"/>
               </a:defRPr>
             </a:pPr>
             <a:r>
@@ -7111,15 +8191,18 @@
             </a:r>
           </a:p>
           <a:p>
-            <a:pPr>
-              <a:spcAft>
+            <a:pPr algn="l">
+              <a:spcBef>
                 <a:spcPts val="800"/>
-              </a:spcAft>
-              <a:defRPr sz="1600">
+              </a:spcBef>
+              <a:spcAft>
+                <a:spcPts val="400"/>
+              </a:spcAft>
+              <a:defRPr sz="1800" b="0" i="0">
                 <a:solidFill>
                   <a:srgbClr val="2C3E50"/>
                 </a:solidFill>
-                <a:latin typeface="Calibri"/>
+                <a:latin typeface="Avenir Next"/>
               </a:defRPr>
             </a:pPr>
             <a:r>
@@ -7127,15 +8210,18 @@
             </a:r>
           </a:p>
           <a:p>
-            <a:pPr>
-              <a:spcAft>
+            <a:pPr algn="l">
+              <a:spcBef>
                 <a:spcPts val="800"/>
-              </a:spcAft>
-              <a:defRPr sz="1600">
+              </a:spcBef>
+              <a:spcAft>
+                <a:spcPts val="400"/>
+              </a:spcAft>
+              <a:defRPr sz="1800" b="0" i="0">
                 <a:solidFill>
                   <a:srgbClr val="2C3E50"/>
                 </a:solidFill>
-                <a:latin typeface="Calibri"/>
+                <a:latin typeface="Avenir Next"/>
               </a:defRPr>
             </a:pPr>
             <a:r>
@@ -7146,14 +8232,14 @@
       </p:sp>
       <p:sp>
         <p:nvSpPr>
-          <p:cNvPr id="5" name="TextBox 4"/>
+          <p:cNvPr id="7" name="TextBox 6"/>
           <p:cNvSpPr txBox="1"/>
           <p:nvPr/>
         </p:nvSpPr>
         <p:spPr>
           <a:xfrm>
-            <a:off x="4754880" y="1463040"/>
-            <a:ext cx="3657600" cy="4572000"/>
+            <a:off x="4663440" y="1508760"/>
+            <a:ext cx="4114800" cy="4846320"/>
           </a:xfrm>
           <a:prstGeom prst="rect">
             <a:avLst/>
@@ -7166,15 +8252,18 @@
           </a:bodyPr>
           <a:lstStyle/>
           <a:p>
-            <a:pPr>
-              <a:spcAft>
+            <a:pPr algn="l">
+              <a:spcBef>
                 <a:spcPts val="800"/>
-              </a:spcAft>
-              <a:defRPr sz="1600">
+              </a:spcBef>
+              <a:spcAft>
+                <a:spcPts val="400"/>
+              </a:spcAft>
+              <a:defRPr sz="1800" b="0" i="0">
                 <a:solidFill>
                   <a:srgbClr val="2C3E50"/>
                 </a:solidFill>
-                <a:latin typeface="Calibri"/>
+                <a:latin typeface="Avenir Next"/>
               </a:defRPr>
             </a:pPr>
             <a:r>
@@ -7182,15 +8271,18 @@
             </a:r>
           </a:p>
           <a:p>
-            <a:pPr>
-              <a:spcAft>
+            <a:pPr algn="l">
+              <a:spcBef>
                 <a:spcPts val="800"/>
-              </a:spcAft>
-              <a:defRPr sz="1600">
+              </a:spcBef>
+              <a:spcAft>
+                <a:spcPts val="400"/>
+              </a:spcAft>
+              <a:defRPr sz="1800" b="0" i="0">
                 <a:solidFill>
                   <a:srgbClr val="2C3E50"/>
                 </a:solidFill>
-                <a:latin typeface="Calibri"/>
+                <a:latin typeface="Avenir Next"/>
               </a:defRPr>
             </a:pPr>
             <a:r>
@@ -7198,15 +8290,18 @@
             </a:r>
           </a:p>
           <a:p>
-            <a:pPr>
-              <a:spcAft>
+            <a:pPr algn="l">
+              <a:spcBef>
                 <a:spcPts val="800"/>
-              </a:spcAft>
-              <a:defRPr sz="1600">
+              </a:spcBef>
+              <a:spcAft>
+                <a:spcPts val="400"/>
+              </a:spcAft>
+              <a:defRPr sz="1800" b="0" i="0">
                 <a:solidFill>
                   <a:srgbClr val="2C3E50"/>
                 </a:solidFill>
-                <a:latin typeface="Calibri"/>
+                <a:latin typeface="Avenir Next"/>
               </a:defRPr>
             </a:pPr>
             <a:r>
@@ -7214,15 +8309,18 @@
             </a:r>
           </a:p>
           <a:p>
-            <a:pPr>
-              <a:spcAft>
+            <a:pPr algn="l">
+              <a:spcBef>
                 <a:spcPts val="800"/>
-              </a:spcAft>
-              <a:defRPr sz="1600">
+              </a:spcBef>
+              <a:spcAft>
+                <a:spcPts val="400"/>
+              </a:spcAft>
+              <a:defRPr sz="1800" b="0" i="0">
                 <a:solidFill>
                   <a:srgbClr val="2C3E50"/>
                 </a:solidFill>
-                <a:latin typeface="Calibri"/>
+                <a:latin typeface="Avenir Next"/>
               </a:defRPr>
             </a:pPr>
             <a:r>
@@ -7259,14 +8357,57 @@
       <p:grpSpPr/>
       <p:sp>
         <p:nvSpPr>
-          <p:cNvPr id="2" name="TextBox 1"/>
+          <p:cNvPr id="2" name="Rectangle 1"/>
+          <p:cNvSpPr/>
+          <p:nvPr/>
+        </p:nvSpPr>
+        <p:spPr>
+          <a:xfrm>
+            <a:off x="0" y="0"/>
+            <a:ext cx="320040" cy="6858000"/>
+          </a:xfrm>
+          <a:prstGeom prst="rect">
+            <a:avLst/>
+          </a:prstGeom>
+          <a:solidFill>
+            <a:srgbClr val="1E2761"/>
+          </a:solidFill>
+          <a:ln>
+            <a:noFill/>
+          </a:ln>
+        </p:spPr>
+        <p:style>
+          <a:lnRef idx="1">
+            <a:schemeClr val="accent1"/>
+          </a:lnRef>
+          <a:fillRef idx="3">
+            <a:schemeClr val="accent1"/>
+          </a:fillRef>
+          <a:effectRef idx="2">
+            <a:schemeClr val="accent1"/>
+          </a:effectRef>
+          <a:fontRef idx="minor">
+            <a:schemeClr val="lt1"/>
+          </a:fontRef>
+        </p:style>
+        <p:txBody>
+          <a:bodyPr rtlCol="0" anchor="ctr"/>
+          <a:lstStyle/>
+          <a:p>
+            <a:pPr algn="ctr"/>
+          </a:p>
+        </p:txBody>
+      </p:sp>
+      <p:sp>
+        <p:nvSpPr>
+          <p:cNvPr id="3" name="TextBox 2"/>
           <p:cNvSpPr txBox="1"/>
           <p:nvPr/>
         </p:nvSpPr>
         <p:spPr>
           <a:xfrm>
-            <a:off x="731520" y="457200"/>
-            <a:ext cx="7680960" cy="731520"/>
+            <a:off x="731520" y="320040"/>
+            <a:ext cx="8046720" cy="822960"/>
           </a:xfrm>
           <a:prstGeom prst="rect">
             <a:avLst/>
@@ -7280,11 +8421,17 @@
           <a:lstStyle/>
           <a:p>
             <a:pPr algn="l">
-              <a:defRPr sz="2800" b="1">
+              <a:spcBef>
+                <a:spcPts val="0"/>
+              </a:spcBef>
+              <a:spcAft>
+                <a:spcPts val="0"/>
+              </a:spcAft>
+              <a:defRPr sz="3200" b="1" i="0">
                 <a:solidFill>
                   <a:srgbClr val="1E2761"/>
                 </a:solidFill>
-                <a:latin typeface="Georgia"/>
+                <a:latin typeface="Palatino"/>
               </a:defRPr>
             </a:pPr>
             <a:r>
@@ -7295,17 +8442,19 @@
       </p:sp>
       <p:sp>
         <p:nvSpPr>
-          <p:cNvPr id="3" name="Rectangle 2"/>
+          <p:cNvPr id="4" name="Rounded Rectangle 3"/>
           <p:cNvSpPr/>
           <p:nvPr/>
         </p:nvSpPr>
         <p:spPr>
           <a:xfrm>
-            <a:off x="731520" y="1143000"/>
-            <a:ext cx="1371600" cy="25400"/>
+            <a:off x="731520" y="1188720"/>
+            <a:ext cx="1828800" cy="50800"/>
           </a:xfrm>
-          <a:prstGeom prst="rect">
-            <a:avLst/>
+          <a:prstGeom prst="roundRect">
+            <a:avLst>
+              <a:gd name="adj" fmla="val 10000"/>
+            </a:avLst>
           </a:prstGeom>
           <a:solidFill>
             <a:srgbClr val="7B2D26"/>
@@ -7338,14 +8487,14 @@
       </p:sp>
       <p:sp>
         <p:nvSpPr>
-          <p:cNvPr id="4" name="TextBox 3"/>
+          <p:cNvPr id="5" name="TextBox 4"/>
           <p:cNvSpPr txBox="1"/>
           <p:nvPr/>
         </p:nvSpPr>
         <p:spPr>
           <a:xfrm>
-            <a:off x="731520" y="1463040"/>
-            <a:ext cx="7680960" cy="4572000"/>
+            <a:off x="731520" y="1554480"/>
+            <a:ext cx="7863840" cy="4754880"/>
           </a:xfrm>
           <a:prstGeom prst="rect">
             <a:avLst/>
@@ -7358,15 +8507,18 @@
           </a:bodyPr>
           <a:lstStyle/>
           <a:p>
-            <a:pPr>
-              <a:spcAft>
+            <a:pPr algn="l">
+              <a:spcBef>
                 <a:spcPts val="800"/>
-              </a:spcAft>
-              <a:defRPr sz="1800">
+              </a:spcBef>
+              <a:spcAft>
+                <a:spcPts val="400"/>
+              </a:spcAft>
+              <a:defRPr sz="2000" b="0" i="0">
                 <a:solidFill>
                   <a:srgbClr val="2C3E50"/>
                 </a:solidFill>
-                <a:latin typeface="Calibri"/>
+                <a:latin typeface="Avenir Next"/>
               </a:defRPr>
             </a:pPr>
             <a:r>
@@ -7374,15 +8526,18 @@
             </a:r>
           </a:p>
           <a:p>
-            <a:pPr>
-              <a:spcAft>
+            <a:pPr algn="l">
+              <a:spcBef>
                 <a:spcPts val="800"/>
-              </a:spcAft>
-              <a:defRPr sz="1800">
+              </a:spcBef>
+              <a:spcAft>
+                <a:spcPts val="400"/>
+              </a:spcAft>
+              <a:defRPr sz="2000" b="0" i="0">
                 <a:solidFill>
                   <a:srgbClr val="2C3E50"/>
                 </a:solidFill>
-                <a:latin typeface="Calibri"/>
+                <a:latin typeface="Avenir Next"/>
               </a:defRPr>
             </a:pPr>
             <a:r>
@@ -7390,15 +8545,18 @@
             </a:r>
           </a:p>
           <a:p>
-            <a:pPr>
-              <a:spcAft>
+            <a:pPr algn="l">
+              <a:spcBef>
                 <a:spcPts val="800"/>
-              </a:spcAft>
-              <a:defRPr sz="1800">
+              </a:spcBef>
+              <a:spcAft>
+                <a:spcPts val="400"/>
+              </a:spcAft>
+              <a:defRPr sz="2000" b="0" i="0">
                 <a:solidFill>
                   <a:srgbClr val="2C3E50"/>
                 </a:solidFill>
-                <a:latin typeface="Calibri"/>
+                <a:latin typeface="Avenir Next"/>
               </a:defRPr>
             </a:pPr>
             <a:r>
@@ -7406,15 +8564,18 @@
             </a:r>
           </a:p>
           <a:p>
-            <a:pPr>
-              <a:spcAft>
+            <a:pPr algn="l">
+              <a:spcBef>
                 <a:spcPts val="800"/>
-              </a:spcAft>
-              <a:defRPr sz="1800">
+              </a:spcBef>
+              <a:spcAft>
+                <a:spcPts val="400"/>
+              </a:spcAft>
+              <a:defRPr sz="2000" b="0" i="0">
                 <a:solidFill>
                   <a:srgbClr val="2C3E50"/>
                 </a:solidFill>
-                <a:latin typeface="Calibri"/>
+                <a:latin typeface="Avenir Next"/>
               </a:defRPr>
             </a:pPr>
             <a:r>
@@ -7422,79 +8583,94 @@
             </a:r>
           </a:p>
           <a:p>
-            <a:pPr>
-              <a:spcAft>
+            <a:pPr algn="l">
+              <a:spcBef>
+                <a:spcPts val="1600"/>
+              </a:spcBef>
+              <a:spcAft>
+                <a:spcPts val="400"/>
+              </a:spcAft>
+              <a:defRPr sz="2000" b="1" i="0">
+                <a:solidFill>
+                  <a:srgbClr val="2C3E50"/>
+                </a:solidFill>
+                <a:latin typeface="Avenir Next"/>
+              </a:defRPr>
+            </a:pPr>
+            <a:r>
+              <a:t>Three lives of one word:</a:t>
+            </a:r>
+          </a:p>
+          <a:p>
+            <a:pPr algn="l">
+              <a:spcBef>
+                <a:spcPts val="200"/>
+              </a:spcBef>
+              <a:spcAft>
+                <a:spcPts val="600"/>
+              </a:spcAft>
+              <a:defRPr sz="1800" b="0" i="1">
+                <a:solidFill>
+                  <a:srgbClr val="2C3E50"/>
+                </a:solidFill>
+                <a:latin typeface="Avenir Next"/>
+              </a:defRPr>
+            </a:pPr>
+            <a:r>
+              <a:t>     Ritual: consecration, sacrament</a:t>
+            </a:r>
+          </a:p>
+          <a:p>
+            <a:pPr algn="l">
+              <a:spcBef>
+                <a:spcPts val="200"/>
+              </a:spcBef>
+              <a:spcAft>
+                <a:spcPts val="600"/>
+              </a:spcAft>
+              <a:defRPr sz="1800" b="0" i="1">
+                <a:solidFill>
+                  <a:srgbClr val="2C3E50"/>
+                </a:solidFill>
+                <a:latin typeface="Avenir Next"/>
+              </a:defRPr>
+            </a:pPr>
+            <a:r>
+              <a:t>     Grammar: refinement — saṃskṛta = "Sanskrit" = the "well-made" language</a:t>
+            </a:r>
+          </a:p>
+          <a:p>
+            <a:pPr algn="l">
+              <a:spcBef>
+                <a:spcPts val="200"/>
+              </a:spcBef>
+              <a:spcAft>
+                <a:spcPts val="600"/>
+              </a:spcAft>
+              <a:defRPr sz="1800" b="0" i="1">
+                <a:solidFill>
+                  <a:srgbClr val="2C3E50"/>
+                </a:solidFill>
+                <a:latin typeface="Avenir Next"/>
+              </a:defRPr>
+            </a:pPr>
+            <a:r>
+              <a:t>     Yoga Sutras: the unconscious residue of experience</a:t>
+            </a:r>
+          </a:p>
+          <a:p>
+            <a:pPr algn="l">
+              <a:spcBef>
                 <a:spcPts val="800"/>
-              </a:spcAft>
-              <a:defRPr sz="1800">
+              </a:spcBef>
+              <a:spcAft>
+                <a:spcPts val="400"/>
+              </a:spcAft>
+              <a:defRPr sz="2000" b="0" i="0">
                 <a:solidFill>
                   <a:srgbClr val="2C3E50"/>
                 </a:solidFill>
-                <a:latin typeface="Calibri"/>
-              </a:defRPr>
-            </a:pPr>
-            <a:r>
-              <a:t>Three lives of one word:</a:t>
-            </a:r>
-          </a:p>
-          <a:p>
-            <a:pPr>
-              <a:spcAft>
-                <a:spcPts val="800"/>
-              </a:spcAft>
-              <a:defRPr sz="1800">
-                <a:solidFill>
-                  <a:srgbClr val="2C3E50"/>
-                </a:solidFill>
-                <a:latin typeface="Calibri"/>
-              </a:defRPr>
-            </a:pPr>
-            <a:r>
-              <a:t>Ritual: consecration, sacrament</a:t>
-            </a:r>
-          </a:p>
-          <a:p>
-            <a:pPr>
-              <a:spcAft>
-                <a:spcPts val="800"/>
-              </a:spcAft>
-              <a:defRPr sz="1800">
-                <a:solidFill>
-                  <a:srgbClr val="2C3E50"/>
-                </a:solidFill>
-                <a:latin typeface="Calibri"/>
-              </a:defRPr>
-            </a:pPr>
-            <a:r>
-              <a:t>Grammar: refinement — saṃskṛta = "Sanskrit" = the "well-made" language</a:t>
-            </a:r>
-          </a:p>
-          <a:p>
-            <a:pPr>
-              <a:spcAft>
-                <a:spcPts val="800"/>
-              </a:spcAft>
-              <a:defRPr sz="1800">
-                <a:solidFill>
-                  <a:srgbClr val="2C3E50"/>
-                </a:solidFill>
-                <a:latin typeface="Calibri"/>
-              </a:defRPr>
-            </a:pPr>
-            <a:r>
-              <a:t>Yoga Sutras: the unconscious residue of experience</a:t>
-            </a:r>
-          </a:p>
-          <a:p>
-            <a:pPr>
-              <a:spcAft>
-                <a:spcPts val="800"/>
-              </a:spcAft>
-              <a:defRPr sz="1800">
-                <a:solidFill>
-                  <a:srgbClr val="2C3E50"/>
-                </a:solidFill>
-                <a:latin typeface="Calibri"/>
+                <a:latin typeface="Avenir Next"/>
               </a:defRPr>
             </a:pPr>
             <a:r>
@@ -7531,14 +8707,59 @@
       <p:grpSpPr/>
       <p:sp>
         <p:nvSpPr>
-          <p:cNvPr id="2" name="TextBox 1"/>
+          <p:cNvPr id="2" name="Rounded Rectangle 1"/>
+          <p:cNvSpPr/>
+          <p:nvPr/>
+        </p:nvSpPr>
+        <p:spPr>
+          <a:xfrm>
+            <a:off x="731520" y="2560320"/>
+            <a:ext cx="2286000" cy="63500"/>
+          </a:xfrm>
+          <a:prstGeom prst="roundRect">
+            <a:avLst>
+              <a:gd name="adj" fmla="val 10000"/>
+            </a:avLst>
+          </a:prstGeom>
+          <a:solidFill>
+            <a:srgbClr val="7B2D26"/>
+          </a:solidFill>
+          <a:ln>
+            <a:noFill/>
+          </a:ln>
+        </p:spPr>
+        <p:style>
+          <a:lnRef idx="1">
+            <a:schemeClr val="accent1"/>
+          </a:lnRef>
+          <a:fillRef idx="3">
+            <a:schemeClr val="accent1"/>
+          </a:fillRef>
+          <a:effectRef idx="2">
+            <a:schemeClr val="accent1"/>
+          </a:effectRef>
+          <a:fontRef idx="minor">
+            <a:schemeClr val="lt1"/>
+          </a:fontRef>
+        </p:style>
+        <p:txBody>
+          <a:bodyPr rtlCol="0" anchor="ctr"/>
+          <a:lstStyle/>
+          <a:p>
+            <a:pPr algn="ctr"/>
+          </a:p>
+        </p:txBody>
+      </p:sp>
+      <p:sp>
+        <p:nvSpPr>
+          <p:cNvPr id="3" name="TextBox 2"/>
           <p:cNvSpPr txBox="1"/>
           <p:nvPr/>
         </p:nvSpPr>
         <p:spPr>
           <a:xfrm>
-            <a:off x="731520" y="2286000"/>
-            <a:ext cx="7680960" cy="1828800"/>
+            <a:off x="731520" y="2834640"/>
+            <a:ext cx="7680960" cy="1645920"/>
           </a:xfrm>
           <a:prstGeom prst="rect">
             <a:avLst/>
@@ -7552,11 +8773,17 @@
           <a:lstStyle/>
           <a:p>
             <a:pPr algn="l">
-              <a:defRPr sz="3200" b="1">
+              <a:spcBef>
+                <a:spcPts val="0"/>
+              </a:spcBef>
+              <a:spcAft>
+                <a:spcPts val="0"/>
+              </a:spcAft>
+              <a:defRPr sz="3800" b="1" i="0">
                 <a:solidFill>
                   <a:srgbClr val="FFFFFF"/>
                 </a:solidFill>
-                <a:latin typeface="Georgia"/>
+                <a:latin typeface="Palatino"/>
               </a:defRPr>
             </a:pPr>
             <a:r>

</xml_diff>

<commit_message>
Add live demo section to all presentation materials
New slide 13 (demo) in the deck, plus demo section in outline, script,
and paper draft. Deck is now 14 slides. Script includes stage directions
for switching to browser and walking through samadhi + karma lookups.

Co-Authored-By: Claude Opus 4.6 (1M context) <noreply@anthropic.com>
</commit_message>
<xml_diff>
--- a/docs/final_presentation.pptx
+++ b/docs/final_presentation.pptx
@@ -18,6 +18,7 @@
     <p:sldId id="266" r:id="rId18"/>
     <p:sldId id="267" r:id="rId19"/>
     <p:sldId id="268" r:id="rId20"/>
+    <p:sldId id="269" r:id="rId21"/>
   </p:sldIdLst>
   <p:sldSz cx="12191695" cy="6858000" type="screen4x3"/>
   <p:notesSz cx="6858000" cy="9144000"/>
@@ -798,6 +799,88 @@
 </file>
 
 <file path=ppt/notesSlides/notesSlide13.xml><?xml version="1.0" encoding="utf-8"?>
+<p:notes xmlns:a="http://schemas.openxmlformats.org/drawingml/2006/main" xmlns:p="http://schemas.openxmlformats.org/presentationml/2006/main" xmlns:r="http://schemas.openxmlformats.org/officeDocument/2006/relationships">
+  <p:cSld>
+    <p:spTree>
+      <p:nvGrpSpPr>
+        <p:cNvPr id="1" name=""/>
+        <p:cNvGrpSpPr/>
+        <p:nvPr/>
+      </p:nvGrpSpPr>
+      <p:grpSpPr>
+        <a:xfrm>
+          <a:off x="0" y="0"/>
+          <a:ext cx="0" cy="0"/>
+          <a:chOff x="0" y="0"/>
+          <a:chExt cx="0" cy="0"/>
+        </a:xfrm>
+      </p:grpSpPr>
+      <p:sp>
+        <p:nvSpPr>
+          <p:cNvPr id="2" name="Slide Image Placeholder 1"/>
+          <p:cNvSpPr>
+            <a:spLocks noGrp="1"/>
+          </p:cNvSpPr>
+          <p:nvPr>
+            <p:ph type="sldImg" idx="2"/>
+          </p:nvPr>
+        </p:nvSpPr>
+        <p:spPr/>
+      </p:sp>
+      <p:sp>
+        <p:nvSpPr>
+          <p:cNvPr id="3" name="Notes Placeholder 2"/>
+          <p:cNvSpPr>
+            <a:spLocks noGrp="1"/>
+          </p:cNvSpPr>
+          <p:nvPr>
+            <p:ph type="body" idx="3" sz="quarter"/>
+          </p:nvPr>
+        </p:nvSpPr>
+        <p:spPr/>
+        <p:txBody>
+          <a:bodyPr/>
+          <a:lstStyle/>
+          <a:p>
+            <a:pPr>
+              <a:defRPr sz="1100">
+                <a:latin typeface="Avenir Next"/>
+              </a:defRPr>
+            </a:pPr>
+            <a:r>
+              <a:t>Let me show you something quickly. I built an interactive tool that lets you explore all of these terms yourself. It has 84 terms — every term from your Yoga Sutras vocabulary lists, all four chapters. Let me switch to the browser and show you. [Switch to browser, open demo/index.html] Type "samadhi" — show the full breakdown card. Point out the segmentation strip (color-coded prefixes, root, suffixes), the morphology grid, the philosophical meaning, the Chinese equivalents. Click "karma" from the browse grid to show it works for any term. Point out that karma and samskara share the root kr ("to do/make"). "This is available for you to explore after class — it's just an HTML file, works offline, no installation needed." [Switch back to slides]</a:t>
+            </a:r>
+          </a:p>
+          <a:p>
+            <a:pPr>
+              <a:defRPr sz="1100">
+                <a:latin typeface="Avenir Next"/>
+              </a:defRPr>
+            </a:pPr>
+          </a:p>
+        </p:txBody>
+      </p:sp>
+      <p:sp>
+        <p:nvSpPr>
+          <p:cNvPr id="4" name="Slide Number Placeholder 3"/>
+          <p:cNvSpPr>
+            <a:spLocks noGrp="1"/>
+          </p:cNvSpPr>
+          <p:nvPr>
+            <p:ph type="sldNum" idx="5" sz="quarter"/>
+          </p:nvPr>
+        </p:nvSpPr>
+        <p:spPr/>
+      </p:sp>
+    </p:spTree>
+  </p:cSld>
+  <p:clrMapOvr>
+    <a:masterClrMapping/>
+  </p:clrMapOvr>
+</p:notes>
+</file>
+
+<file path=ppt/notesSlides/notesSlide14.xml><?xml version="1.0" encoding="utf-8"?>
 <p:notes xmlns:a="http://schemas.openxmlformats.org/drawingml/2006/main" xmlns:p="http://schemas.openxmlformats.org/presentationml/2006/main" xmlns:r="http://schemas.openxmlformats.org/officeDocument/2006/relationships">
   <p:cSld>
     <p:spTree>
@@ -5993,6 +6076,337 @@
 </file>
 
 <file path=ppt/slides/slide13.xml><?xml version="1.0" encoding="utf-8"?>
+<p:sld xmlns:a="http://schemas.openxmlformats.org/drawingml/2006/main" xmlns:p="http://schemas.openxmlformats.org/presentationml/2006/main" xmlns:r="http://schemas.openxmlformats.org/officeDocument/2006/relationships">
+  <p:cSld>
+    <p:bg>
+      <p:bgPr>
+        <a:solidFill>
+          <a:srgbClr val="F7F6F2"/>
+        </a:solidFill>
+        <a:effectLst/>
+      </p:bgPr>
+    </p:bg>
+    <p:spTree>
+      <p:nvGrpSpPr>
+        <p:cNvPr id="1" name=""/>
+        <p:cNvGrpSpPr/>
+        <p:nvPr/>
+      </p:nvGrpSpPr>
+      <p:grpSpPr/>
+      <p:sp>
+        <p:nvSpPr>
+          <p:cNvPr id="2" name="Rectangle 1"/>
+          <p:cNvSpPr/>
+          <p:nvPr/>
+        </p:nvSpPr>
+        <p:spPr>
+          <a:xfrm>
+            <a:off x="0" y="0"/>
+            <a:ext cx="320040" cy="6858000"/>
+          </a:xfrm>
+          <a:prstGeom prst="rect">
+            <a:avLst/>
+          </a:prstGeom>
+          <a:solidFill>
+            <a:srgbClr val="1E2761"/>
+          </a:solidFill>
+          <a:ln>
+            <a:noFill/>
+          </a:ln>
+        </p:spPr>
+        <p:style>
+          <a:lnRef idx="1">
+            <a:schemeClr val="accent1"/>
+          </a:lnRef>
+          <a:fillRef idx="3">
+            <a:schemeClr val="accent1"/>
+          </a:fillRef>
+          <a:effectRef idx="2">
+            <a:schemeClr val="accent1"/>
+          </a:effectRef>
+          <a:fontRef idx="minor">
+            <a:schemeClr val="lt1"/>
+          </a:fontRef>
+        </p:style>
+        <p:txBody>
+          <a:bodyPr rtlCol="0" anchor="ctr"/>
+          <a:lstStyle/>
+          <a:p>
+            <a:pPr algn="ctr"/>
+          </a:p>
+        </p:txBody>
+      </p:sp>
+      <p:sp>
+        <p:nvSpPr>
+          <p:cNvPr id="3" name="TextBox 2"/>
+          <p:cNvSpPr txBox="1"/>
+          <p:nvPr/>
+        </p:nvSpPr>
+        <p:spPr>
+          <a:xfrm>
+            <a:off x="731520" y="320040"/>
+            <a:ext cx="8046720" cy="822960"/>
+          </a:xfrm>
+          <a:prstGeom prst="rect">
+            <a:avLst/>
+          </a:prstGeom>
+          <a:noFill/>
+        </p:spPr>
+        <p:txBody>
+          <a:bodyPr wrap="square">
+            <a:spAutoFit/>
+          </a:bodyPr>
+          <a:lstStyle/>
+          <a:p>
+            <a:pPr algn="l">
+              <a:spcBef>
+                <a:spcPts val="0"/>
+              </a:spcBef>
+              <a:spcAft>
+                <a:spcPts val="0"/>
+              </a:spcAft>
+              <a:defRPr sz="3200" b="1" i="0">
+                <a:solidFill>
+                  <a:srgbClr val="1E2761"/>
+                </a:solidFill>
+                <a:latin typeface="Palatino"/>
+              </a:defRPr>
+            </a:pPr>
+            <a:r>
+              <a:t>Live Demo — Sanskrit Word Explorer</a:t>
+            </a:r>
+          </a:p>
+        </p:txBody>
+      </p:sp>
+      <p:sp>
+        <p:nvSpPr>
+          <p:cNvPr id="4" name="Rounded Rectangle 3"/>
+          <p:cNvSpPr/>
+          <p:nvPr/>
+        </p:nvSpPr>
+        <p:spPr>
+          <a:xfrm>
+            <a:off x="731520" y="1188720"/>
+            <a:ext cx="1828800" cy="50800"/>
+          </a:xfrm>
+          <a:prstGeom prst="roundRect">
+            <a:avLst>
+              <a:gd name="adj" fmla="val 10000"/>
+            </a:avLst>
+          </a:prstGeom>
+          <a:solidFill>
+            <a:srgbClr val="7B2D26"/>
+          </a:solidFill>
+          <a:ln>
+            <a:noFill/>
+          </a:ln>
+        </p:spPr>
+        <p:style>
+          <a:lnRef idx="1">
+            <a:schemeClr val="accent1"/>
+          </a:lnRef>
+          <a:fillRef idx="3">
+            <a:schemeClr val="accent1"/>
+          </a:fillRef>
+          <a:effectRef idx="2">
+            <a:schemeClr val="accent1"/>
+          </a:effectRef>
+          <a:fontRef idx="minor">
+            <a:schemeClr val="lt1"/>
+          </a:fontRef>
+        </p:style>
+        <p:txBody>
+          <a:bodyPr rtlCol="0" anchor="ctr"/>
+          <a:lstStyle/>
+          <a:p>
+            <a:pPr algn="ctr"/>
+          </a:p>
+        </p:txBody>
+      </p:sp>
+      <p:sp>
+        <p:nvSpPr>
+          <p:cNvPr id="5" name="TextBox 4"/>
+          <p:cNvSpPr txBox="1"/>
+          <p:nvPr/>
+        </p:nvSpPr>
+        <p:spPr>
+          <a:xfrm>
+            <a:off x="731520" y="1554480"/>
+            <a:ext cx="7863840" cy="4754880"/>
+          </a:xfrm>
+          <a:prstGeom prst="rect">
+            <a:avLst/>
+          </a:prstGeom>
+          <a:noFill/>
+        </p:spPr>
+        <p:txBody>
+          <a:bodyPr wrap="square">
+            <a:spAutoFit/>
+          </a:bodyPr>
+          <a:lstStyle/>
+          <a:p>
+            <a:pPr algn="l">
+              <a:spcBef>
+                <a:spcPts val="1600"/>
+              </a:spcBef>
+              <a:spcAft>
+                <a:spcPts val="400"/>
+              </a:spcAft>
+              <a:defRPr sz="2000" b="1" i="0">
+                <a:solidFill>
+                  <a:srgbClr val="2C3E50"/>
+                </a:solidFill>
+                <a:latin typeface="Avenir Next"/>
+              </a:defRPr>
+            </a:pPr>
+            <a:r>
+              <a:t>84 terms from all 4 chapters of the Yoga Sutras</a:t>
+            </a:r>
+          </a:p>
+          <a:p>
+            <a:pPr algn="l">
+              <a:spcBef>
+                <a:spcPts val="200"/>
+              </a:spcBef>
+              <a:spcAft>
+                <a:spcPts val="600"/>
+              </a:spcAft>
+              <a:defRPr sz="1800" b="0" i="1">
+                <a:solidFill>
+                  <a:srgbClr val="2C3E50"/>
+                </a:solidFill>
+                <a:latin typeface="Avenir Next"/>
+              </a:defRPr>
+            </a:pPr>
+            <a:r>
+              <a:t>     Search by English, IAST, or Devanagari</a:t>
+            </a:r>
+          </a:p>
+          <a:p>
+            <a:pPr algn="l">
+              <a:spcBef>
+                <a:spcPts val="200"/>
+              </a:spcBef>
+              <a:spcAft>
+                <a:spcPts val="600"/>
+              </a:spcAft>
+              <a:defRPr sz="1800" b="0" i="1">
+                <a:solidFill>
+                  <a:srgbClr val="2C3E50"/>
+                </a:solidFill>
+                <a:latin typeface="Avenir Next"/>
+              </a:defRPr>
+            </a:pPr>
+            <a:r>
+              <a:t>     Color-coded morphological segmentation</a:t>
+            </a:r>
+          </a:p>
+          <a:p>
+            <a:pPr algn="l">
+              <a:spcBef>
+                <a:spcPts val="200"/>
+              </a:spcBef>
+              <a:spcAft>
+                <a:spcPts val="600"/>
+              </a:spcAft>
+              <a:defRPr sz="1800" b="0" i="1">
+                <a:solidFill>
+                  <a:srgbClr val="2C3E50"/>
+                </a:solidFill>
+                <a:latin typeface="Avenir Next"/>
+              </a:defRPr>
+            </a:pPr>
+            <a:r>
+              <a:t>     Root, prefix, and suffix breakdown cards</a:t>
+            </a:r>
+          </a:p>
+          <a:p>
+            <a:pPr algn="l">
+              <a:spcBef>
+                <a:spcPts val="200"/>
+              </a:spcBef>
+              <a:spcAft>
+                <a:spcPts val="600"/>
+              </a:spcAft>
+              <a:defRPr sz="1800" b="0" i="1">
+                <a:solidFill>
+                  <a:srgbClr val="2C3E50"/>
+                </a:solidFill>
+                <a:latin typeface="Avenir Next"/>
+              </a:defRPr>
+            </a:pPr>
+            <a:r>
+              <a:t>     Philosophical meaning and Yoga Sutras references</a:t>
+            </a:r>
+          </a:p>
+          <a:p>
+            <a:pPr algn="l">
+              <a:spcBef>
+                <a:spcPts val="200"/>
+              </a:spcBef>
+              <a:spcAft>
+                <a:spcPts val="600"/>
+              </a:spcAft>
+              <a:defRPr sz="1800" b="0" i="1">
+                <a:solidFill>
+                  <a:srgbClr val="2C3E50"/>
+                </a:solidFill>
+                <a:latin typeface="Avenir Next"/>
+              </a:defRPr>
+            </a:pPr>
+            <a:r>
+              <a:t>     Chinese Buddhist equivalents where attested</a:t>
+            </a:r>
+          </a:p>
+          <a:p>
+            <a:pPr algn="l">
+              <a:spcBef>
+                <a:spcPts val="1600"/>
+              </a:spcBef>
+              <a:spcAft>
+                <a:spcPts val="400"/>
+              </a:spcAft>
+              <a:defRPr sz="2000" b="1" i="0">
+                <a:solidFill>
+                  <a:srgbClr val="2C3E50"/>
+                </a:solidFill>
+                <a:latin typeface="Avenir Next"/>
+              </a:defRPr>
+            </a:pPr>
+            <a:r>
+              <a:t>Works offline — no installation needed</a:t>
+            </a:r>
+          </a:p>
+          <a:p>
+            <a:pPr algn="l">
+              <a:spcBef>
+                <a:spcPts val="200"/>
+              </a:spcBef>
+              <a:spcAft>
+                <a:spcPts val="600"/>
+              </a:spcAft>
+              <a:defRPr sz="1800" b="0" i="1">
+                <a:solidFill>
+                  <a:srgbClr val="2C3E50"/>
+                </a:solidFill>
+                <a:latin typeface="Avenir Next"/>
+              </a:defRPr>
+            </a:pPr>
+            <a:r>
+              <a:t>     Available for you to explore after class</a:t>
+            </a:r>
+          </a:p>
+        </p:txBody>
+      </p:sp>
+    </p:spTree>
+  </p:cSld>
+  <p:clrMapOvr>
+    <a:masterClrMapping/>
+  </p:clrMapOvr>
+</p:sld>
+</file>
+
+<file path=ppt/slides/slide14.xml><?xml version="1.0" encoding="utf-8"?>
 <p:sld xmlns:a="http://schemas.openxmlformats.org/drawingml/2006/main" xmlns:p="http://schemas.openxmlformats.org/presentationml/2006/main" xmlns:r="http://schemas.openxmlformats.org/officeDocument/2006/relationships">
   <p:cSld>
     <p:bg>

</xml_diff>